<commit_message>
Started making arculat design guide and added an icon pack
</commit_message>
<xml_diff>
--- a/documentation/mytunes presentation.pptx
+++ b/documentation/mytunes presentation.pptx
@@ -11,6 +11,11 @@
     <p:sldId id="549" r:id="rId5"/>
     <p:sldId id="259" r:id="rId6"/>
     <p:sldId id="550" r:id="rId7"/>
+    <p:sldId id="551" r:id="rId8"/>
+    <p:sldId id="552" r:id="rId9"/>
+    <p:sldId id="553" r:id="rId10"/>
+    <p:sldId id="554" r:id="rId11"/>
+    <p:sldId id="555" r:id="rId12"/>
   </p:sldIdLst>
   <p:sldSz cx="12192000" cy="6858000"/>
   <p:notesSz cx="6858000" cy="9144000"/>
@@ -4179,6 +4184,1614 @@
 </p:sld>
 </file>
 
+<file path=ppt/slides/slide10.xml><?xml version="1.0" encoding="utf-8"?>
+<p:sld xmlns:a="http://schemas.openxmlformats.org/drawingml/2006/main" xmlns:r="http://schemas.openxmlformats.org/officeDocument/2006/relationships" xmlns:p="http://schemas.openxmlformats.org/presentationml/2006/main">
+  <p:cSld>
+    <p:spTree>
+      <p:nvGrpSpPr>
+        <p:cNvPr id="1" name=""/>
+        <p:cNvGrpSpPr/>
+        <p:nvPr/>
+      </p:nvGrpSpPr>
+      <p:grpSpPr>
+        <a:xfrm>
+          <a:off x="0" y="0"/>
+          <a:ext cx="0" cy="0"/>
+          <a:chOff x="0" y="0"/>
+          <a:chExt cx="0" cy="0"/>
+        </a:xfrm>
+      </p:grpSpPr>
+      <p:sp>
+        <p:nvSpPr>
+          <p:cNvPr id="2" name="Cím 1">
+            <a:extLst>
+              <a:ext uri="{FF2B5EF4-FFF2-40B4-BE49-F238E27FC236}">
+                <a16:creationId xmlns:a16="http://schemas.microsoft.com/office/drawing/2014/main" id="{28054C95-C947-C0E8-879A-DF2E896ADE72}"/>
+              </a:ext>
+            </a:extLst>
+          </p:cNvPr>
+          <p:cNvSpPr>
+            <a:spLocks noGrp="1"/>
+          </p:cNvSpPr>
+          <p:nvPr>
+            <p:ph type="title"/>
+          </p:nvPr>
+        </p:nvSpPr>
+        <p:spPr/>
+        <p:txBody>
+          <a:bodyPr/>
+          <a:lstStyle/>
+          <a:p>
+            <a:r>
+              <a:rPr lang="hu-HU" dirty="0">
+                <a:latin typeface="Montserrat" panose="00000500000000000000" pitchFamily="2" charset="-18"/>
+              </a:rPr>
+              <a:t>Tipográfia</a:t>
+            </a:r>
+          </a:p>
+        </p:txBody>
+      </p:sp>
+      <p:sp>
+        <p:nvSpPr>
+          <p:cNvPr id="3" name="Tartalom helye 2">
+            <a:extLst>
+              <a:ext uri="{FF2B5EF4-FFF2-40B4-BE49-F238E27FC236}">
+                <a16:creationId xmlns:a16="http://schemas.microsoft.com/office/drawing/2014/main" id="{8FF9A8F0-254D-5FB9-7007-B3330FFA8DE1}"/>
+              </a:ext>
+            </a:extLst>
+          </p:cNvPr>
+          <p:cNvSpPr>
+            <a:spLocks noGrp="1"/>
+          </p:cNvSpPr>
+          <p:nvPr>
+            <p:ph idx="1"/>
+          </p:nvPr>
+        </p:nvSpPr>
+        <p:spPr>
+          <a:xfrm>
+            <a:off x="788187" y="2672109"/>
+            <a:ext cx="3674343" cy="3566160"/>
+          </a:xfrm>
+        </p:spPr>
+        <p:txBody>
+          <a:bodyPr>
+            <a:normAutofit fontScale="92500" lnSpcReduction="10000"/>
+          </a:bodyPr>
+          <a:lstStyle/>
+          <a:p>
+            <a:r>
+              <a:rPr lang="hu-HU" sz="6000" dirty="0">
+                <a:solidFill>
+                  <a:srgbClr val="FF00FF"/>
+                </a:solidFill>
+                <a:latin typeface="Montserrat" panose="00000500000000000000" pitchFamily="2" charset="-18"/>
+              </a:rPr>
+              <a:t>Címsor 1</a:t>
+            </a:r>
+          </a:p>
+          <a:p>
+            <a:r>
+              <a:rPr lang="hu-HU" sz="4800" dirty="0">
+                <a:solidFill>
+                  <a:srgbClr val="BF40FF"/>
+                </a:solidFill>
+                <a:latin typeface="Montserrat" panose="00000500000000000000" pitchFamily="2" charset="-18"/>
+              </a:rPr>
+              <a:t>Címsor 2</a:t>
+            </a:r>
+          </a:p>
+          <a:p>
+            <a:r>
+              <a:rPr lang="hu-HU" sz="3900" dirty="0">
+                <a:solidFill>
+                  <a:srgbClr val="8080FF"/>
+                </a:solidFill>
+                <a:latin typeface="Montserrat" panose="00000500000000000000" pitchFamily="2" charset="-18"/>
+              </a:rPr>
+              <a:t>Címsor 3</a:t>
+            </a:r>
+          </a:p>
+          <a:p>
+            <a:r>
+              <a:rPr lang="hu-HU" sz="2400" dirty="0">
+                <a:solidFill>
+                  <a:srgbClr val="40BFFF"/>
+                </a:solidFill>
+                <a:latin typeface="Montserrat" panose="00000500000000000000" pitchFamily="2" charset="-18"/>
+              </a:rPr>
+              <a:t>Címsor 4</a:t>
+            </a:r>
+          </a:p>
+          <a:p>
+            <a:r>
+              <a:rPr lang="hu-HU" sz="1500" dirty="0">
+                <a:solidFill>
+                  <a:srgbClr val="00FFFF"/>
+                </a:solidFill>
+                <a:latin typeface="Montserrat" panose="00000500000000000000" pitchFamily="2" charset="-18"/>
+              </a:rPr>
+              <a:t>Címsor 5</a:t>
+            </a:r>
+          </a:p>
+        </p:txBody>
+      </p:sp>
+      <p:sp>
+        <p:nvSpPr>
+          <p:cNvPr id="4" name="Tartalom helye 2">
+            <a:extLst>
+              <a:ext uri="{FF2B5EF4-FFF2-40B4-BE49-F238E27FC236}">
+                <a16:creationId xmlns:a16="http://schemas.microsoft.com/office/drawing/2014/main" id="{16E92EC3-39C6-115A-BC84-9C7003BFA03A}"/>
+              </a:ext>
+            </a:extLst>
+          </p:cNvPr>
+          <p:cNvSpPr txBox="1">
+            <a:spLocks/>
+          </p:cNvSpPr>
+          <p:nvPr/>
+        </p:nvSpPr>
+        <p:spPr>
+          <a:xfrm>
+            <a:off x="5003872" y="2672109"/>
+            <a:ext cx="6136353" cy="3566160"/>
+          </a:xfrm>
+          <a:prstGeom prst="rect">
+            <a:avLst/>
+          </a:prstGeom>
+        </p:spPr>
+        <p:txBody>
+          <a:bodyPr vert="horz" lIns="91440" tIns="45720" rIns="91440" bIns="45720" rtlCol="0">
+            <a:normAutofit/>
+          </a:bodyPr>
+          <a:lstStyle>
+            <a:lvl1pPr marL="228600" indent="-228600" algn="l" defTabSz="914400" rtl="0" eaLnBrk="1" latinLnBrk="0" hangingPunct="1">
+              <a:lnSpc>
+                <a:spcPct val="120000"/>
+              </a:lnSpc>
+              <a:spcBef>
+                <a:spcPts val="1000"/>
+              </a:spcBef>
+              <a:buSzPct val="87000"/>
+              <a:buFont typeface="Arial" panose="020B0604020202020204" pitchFamily="34" charset="0"/>
+              <a:buChar char="•"/>
+              <a:defRPr sz="2000" kern="1200">
+                <a:solidFill>
+                  <a:schemeClr val="tx1"/>
+                </a:solidFill>
+                <a:latin typeface="+mn-lt"/>
+                <a:ea typeface="+mn-ea"/>
+                <a:cs typeface="+mn-cs"/>
+              </a:defRPr>
+            </a:lvl1pPr>
+            <a:lvl2pPr marL="493776" indent="-228600" algn="l" defTabSz="914400" rtl="0" eaLnBrk="1" latinLnBrk="0" hangingPunct="1">
+              <a:lnSpc>
+                <a:spcPct val="120000"/>
+              </a:lnSpc>
+              <a:spcBef>
+                <a:spcPts val="500"/>
+              </a:spcBef>
+              <a:buSzPct val="87000"/>
+              <a:buFont typeface="Arial" panose="020B0604020202020204" pitchFamily="34" charset="0"/>
+              <a:buChar char="•"/>
+              <a:defRPr sz="1800" kern="1200">
+                <a:solidFill>
+                  <a:schemeClr val="tx1"/>
+                </a:solidFill>
+                <a:latin typeface="+mn-lt"/>
+                <a:ea typeface="+mn-ea"/>
+                <a:cs typeface="+mn-cs"/>
+              </a:defRPr>
+            </a:lvl2pPr>
+            <a:lvl3pPr marL="731520" indent="-228600" algn="l" defTabSz="914400" rtl="0" eaLnBrk="1" latinLnBrk="0" hangingPunct="1">
+              <a:lnSpc>
+                <a:spcPct val="120000"/>
+              </a:lnSpc>
+              <a:spcBef>
+                <a:spcPts val="500"/>
+              </a:spcBef>
+              <a:buSzPct val="87000"/>
+              <a:buFont typeface="Arial" panose="020B0604020202020204" pitchFamily="34" charset="0"/>
+              <a:buChar char="•"/>
+              <a:defRPr sz="1600" kern="1200">
+                <a:solidFill>
+                  <a:schemeClr val="tx1"/>
+                </a:solidFill>
+                <a:latin typeface="+mn-lt"/>
+                <a:ea typeface="+mn-ea"/>
+                <a:cs typeface="+mn-cs"/>
+              </a:defRPr>
+            </a:lvl3pPr>
+            <a:lvl4pPr marL="1051560" indent="-285750" algn="l" defTabSz="914400" rtl="0" eaLnBrk="1" latinLnBrk="0" hangingPunct="1">
+              <a:lnSpc>
+                <a:spcPct val="120000"/>
+              </a:lnSpc>
+              <a:spcBef>
+                <a:spcPts val="500"/>
+              </a:spcBef>
+              <a:buSzPct val="87000"/>
+              <a:buFont typeface="Arial" panose="020B0604020202020204" pitchFamily="34" charset="0"/>
+              <a:buChar char="•"/>
+              <a:defRPr sz="1400" kern="1200">
+                <a:solidFill>
+                  <a:schemeClr val="tx1"/>
+                </a:solidFill>
+                <a:latin typeface="+mn-lt"/>
+                <a:ea typeface="+mn-ea"/>
+                <a:cs typeface="+mn-cs"/>
+              </a:defRPr>
+            </a:lvl4pPr>
+            <a:lvl5pPr marL="1298448" indent="-228600" algn="l" defTabSz="914400" rtl="0" eaLnBrk="1" latinLnBrk="0" hangingPunct="1">
+              <a:lnSpc>
+                <a:spcPct val="120000"/>
+              </a:lnSpc>
+              <a:spcBef>
+                <a:spcPts val="500"/>
+              </a:spcBef>
+              <a:buSzPct val="87000"/>
+              <a:buFont typeface="Arial" panose="020B0604020202020204" pitchFamily="34" charset="0"/>
+              <a:buChar char="•"/>
+              <a:defRPr sz="1400" kern="1200">
+                <a:solidFill>
+                  <a:schemeClr val="tx1"/>
+                </a:solidFill>
+                <a:latin typeface="+mn-lt"/>
+                <a:ea typeface="+mn-ea"/>
+                <a:cs typeface="+mn-cs"/>
+              </a:defRPr>
+            </a:lvl5pPr>
+            <a:lvl6pPr marL="2514600" indent="-228600" algn="l" defTabSz="914400" rtl="0" eaLnBrk="1" latinLnBrk="0" hangingPunct="1">
+              <a:lnSpc>
+                <a:spcPct val="90000"/>
+              </a:lnSpc>
+              <a:spcBef>
+                <a:spcPts val="500"/>
+              </a:spcBef>
+              <a:buFont typeface="Arial" panose="020B0604020202020204" pitchFamily="34" charset="0"/>
+              <a:buChar char="•"/>
+              <a:defRPr sz="1800" kern="1200">
+                <a:solidFill>
+                  <a:schemeClr val="tx1"/>
+                </a:solidFill>
+                <a:latin typeface="+mn-lt"/>
+                <a:ea typeface="+mn-ea"/>
+                <a:cs typeface="+mn-cs"/>
+              </a:defRPr>
+            </a:lvl6pPr>
+            <a:lvl7pPr marL="2971800" indent="-228600" algn="l" defTabSz="914400" rtl="0" eaLnBrk="1" latinLnBrk="0" hangingPunct="1">
+              <a:lnSpc>
+                <a:spcPct val="90000"/>
+              </a:lnSpc>
+              <a:spcBef>
+                <a:spcPts val="500"/>
+              </a:spcBef>
+              <a:buFont typeface="Arial" panose="020B0604020202020204" pitchFamily="34" charset="0"/>
+              <a:buChar char="•"/>
+              <a:defRPr sz="1800" kern="1200">
+                <a:solidFill>
+                  <a:schemeClr val="tx1"/>
+                </a:solidFill>
+                <a:latin typeface="+mn-lt"/>
+                <a:ea typeface="+mn-ea"/>
+                <a:cs typeface="+mn-cs"/>
+              </a:defRPr>
+            </a:lvl7pPr>
+            <a:lvl8pPr marL="3429000" indent="-228600" algn="l" defTabSz="914400" rtl="0" eaLnBrk="1" latinLnBrk="0" hangingPunct="1">
+              <a:lnSpc>
+                <a:spcPct val="90000"/>
+              </a:lnSpc>
+              <a:spcBef>
+                <a:spcPts val="500"/>
+              </a:spcBef>
+              <a:buFont typeface="Arial" panose="020B0604020202020204" pitchFamily="34" charset="0"/>
+              <a:buChar char="•"/>
+              <a:defRPr sz="1800" kern="1200">
+                <a:solidFill>
+                  <a:schemeClr val="tx1"/>
+                </a:solidFill>
+                <a:latin typeface="+mn-lt"/>
+                <a:ea typeface="+mn-ea"/>
+                <a:cs typeface="+mn-cs"/>
+              </a:defRPr>
+            </a:lvl8pPr>
+            <a:lvl9pPr marL="3886200" indent="-228600" algn="l" defTabSz="914400" rtl="0" eaLnBrk="1" latinLnBrk="0" hangingPunct="1">
+              <a:lnSpc>
+                <a:spcPct val="90000"/>
+              </a:lnSpc>
+              <a:spcBef>
+                <a:spcPts val="500"/>
+              </a:spcBef>
+              <a:buFont typeface="Arial" panose="020B0604020202020204" pitchFamily="34" charset="0"/>
+              <a:buChar char="•"/>
+              <a:defRPr sz="1800" kern="1200">
+                <a:solidFill>
+                  <a:schemeClr val="tx1"/>
+                </a:solidFill>
+                <a:latin typeface="+mn-lt"/>
+                <a:ea typeface="+mn-ea"/>
+                <a:cs typeface="+mn-cs"/>
+              </a:defRPr>
+            </a:lvl9pPr>
+          </a:lstStyle>
+          <a:p>
+            <a:pPr marL="0" indent="0" algn="just">
+              <a:buNone/>
+            </a:pPr>
+            <a:r>
+              <a:rPr lang="hu-HU" sz="1200" dirty="0">
+                <a:latin typeface="Montserrat" panose="00000500000000000000" pitchFamily="2" charset="-18"/>
+              </a:rPr>
+              <a:t>	</a:t>
+            </a:r>
+            <a:r>
+              <a:rPr lang="hu-HU" sz="1200" dirty="0" err="1">
+                <a:latin typeface="Montserrat" panose="00000500000000000000" pitchFamily="2" charset="-18"/>
+              </a:rPr>
+              <a:t>Lorem</a:t>
+            </a:r>
+            <a:r>
+              <a:rPr lang="hu-HU" sz="1200" dirty="0">
+                <a:latin typeface="Montserrat" panose="00000500000000000000" pitchFamily="2" charset="-18"/>
+              </a:rPr>
+              <a:t> </a:t>
+            </a:r>
+            <a:r>
+              <a:rPr lang="hu-HU" sz="1200" dirty="0" err="1">
+                <a:latin typeface="Montserrat" panose="00000500000000000000" pitchFamily="2" charset="-18"/>
+              </a:rPr>
+              <a:t>ipsum</a:t>
+            </a:r>
+            <a:r>
+              <a:rPr lang="hu-HU" sz="1200" dirty="0">
+                <a:latin typeface="Montserrat" panose="00000500000000000000" pitchFamily="2" charset="-18"/>
+              </a:rPr>
+              <a:t> </a:t>
+            </a:r>
+            <a:r>
+              <a:rPr lang="hu-HU" sz="1200" dirty="0" err="1">
+                <a:latin typeface="Montserrat" panose="00000500000000000000" pitchFamily="2" charset="-18"/>
+              </a:rPr>
+              <a:t>dolor</a:t>
+            </a:r>
+            <a:r>
+              <a:rPr lang="hu-HU" sz="1200" dirty="0">
+                <a:latin typeface="Montserrat" panose="00000500000000000000" pitchFamily="2" charset="-18"/>
+              </a:rPr>
+              <a:t> </a:t>
+            </a:r>
+            <a:r>
+              <a:rPr lang="hu-HU" sz="1200" dirty="0" err="1">
+                <a:latin typeface="Montserrat" panose="00000500000000000000" pitchFamily="2" charset="-18"/>
+              </a:rPr>
+              <a:t>sit</a:t>
+            </a:r>
+            <a:r>
+              <a:rPr lang="hu-HU" sz="1200" dirty="0">
+                <a:latin typeface="Montserrat" panose="00000500000000000000" pitchFamily="2" charset="-18"/>
+              </a:rPr>
+              <a:t> </a:t>
+            </a:r>
+            <a:r>
+              <a:rPr lang="hu-HU" sz="1200" dirty="0" err="1">
+                <a:latin typeface="Montserrat" panose="00000500000000000000" pitchFamily="2" charset="-18"/>
+              </a:rPr>
+              <a:t>amet</a:t>
+            </a:r>
+            <a:r>
+              <a:rPr lang="hu-HU" sz="1200" dirty="0">
+                <a:latin typeface="Montserrat" panose="00000500000000000000" pitchFamily="2" charset="-18"/>
+              </a:rPr>
+              <a:t>, </a:t>
+            </a:r>
+            <a:r>
+              <a:rPr lang="hu-HU" sz="1200" dirty="0" err="1">
+                <a:latin typeface="Montserrat" panose="00000500000000000000" pitchFamily="2" charset="-18"/>
+              </a:rPr>
+              <a:t>consectetur</a:t>
+            </a:r>
+            <a:r>
+              <a:rPr lang="hu-HU" sz="1200" dirty="0">
+                <a:latin typeface="Montserrat" panose="00000500000000000000" pitchFamily="2" charset="-18"/>
+              </a:rPr>
+              <a:t> </a:t>
+            </a:r>
+            <a:r>
+              <a:rPr lang="hu-HU" sz="1200" dirty="0" err="1">
+                <a:latin typeface="Montserrat" panose="00000500000000000000" pitchFamily="2" charset="-18"/>
+              </a:rPr>
+              <a:t>adipiscing</a:t>
+            </a:r>
+            <a:r>
+              <a:rPr lang="hu-HU" sz="1200" dirty="0">
+                <a:latin typeface="Montserrat" panose="00000500000000000000" pitchFamily="2" charset="-18"/>
+              </a:rPr>
+              <a:t> elit. </a:t>
+            </a:r>
+            <a:r>
+              <a:rPr lang="hu-HU" sz="1200" dirty="0" err="1">
+                <a:latin typeface="Montserrat" panose="00000500000000000000" pitchFamily="2" charset="-18"/>
+              </a:rPr>
+              <a:t>Suspendisse</a:t>
+            </a:r>
+            <a:r>
+              <a:rPr lang="hu-HU" sz="1200" dirty="0">
+                <a:latin typeface="Montserrat" panose="00000500000000000000" pitchFamily="2" charset="-18"/>
+              </a:rPr>
+              <a:t> </a:t>
+            </a:r>
+            <a:r>
+              <a:rPr lang="hu-HU" sz="1200" dirty="0" err="1">
+                <a:latin typeface="Montserrat" panose="00000500000000000000" pitchFamily="2" charset="-18"/>
+              </a:rPr>
+              <a:t>ac</a:t>
+            </a:r>
+            <a:r>
+              <a:rPr lang="hu-HU" sz="1200" dirty="0">
+                <a:latin typeface="Montserrat" panose="00000500000000000000" pitchFamily="2" charset="-18"/>
+              </a:rPr>
+              <a:t> est </a:t>
+            </a:r>
+            <a:r>
+              <a:rPr lang="hu-HU" sz="1200" dirty="0" err="1">
+                <a:latin typeface="Montserrat" panose="00000500000000000000" pitchFamily="2" charset="-18"/>
+              </a:rPr>
+              <a:t>ornare</a:t>
+            </a:r>
+            <a:r>
+              <a:rPr lang="hu-HU" sz="1200" dirty="0">
+                <a:latin typeface="Montserrat" panose="00000500000000000000" pitchFamily="2" charset="-18"/>
+              </a:rPr>
+              <a:t>, </a:t>
+            </a:r>
+            <a:r>
+              <a:rPr lang="hu-HU" sz="1200" dirty="0" err="1">
+                <a:latin typeface="Montserrat" panose="00000500000000000000" pitchFamily="2" charset="-18"/>
+              </a:rPr>
+              <a:t>tempor</a:t>
+            </a:r>
+            <a:r>
+              <a:rPr lang="hu-HU" sz="1200" dirty="0">
+                <a:latin typeface="Montserrat" panose="00000500000000000000" pitchFamily="2" charset="-18"/>
+              </a:rPr>
+              <a:t> </a:t>
+            </a:r>
+            <a:r>
+              <a:rPr lang="hu-HU" sz="1200" dirty="0" err="1">
+                <a:latin typeface="Montserrat" panose="00000500000000000000" pitchFamily="2" charset="-18"/>
+              </a:rPr>
+              <a:t>velit</a:t>
+            </a:r>
+            <a:r>
+              <a:rPr lang="hu-HU" sz="1200" dirty="0">
+                <a:latin typeface="Montserrat" panose="00000500000000000000" pitchFamily="2" charset="-18"/>
+              </a:rPr>
+              <a:t> </a:t>
+            </a:r>
+            <a:r>
+              <a:rPr lang="hu-HU" sz="1200" dirty="0" err="1">
+                <a:latin typeface="Montserrat" panose="00000500000000000000" pitchFamily="2" charset="-18"/>
+              </a:rPr>
+              <a:t>id</a:t>
+            </a:r>
+            <a:r>
+              <a:rPr lang="hu-HU" sz="1200" dirty="0">
+                <a:latin typeface="Montserrat" panose="00000500000000000000" pitchFamily="2" charset="-18"/>
+              </a:rPr>
+              <a:t>, </a:t>
+            </a:r>
+            <a:r>
+              <a:rPr lang="hu-HU" sz="1200" dirty="0" err="1">
+                <a:latin typeface="Montserrat" panose="00000500000000000000" pitchFamily="2" charset="-18"/>
+              </a:rPr>
+              <a:t>hendrerit</a:t>
+            </a:r>
+            <a:r>
+              <a:rPr lang="hu-HU" sz="1200" dirty="0">
+                <a:latin typeface="Montserrat" panose="00000500000000000000" pitchFamily="2" charset="-18"/>
+              </a:rPr>
+              <a:t> </a:t>
+            </a:r>
+            <a:r>
+              <a:rPr lang="hu-HU" sz="1200" dirty="0" err="1">
+                <a:latin typeface="Montserrat" panose="00000500000000000000" pitchFamily="2" charset="-18"/>
+              </a:rPr>
+              <a:t>risus</a:t>
+            </a:r>
+            <a:r>
+              <a:rPr lang="hu-HU" sz="1200" dirty="0">
+                <a:latin typeface="Montserrat" panose="00000500000000000000" pitchFamily="2" charset="-18"/>
+              </a:rPr>
+              <a:t>. </a:t>
+            </a:r>
+            <a:r>
+              <a:rPr lang="hu-HU" sz="1200" dirty="0" err="1">
+                <a:latin typeface="Montserrat" panose="00000500000000000000" pitchFamily="2" charset="-18"/>
+              </a:rPr>
+              <a:t>Vestibulum</a:t>
+            </a:r>
+            <a:r>
+              <a:rPr lang="hu-HU" sz="1200" dirty="0">
+                <a:latin typeface="Montserrat" panose="00000500000000000000" pitchFamily="2" charset="-18"/>
+              </a:rPr>
+              <a:t> ante </a:t>
+            </a:r>
+            <a:r>
+              <a:rPr lang="hu-HU" sz="1200" dirty="0" err="1">
+                <a:latin typeface="Montserrat" panose="00000500000000000000" pitchFamily="2" charset="-18"/>
+              </a:rPr>
+              <a:t>ipsum</a:t>
+            </a:r>
+            <a:r>
+              <a:rPr lang="hu-HU" sz="1200" dirty="0">
+                <a:latin typeface="Montserrat" panose="00000500000000000000" pitchFamily="2" charset="-18"/>
+              </a:rPr>
+              <a:t> </a:t>
+            </a:r>
+            <a:r>
+              <a:rPr lang="hu-HU" sz="1200" dirty="0" err="1">
+                <a:latin typeface="Montserrat" panose="00000500000000000000" pitchFamily="2" charset="-18"/>
+              </a:rPr>
+              <a:t>primis</a:t>
+            </a:r>
+            <a:r>
+              <a:rPr lang="hu-HU" sz="1200" dirty="0">
+                <a:latin typeface="Montserrat" panose="00000500000000000000" pitchFamily="2" charset="-18"/>
+              </a:rPr>
+              <a:t> in </a:t>
+            </a:r>
+            <a:r>
+              <a:rPr lang="hu-HU" sz="1200" dirty="0" err="1">
+                <a:latin typeface="Montserrat" panose="00000500000000000000" pitchFamily="2" charset="-18"/>
+              </a:rPr>
+              <a:t>faucibus</a:t>
+            </a:r>
+            <a:r>
+              <a:rPr lang="hu-HU" sz="1200" dirty="0">
+                <a:latin typeface="Montserrat" panose="00000500000000000000" pitchFamily="2" charset="-18"/>
+              </a:rPr>
+              <a:t> </a:t>
+            </a:r>
+            <a:r>
+              <a:rPr lang="hu-HU" sz="1200" dirty="0" err="1">
+                <a:latin typeface="Montserrat" panose="00000500000000000000" pitchFamily="2" charset="-18"/>
+              </a:rPr>
+              <a:t>orci</a:t>
+            </a:r>
+            <a:r>
+              <a:rPr lang="hu-HU" sz="1200" dirty="0">
+                <a:latin typeface="Montserrat" panose="00000500000000000000" pitchFamily="2" charset="-18"/>
+              </a:rPr>
+              <a:t> </a:t>
+            </a:r>
+            <a:r>
+              <a:rPr lang="hu-HU" sz="1200" dirty="0" err="1">
+                <a:latin typeface="Montserrat" panose="00000500000000000000" pitchFamily="2" charset="-18"/>
+              </a:rPr>
+              <a:t>luctus</a:t>
+            </a:r>
+            <a:r>
+              <a:rPr lang="hu-HU" sz="1200" dirty="0">
+                <a:latin typeface="Montserrat" panose="00000500000000000000" pitchFamily="2" charset="-18"/>
+              </a:rPr>
+              <a:t> </a:t>
+            </a:r>
+            <a:r>
+              <a:rPr lang="hu-HU" sz="1200" dirty="0" err="1">
+                <a:latin typeface="Montserrat" panose="00000500000000000000" pitchFamily="2" charset="-18"/>
+              </a:rPr>
+              <a:t>et</a:t>
+            </a:r>
+            <a:r>
+              <a:rPr lang="hu-HU" sz="1200" dirty="0">
+                <a:latin typeface="Montserrat" panose="00000500000000000000" pitchFamily="2" charset="-18"/>
+              </a:rPr>
+              <a:t> </a:t>
+            </a:r>
+            <a:r>
+              <a:rPr lang="hu-HU" sz="1200" dirty="0" err="1">
+                <a:latin typeface="Montserrat" panose="00000500000000000000" pitchFamily="2" charset="-18"/>
+              </a:rPr>
+              <a:t>ultrices</a:t>
+            </a:r>
+            <a:r>
+              <a:rPr lang="hu-HU" sz="1200" dirty="0">
+                <a:latin typeface="Montserrat" panose="00000500000000000000" pitchFamily="2" charset="-18"/>
+              </a:rPr>
+              <a:t> </a:t>
+            </a:r>
+            <a:r>
+              <a:rPr lang="hu-HU" sz="1200" dirty="0" err="1">
+                <a:latin typeface="Montserrat" panose="00000500000000000000" pitchFamily="2" charset="-18"/>
+              </a:rPr>
+              <a:t>posuere</a:t>
+            </a:r>
+            <a:r>
+              <a:rPr lang="hu-HU" sz="1200" dirty="0">
+                <a:latin typeface="Montserrat" panose="00000500000000000000" pitchFamily="2" charset="-18"/>
+              </a:rPr>
+              <a:t> </a:t>
+            </a:r>
+            <a:r>
+              <a:rPr lang="hu-HU" sz="1200" dirty="0" err="1">
+                <a:latin typeface="Montserrat" panose="00000500000000000000" pitchFamily="2" charset="-18"/>
+              </a:rPr>
+              <a:t>cubilia</a:t>
+            </a:r>
+            <a:r>
+              <a:rPr lang="hu-HU" sz="1200" dirty="0">
+                <a:latin typeface="Montserrat" panose="00000500000000000000" pitchFamily="2" charset="-18"/>
+              </a:rPr>
+              <a:t> </a:t>
+            </a:r>
+            <a:r>
+              <a:rPr lang="hu-HU" sz="1200" dirty="0" err="1">
+                <a:latin typeface="Montserrat" panose="00000500000000000000" pitchFamily="2" charset="-18"/>
+              </a:rPr>
+              <a:t>curae</a:t>
+            </a:r>
+            <a:r>
+              <a:rPr lang="hu-HU" sz="1200" dirty="0">
+                <a:latin typeface="Montserrat" panose="00000500000000000000" pitchFamily="2" charset="-18"/>
+              </a:rPr>
+              <a:t>; </a:t>
+            </a:r>
+            <a:r>
+              <a:rPr lang="hu-HU" sz="1200" dirty="0" err="1">
+                <a:latin typeface="Montserrat" panose="00000500000000000000" pitchFamily="2" charset="-18"/>
+              </a:rPr>
+              <a:t>Mauris</a:t>
+            </a:r>
+            <a:r>
+              <a:rPr lang="hu-HU" sz="1200" dirty="0">
+                <a:latin typeface="Montserrat" panose="00000500000000000000" pitchFamily="2" charset="-18"/>
+              </a:rPr>
+              <a:t> </a:t>
+            </a:r>
+            <a:r>
+              <a:rPr lang="hu-HU" sz="1200" dirty="0" err="1">
+                <a:latin typeface="Montserrat" panose="00000500000000000000" pitchFamily="2" charset="-18"/>
+              </a:rPr>
+              <a:t>volutpat</a:t>
+            </a:r>
+            <a:r>
+              <a:rPr lang="hu-HU" sz="1200" dirty="0">
+                <a:latin typeface="Montserrat" panose="00000500000000000000" pitchFamily="2" charset="-18"/>
+              </a:rPr>
+              <a:t> </a:t>
+            </a:r>
+            <a:r>
+              <a:rPr lang="hu-HU" sz="1200" dirty="0" err="1">
+                <a:latin typeface="Montserrat" panose="00000500000000000000" pitchFamily="2" charset="-18"/>
+              </a:rPr>
+              <a:t>justo</a:t>
+            </a:r>
+            <a:r>
+              <a:rPr lang="hu-HU" sz="1200" dirty="0">
+                <a:latin typeface="Montserrat" panose="00000500000000000000" pitchFamily="2" charset="-18"/>
+              </a:rPr>
+              <a:t> </a:t>
+            </a:r>
+            <a:r>
+              <a:rPr lang="hu-HU" sz="1200" dirty="0" err="1">
+                <a:latin typeface="Montserrat" panose="00000500000000000000" pitchFamily="2" charset="-18"/>
+              </a:rPr>
+              <a:t>lacus</a:t>
+            </a:r>
+            <a:r>
+              <a:rPr lang="hu-HU" sz="1200" dirty="0">
+                <a:latin typeface="Montserrat" panose="00000500000000000000" pitchFamily="2" charset="-18"/>
+              </a:rPr>
+              <a:t>, </a:t>
+            </a:r>
+            <a:r>
+              <a:rPr lang="hu-HU" sz="1200" dirty="0" err="1">
+                <a:latin typeface="Montserrat" panose="00000500000000000000" pitchFamily="2" charset="-18"/>
+              </a:rPr>
+              <a:t>ac</a:t>
+            </a:r>
+            <a:r>
+              <a:rPr lang="hu-HU" sz="1200" dirty="0">
+                <a:latin typeface="Montserrat" panose="00000500000000000000" pitchFamily="2" charset="-18"/>
+              </a:rPr>
+              <a:t> </a:t>
+            </a:r>
+            <a:r>
+              <a:rPr lang="hu-HU" sz="1200" dirty="0" err="1">
+                <a:latin typeface="Montserrat" panose="00000500000000000000" pitchFamily="2" charset="-18"/>
+              </a:rPr>
+              <a:t>vestibulum</a:t>
+            </a:r>
+            <a:r>
+              <a:rPr lang="hu-HU" sz="1200" dirty="0">
+                <a:latin typeface="Montserrat" panose="00000500000000000000" pitchFamily="2" charset="-18"/>
+              </a:rPr>
+              <a:t> tortor </a:t>
+            </a:r>
+            <a:r>
+              <a:rPr lang="hu-HU" sz="1200" dirty="0" err="1">
+                <a:latin typeface="Montserrat" panose="00000500000000000000" pitchFamily="2" charset="-18"/>
+              </a:rPr>
+              <a:t>rhoncus</a:t>
+            </a:r>
+            <a:r>
+              <a:rPr lang="hu-HU" sz="1200" dirty="0">
+                <a:latin typeface="Montserrat" panose="00000500000000000000" pitchFamily="2" charset="-18"/>
+              </a:rPr>
+              <a:t> non. In </a:t>
+            </a:r>
+            <a:r>
+              <a:rPr lang="hu-HU" sz="1200" dirty="0" err="1">
+                <a:latin typeface="Montserrat" panose="00000500000000000000" pitchFamily="2" charset="-18"/>
+              </a:rPr>
+              <a:t>quis</a:t>
+            </a:r>
+            <a:r>
+              <a:rPr lang="hu-HU" sz="1200" dirty="0">
+                <a:latin typeface="Montserrat" panose="00000500000000000000" pitchFamily="2" charset="-18"/>
+              </a:rPr>
+              <a:t> </a:t>
+            </a:r>
+            <a:r>
+              <a:rPr lang="hu-HU" sz="1200" dirty="0" err="1">
+                <a:latin typeface="Montserrat" panose="00000500000000000000" pitchFamily="2" charset="-18"/>
+              </a:rPr>
+              <a:t>tincidunt</a:t>
+            </a:r>
+            <a:r>
+              <a:rPr lang="hu-HU" sz="1200" dirty="0">
+                <a:latin typeface="Montserrat" panose="00000500000000000000" pitchFamily="2" charset="-18"/>
+              </a:rPr>
+              <a:t> </a:t>
+            </a:r>
+            <a:r>
+              <a:rPr lang="hu-HU" sz="1200" dirty="0" err="1">
+                <a:latin typeface="Montserrat" panose="00000500000000000000" pitchFamily="2" charset="-18"/>
+              </a:rPr>
+              <a:t>lorem</a:t>
+            </a:r>
+            <a:r>
+              <a:rPr lang="hu-HU" sz="1200" dirty="0">
+                <a:latin typeface="Montserrat" panose="00000500000000000000" pitchFamily="2" charset="-18"/>
+              </a:rPr>
+              <a:t>. Nulla </a:t>
+            </a:r>
+            <a:r>
+              <a:rPr lang="hu-HU" sz="1200" dirty="0" err="1">
+                <a:latin typeface="Montserrat" panose="00000500000000000000" pitchFamily="2" charset="-18"/>
+              </a:rPr>
+              <a:t>efficitur</a:t>
+            </a:r>
+            <a:r>
+              <a:rPr lang="hu-HU" sz="1200" dirty="0">
+                <a:latin typeface="Montserrat" panose="00000500000000000000" pitchFamily="2" charset="-18"/>
+              </a:rPr>
+              <a:t> </a:t>
+            </a:r>
+            <a:r>
+              <a:rPr lang="hu-HU" sz="1200" dirty="0" err="1">
+                <a:latin typeface="Montserrat" panose="00000500000000000000" pitchFamily="2" charset="-18"/>
+              </a:rPr>
+              <a:t>hendrerit</a:t>
+            </a:r>
+            <a:r>
+              <a:rPr lang="hu-HU" sz="1200" dirty="0">
+                <a:latin typeface="Montserrat" panose="00000500000000000000" pitchFamily="2" charset="-18"/>
+              </a:rPr>
+              <a:t> </a:t>
+            </a:r>
+            <a:r>
+              <a:rPr lang="hu-HU" sz="1200" dirty="0" err="1">
+                <a:latin typeface="Montserrat" panose="00000500000000000000" pitchFamily="2" charset="-18"/>
+              </a:rPr>
+              <a:t>efficitur</a:t>
+            </a:r>
+            <a:r>
+              <a:rPr lang="hu-HU" sz="1200" dirty="0">
+                <a:latin typeface="Montserrat" panose="00000500000000000000" pitchFamily="2" charset="-18"/>
+              </a:rPr>
+              <a:t>. </a:t>
+            </a:r>
+            <a:r>
+              <a:rPr lang="hu-HU" sz="1200" dirty="0" err="1">
+                <a:latin typeface="Montserrat" panose="00000500000000000000" pitchFamily="2" charset="-18"/>
+              </a:rPr>
+              <a:t>Vivamus</a:t>
+            </a:r>
+            <a:r>
+              <a:rPr lang="hu-HU" sz="1200" dirty="0">
+                <a:latin typeface="Montserrat" panose="00000500000000000000" pitchFamily="2" charset="-18"/>
+              </a:rPr>
+              <a:t> </a:t>
+            </a:r>
+            <a:r>
+              <a:rPr lang="hu-HU" sz="1200" dirty="0" err="1">
+                <a:latin typeface="Montserrat" panose="00000500000000000000" pitchFamily="2" charset="-18"/>
+              </a:rPr>
+              <a:t>ut</a:t>
+            </a:r>
+            <a:r>
+              <a:rPr lang="hu-HU" sz="1200" dirty="0">
+                <a:latin typeface="Montserrat" panose="00000500000000000000" pitchFamily="2" charset="-18"/>
+              </a:rPr>
+              <a:t> </a:t>
+            </a:r>
+            <a:r>
+              <a:rPr lang="hu-HU" sz="1200" dirty="0" err="1">
+                <a:latin typeface="Montserrat" panose="00000500000000000000" pitchFamily="2" charset="-18"/>
+              </a:rPr>
+              <a:t>euismod</a:t>
+            </a:r>
+            <a:r>
+              <a:rPr lang="hu-HU" sz="1200" dirty="0">
+                <a:latin typeface="Montserrat" panose="00000500000000000000" pitchFamily="2" charset="-18"/>
+              </a:rPr>
+              <a:t> est. </a:t>
+            </a:r>
+            <a:r>
+              <a:rPr lang="hu-HU" sz="1200" dirty="0" err="1">
+                <a:latin typeface="Montserrat" panose="00000500000000000000" pitchFamily="2" charset="-18"/>
+              </a:rPr>
+              <a:t>Etiam</a:t>
+            </a:r>
+            <a:r>
+              <a:rPr lang="hu-HU" sz="1200" dirty="0">
+                <a:latin typeface="Montserrat" panose="00000500000000000000" pitchFamily="2" charset="-18"/>
+              </a:rPr>
+              <a:t> </a:t>
+            </a:r>
+            <a:r>
+              <a:rPr lang="hu-HU" sz="1200" dirty="0" err="1">
+                <a:latin typeface="Montserrat" panose="00000500000000000000" pitchFamily="2" charset="-18"/>
+              </a:rPr>
+              <a:t>viverra</a:t>
+            </a:r>
+            <a:r>
+              <a:rPr lang="hu-HU" sz="1200" dirty="0">
+                <a:latin typeface="Montserrat" panose="00000500000000000000" pitchFamily="2" charset="-18"/>
+              </a:rPr>
+              <a:t>, </a:t>
+            </a:r>
+            <a:r>
+              <a:rPr lang="hu-HU" sz="1200" dirty="0" err="1">
+                <a:latin typeface="Montserrat" panose="00000500000000000000" pitchFamily="2" charset="-18"/>
+              </a:rPr>
+              <a:t>eros</a:t>
+            </a:r>
+            <a:r>
+              <a:rPr lang="hu-HU" sz="1200" dirty="0">
+                <a:latin typeface="Montserrat" panose="00000500000000000000" pitchFamily="2" charset="-18"/>
+              </a:rPr>
+              <a:t> </a:t>
+            </a:r>
+            <a:r>
+              <a:rPr lang="hu-HU" sz="1200" dirty="0" err="1">
+                <a:latin typeface="Montserrat" panose="00000500000000000000" pitchFamily="2" charset="-18"/>
+              </a:rPr>
+              <a:t>sit</a:t>
+            </a:r>
+            <a:r>
+              <a:rPr lang="hu-HU" sz="1200" dirty="0">
+                <a:latin typeface="Montserrat" panose="00000500000000000000" pitchFamily="2" charset="-18"/>
+              </a:rPr>
+              <a:t> </a:t>
+            </a:r>
+            <a:r>
+              <a:rPr lang="hu-HU" sz="1200" dirty="0" err="1">
+                <a:latin typeface="Montserrat" panose="00000500000000000000" pitchFamily="2" charset="-18"/>
+              </a:rPr>
+              <a:t>amet</a:t>
+            </a:r>
+            <a:r>
+              <a:rPr lang="hu-HU" sz="1200" dirty="0">
+                <a:latin typeface="Montserrat" panose="00000500000000000000" pitchFamily="2" charset="-18"/>
+              </a:rPr>
+              <a:t> </a:t>
+            </a:r>
+            <a:r>
+              <a:rPr lang="hu-HU" sz="1200" dirty="0" err="1">
+                <a:latin typeface="Montserrat" panose="00000500000000000000" pitchFamily="2" charset="-18"/>
+              </a:rPr>
+              <a:t>maximus</a:t>
+            </a:r>
+            <a:r>
+              <a:rPr lang="hu-HU" sz="1200" dirty="0">
+                <a:latin typeface="Montserrat" panose="00000500000000000000" pitchFamily="2" charset="-18"/>
+              </a:rPr>
+              <a:t> </a:t>
+            </a:r>
+            <a:r>
+              <a:rPr lang="hu-HU" sz="1200" dirty="0" err="1">
+                <a:latin typeface="Montserrat" panose="00000500000000000000" pitchFamily="2" charset="-18"/>
+              </a:rPr>
+              <a:t>pellentesque</a:t>
+            </a:r>
+            <a:r>
+              <a:rPr lang="hu-HU" sz="1200" dirty="0">
+                <a:latin typeface="Montserrat" panose="00000500000000000000" pitchFamily="2" charset="-18"/>
+              </a:rPr>
+              <a:t>, </a:t>
+            </a:r>
+            <a:r>
+              <a:rPr lang="hu-HU" sz="1200" dirty="0" err="1">
+                <a:latin typeface="Montserrat" panose="00000500000000000000" pitchFamily="2" charset="-18"/>
+              </a:rPr>
+              <a:t>orci</a:t>
+            </a:r>
+            <a:r>
+              <a:rPr lang="hu-HU" sz="1200" dirty="0">
+                <a:latin typeface="Montserrat" panose="00000500000000000000" pitchFamily="2" charset="-18"/>
+              </a:rPr>
+              <a:t> </a:t>
+            </a:r>
+            <a:r>
+              <a:rPr lang="hu-HU" sz="1200" dirty="0" err="1">
+                <a:latin typeface="Montserrat" panose="00000500000000000000" pitchFamily="2" charset="-18"/>
+              </a:rPr>
+              <a:t>dui</a:t>
+            </a:r>
+            <a:r>
+              <a:rPr lang="hu-HU" sz="1200" dirty="0">
+                <a:latin typeface="Montserrat" panose="00000500000000000000" pitchFamily="2" charset="-18"/>
+              </a:rPr>
+              <a:t> </a:t>
+            </a:r>
+            <a:r>
+              <a:rPr lang="hu-HU" sz="1200" dirty="0" err="1">
+                <a:latin typeface="Montserrat" panose="00000500000000000000" pitchFamily="2" charset="-18"/>
+              </a:rPr>
+              <a:t>auctor</a:t>
+            </a:r>
+            <a:r>
+              <a:rPr lang="hu-HU" sz="1200" dirty="0">
+                <a:latin typeface="Montserrat" panose="00000500000000000000" pitchFamily="2" charset="-18"/>
+              </a:rPr>
+              <a:t> </a:t>
+            </a:r>
+            <a:r>
+              <a:rPr lang="hu-HU" sz="1200" dirty="0" err="1">
+                <a:latin typeface="Montserrat" panose="00000500000000000000" pitchFamily="2" charset="-18"/>
+              </a:rPr>
+              <a:t>massa</a:t>
+            </a:r>
+            <a:r>
+              <a:rPr lang="hu-HU" sz="1200" dirty="0">
+                <a:latin typeface="Montserrat" panose="00000500000000000000" pitchFamily="2" charset="-18"/>
+              </a:rPr>
+              <a:t>, </a:t>
+            </a:r>
+            <a:r>
+              <a:rPr lang="hu-HU" sz="1200" dirty="0" err="1">
+                <a:latin typeface="Montserrat" panose="00000500000000000000" pitchFamily="2" charset="-18"/>
+              </a:rPr>
+              <a:t>sit</a:t>
+            </a:r>
+            <a:r>
+              <a:rPr lang="hu-HU" sz="1200" dirty="0">
+                <a:latin typeface="Montserrat" panose="00000500000000000000" pitchFamily="2" charset="-18"/>
+              </a:rPr>
+              <a:t> </a:t>
+            </a:r>
+            <a:r>
+              <a:rPr lang="hu-HU" sz="1200" dirty="0" err="1">
+                <a:latin typeface="Montserrat" panose="00000500000000000000" pitchFamily="2" charset="-18"/>
+              </a:rPr>
+              <a:t>amet</a:t>
+            </a:r>
+            <a:r>
+              <a:rPr lang="hu-HU" sz="1200" dirty="0">
+                <a:latin typeface="Montserrat" panose="00000500000000000000" pitchFamily="2" charset="-18"/>
+              </a:rPr>
+              <a:t> </a:t>
+            </a:r>
+            <a:r>
+              <a:rPr lang="hu-HU" sz="1200" dirty="0" err="1">
+                <a:latin typeface="Montserrat" panose="00000500000000000000" pitchFamily="2" charset="-18"/>
+              </a:rPr>
+              <a:t>sollicitudin</a:t>
+            </a:r>
+            <a:r>
+              <a:rPr lang="hu-HU" sz="1200" dirty="0">
+                <a:latin typeface="Montserrat" panose="00000500000000000000" pitchFamily="2" charset="-18"/>
+              </a:rPr>
+              <a:t> mi </a:t>
+            </a:r>
+            <a:r>
+              <a:rPr lang="hu-HU" sz="1200" dirty="0" err="1">
+                <a:latin typeface="Montserrat" panose="00000500000000000000" pitchFamily="2" charset="-18"/>
+              </a:rPr>
+              <a:t>nibh</a:t>
+            </a:r>
+            <a:r>
+              <a:rPr lang="hu-HU" sz="1200" dirty="0">
+                <a:latin typeface="Montserrat" panose="00000500000000000000" pitchFamily="2" charset="-18"/>
+              </a:rPr>
+              <a:t> non </a:t>
+            </a:r>
+            <a:r>
+              <a:rPr lang="hu-HU" sz="1200" dirty="0" err="1">
+                <a:latin typeface="Montserrat" panose="00000500000000000000" pitchFamily="2" charset="-18"/>
+              </a:rPr>
+              <a:t>nisi</a:t>
+            </a:r>
+            <a:r>
+              <a:rPr lang="hu-HU" sz="1200" dirty="0">
+                <a:latin typeface="Montserrat" panose="00000500000000000000" pitchFamily="2" charset="-18"/>
+              </a:rPr>
+              <a:t>. Nullam dictum ante </a:t>
+            </a:r>
+            <a:r>
+              <a:rPr lang="hu-HU" sz="1200" dirty="0" err="1">
+                <a:latin typeface="Montserrat" panose="00000500000000000000" pitchFamily="2" charset="-18"/>
+              </a:rPr>
+              <a:t>sit</a:t>
+            </a:r>
+            <a:r>
+              <a:rPr lang="hu-HU" sz="1200" dirty="0">
+                <a:latin typeface="Montserrat" panose="00000500000000000000" pitchFamily="2" charset="-18"/>
+              </a:rPr>
+              <a:t> </a:t>
+            </a:r>
+            <a:r>
+              <a:rPr lang="hu-HU" sz="1200" dirty="0" err="1">
+                <a:latin typeface="Montserrat" panose="00000500000000000000" pitchFamily="2" charset="-18"/>
+              </a:rPr>
+              <a:t>amet</a:t>
+            </a:r>
+            <a:r>
+              <a:rPr lang="hu-HU" sz="1200" dirty="0">
+                <a:latin typeface="Montserrat" panose="00000500000000000000" pitchFamily="2" charset="-18"/>
+              </a:rPr>
+              <a:t> mi </a:t>
+            </a:r>
+            <a:r>
+              <a:rPr lang="hu-HU" sz="1200" dirty="0" err="1">
+                <a:latin typeface="Montserrat" panose="00000500000000000000" pitchFamily="2" charset="-18"/>
+              </a:rPr>
+              <a:t>aliquam</a:t>
+            </a:r>
+            <a:r>
+              <a:rPr lang="hu-HU" sz="1200" dirty="0">
+                <a:latin typeface="Montserrat" panose="00000500000000000000" pitchFamily="2" charset="-18"/>
+              </a:rPr>
+              <a:t>, in </a:t>
+            </a:r>
+            <a:r>
+              <a:rPr lang="hu-HU" sz="1200" dirty="0" err="1">
+                <a:latin typeface="Montserrat" panose="00000500000000000000" pitchFamily="2" charset="-18"/>
+              </a:rPr>
+              <a:t>gravida</a:t>
+            </a:r>
+            <a:r>
+              <a:rPr lang="hu-HU" sz="1200" dirty="0">
+                <a:latin typeface="Montserrat" panose="00000500000000000000" pitchFamily="2" charset="-18"/>
+              </a:rPr>
+              <a:t> </a:t>
+            </a:r>
+            <a:r>
+              <a:rPr lang="hu-HU" sz="1200" dirty="0" err="1">
+                <a:latin typeface="Montserrat" panose="00000500000000000000" pitchFamily="2" charset="-18"/>
+              </a:rPr>
+              <a:t>ipsum</a:t>
+            </a:r>
+            <a:r>
+              <a:rPr lang="hu-HU" sz="1200" dirty="0">
+                <a:latin typeface="Montserrat" panose="00000500000000000000" pitchFamily="2" charset="-18"/>
+              </a:rPr>
+              <a:t> </a:t>
+            </a:r>
+            <a:r>
+              <a:rPr lang="hu-HU" sz="1200" dirty="0" err="1">
+                <a:latin typeface="Montserrat" panose="00000500000000000000" pitchFamily="2" charset="-18"/>
+              </a:rPr>
+              <a:t>consequat</a:t>
+            </a:r>
+            <a:r>
+              <a:rPr lang="hu-HU" sz="1200" dirty="0">
+                <a:latin typeface="Montserrat" panose="00000500000000000000" pitchFamily="2" charset="-18"/>
+              </a:rPr>
+              <a:t>. </a:t>
+            </a:r>
+            <a:r>
+              <a:rPr lang="hu-HU" sz="1200" dirty="0" err="1">
+                <a:latin typeface="Montserrat" panose="00000500000000000000" pitchFamily="2" charset="-18"/>
+              </a:rPr>
+              <a:t>Morbi</a:t>
+            </a:r>
+            <a:r>
+              <a:rPr lang="hu-HU" sz="1200" dirty="0">
+                <a:latin typeface="Montserrat" panose="00000500000000000000" pitchFamily="2" charset="-18"/>
+              </a:rPr>
+              <a:t> </a:t>
+            </a:r>
+            <a:r>
+              <a:rPr lang="hu-HU" sz="1200" dirty="0" err="1">
+                <a:latin typeface="Montserrat" panose="00000500000000000000" pitchFamily="2" charset="-18"/>
+              </a:rPr>
+              <a:t>sodales</a:t>
+            </a:r>
+            <a:r>
+              <a:rPr lang="hu-HU" sz="1200" dirty="0">
+                <a:latin typeface="Montserrat" panose="00000500000000000000" pitchFamily="2" charset="-18"/>
+              </a:rPr>
+              <a:t> </a:t>
+            </a:r>
+            <a:r>
+              <a:rPr lang="hu-HU" sz="1200" dirty="0" err="1">
+                <a:latin typeface="Montserrat" panose="00000500000000000000" pitchFamily="2" charset="-18"/>
+              </a:rPr>
+              <a:t>luctus</a:t>
+            </a:r>
+            <a:r>
+              <a:rPr lang="hu-HU" sz="1200" dirty="0">
+                <a:latin typeface="Montserrat" panose="00000500000000000000" pitchFamily="2" charset="-18"/>
+              </a:rPr>
+              <a:t> </a:t>
+            </a:r>
+            <a:r>
+              <a:rPr lang="hu-HU" sz="1200" dirty="0" err="1">
+                <a:latin typeface="Montserrat" panose="00000500000000000000" pitchFamily="2" charset="-18"/>
+              </a:rPr>
+              <a:t>ligula</a:t>
+            </a:r>
+            <a:r>
+              <a:rPr lang="hu-HU" sz="1200" dirty="0">
+                <a:latin typeface="Montserrat" panose="00000500000000000000" pitchFamily="2" charset="-18"/>
+              </a:rPr>
+              <a:t> non </a:t>
+            </a:r>
+            <a:r>
+              <a:rPr lang="hu-HU" sz="1200" dirty="0" err="1">
+                <a:latin typeface="Montserrat" panose="00000500000000000000" pitchFamily="2" charset="-18"/>
+              </a:rPr>
+              <a:t>bibendum</a:t>
+            </a:r>
+            <a:r>
+              <a:rPr lang="hu-HU" sz="1200" dirty="0">
+                <a:latin typeface="Montserrat" panose="00000500000000000000" pitchFamily="2" charset="-18"/>
+              </a:rPr>
+              <a:t>. </a:t>
+            </a:r>
+            <a:r>
+              <a:rPr lang="hu-HU" sz="1200" dirty="0" err="1">
+                <a:latin typeface="Montserrat" panose="00000500000000000000" pitchFamily="2" charset="-18"/>
+              </a:rPr>
+              <a:t>Curabitur</a:t>
+            </a:r>
+            <a:r>
+              <a:rPr lang="hu-HU" sz="1200" dirty="0">
+                <a:latin typeface="Montserrat" panose="00000500000000000000" pitchFamily="2" charset="-18"/>
+              </a:rPr>
+              <a:t> </a:t>
+            </a:r>
+            <a:r>
+              <a:rPr lang="hu-HU" sz="1200" dirty="0" err="1">
+                <a:latin typeface="Montserrat" panose="00000500000000000000" pitchFamily="2" charset="-18"/>
+              </a:rPr>
+              <a:t>laoreet</a:t>
+            </a:r>
+            <a:r>
+              <a:rPr lang="hu-HU" sz="1200" dirty="0">
+                <a:latin typeface="Montserrat" panose="00000500000000000000" pitchFamily="2" charset="-18"/>
+              </a:rPr>
+              <a:t> </a:t>
+            </a:r>
+            <a:r>
+              <a:rPr lang="hu-HU" sz="1200" dirty="0" err="1">
+                <a:latin typeface="Montserrat" panose="00000500000000000000" pitchFamily="2" charset="-18"/>
+              </a:rPr>
+              <a:t>placerat</a:t>
+            </a:r>
+            <a:r>
+              <a:rPr lang="hu-HU" sz="1200" dirty="0">
+                <a:latin typeface="Montserrat" panose="00000500000000000000" pitchFamily="2" charset="-18"/>
+              </a:rPr>
+              <a:t> </a:t>
+            </a:r>
+            <a:r>
+              <a:rPr lang="hu-HU" sz="1200" dirty="0" err="1">
+                <a:latin typeface="Montserrat" panose="00000500000000000000" pitchFamily="2" charset="-18"/>
+              </a:rPr>
+              <a:t>augue</a:t>
+            </a:r>
+            <a:r>
+              <a:rPr lang="hu-HU" sz="1200" dirty="0">
+                <a:latin typeface="Montserrat" panose="00000500000000000000" pitchFamily="2" charset="-18"/>
+              </a:rPr>
+              <a:t>, a </a:t>
+            </a:r>
+            <a:r>
+              <a:rPr lang="hu-HU" sz="1200" dirty="0" err="1">
+                <a:latin typeface="Montserrat" panose="00000500000000000000" pitchFamily="2" charset="-18"/>
+              </a:rPr>
+              <a:t>feugiat</a:t>
+            </a:r>
+            <a:r>
+              <a:rPr lang="hu-HU" sz="1200" dirty="0">
+                <a:latin typeface="Montserrat" panose="00000500000000000000" pitchFamily="2" charset="-18"/>
+              </a:rPr>
+              <a:t> </a:t>
+            </a:r>
+            <a:r>
+              <a:rPr lang="hu-HU" sz="1200" dirty="0" err="1">
+                <a:latin typeface="Montserrat" panose="00000500000000000000" pitchFamily="2" charset="-18"/>
+              </a:rPr>
+              <a:t>ipsum</a:t>
+            </a:r>
+            <a:r>
+              <a:rPr lang="hu-HU" sz="1200" dirty="0">
+                <a:latin typeface="Montserrat" panose="00000500000000000000" pitchFamily="2" charset="-18"/>
+              </a:rPr>
+              <a:t> </a:t>
+            </a:r>
+            <a:r>
+              <a:rPr lang="hu-HU" sz="1200" dirty="0" err="1">
+                <a:latin typeface="Montserrat" panose="00000500000000000000" pitchFamily="2" charset="-18"/>
+              </a:rPr>
+              <a:t>consequat</a:t>
+            </a:r>
+            <a:r>
+              <a:rPr lang="hu-HU" sz="1200" dirty="0">
+                <a:latin typeface="Montserrat" panose="00000500000000000000" pitchFamily="2" charset="-18"/>
+              </a:rPr>
+              <a:t> </a:t>
+            </a:r>
+            <a:r>
+              <a:rPr lang="hu-HU" sz="1200" dirty="0" err="1">
+                <a:latin typeface="Montserrat" panose="00000500000000000000" pitchFamily="2" charset="-18"/>
+              </a:rPr>
+              <a:t>pulvinar</a:t>
+            </a:r>
+            <a:r>
+              <a:rPr lang="hu-HU" sz="1200" dirty="0">
+                <a:latin typeface="Montserrat" panose="00000500000000000000" pitchFamily="2" charset="-18"/>
+              </a:rPr>
+              <a:t>. </a:t>
+            </a:r>
+            <a:r>
+              <a:rPr lang="hu-HU" sz="1200" dirty="0" err="1">
+                <a:latin typeface="Montserrat" panose="00000500000000000000" pitchFamily="2" charset="-18"/>
+              </a:rPr>
+              <a:t>Etiam</a:t>
+            </a:r>
+            <a:r>
+              <a:rPr lang="hu-HU" sz="1200" dirty="0">
+                <a:latin typeface="Montserrat" panose="00000500000000000000" pitchFamily="2" charset="-18"/>
+              </a:rPr>
+              <a:t> </a:t>
+            </a:r>
+            <a:r>
+              <a:rPr lang="hu-HU" sz="1200" dirty="0" err="1">
+                <a:latin typeface="Montserrat" panose="00000500000000000000" pitchFamily="2" charset="-18"/>
+              </a:rPr>
+              <a:t>efficitur</a:t>
+            </a:r>
+            <a:r>
+              <a:rPr lang="hu-HU" sz="1200" dirty="0">
+                <a:latin typeface="Montserrat" panose="00000500000000000000" pitchFamily="2" charset="-18"/>
+              </a:rPr>
+              <a:t> </a:t>
+            </a:r>
+            <a:r>
+              <a:rPr lang="hu-HU" sz="1200" dirty="0" err="1">
+                <a:latin typeface="Montserrat" panose="00000500000000000000" pitchFamily="2" charset="-18"/>
+              </a:rPr>
+              <a:t>nunc</a:t>
+            </a:r>
+            <a:r>
+              <a:rPr lang="hu-HU" sz="1200" dirty="0">
+                <a:latin typeface="Montserrat" panose="00000500000000000000" pitchFamily="2" charset="-18"/>
+              </a:rPr>
+              <a:t> vel </a:t>
+            </a:r>
+            <a:r>
+              <a:rPr lang="hu-HU" sz="1200" dirty="0" err="1">
+                <a:latin typeface="Montserrat" panose="00000500000000000000" pitchFamily="2" charset="-18"/>
+              </a:rPr>
+              <a:t>dui</a:t>
+            </a:r>
+            <a:r>
+              <a:rPr lang="hu-HU" sz="1200" dirty="0">
+                <a:latin typeface="Montserrat" panose="00000500000000000000" pitchFamily="2" charset="-18"/>
+              </a:rPr>
+              <a:t> </a:t>
+            </a:r>
+            <a:r>
+              <a:rPr lang="hu-HU" sz="1200" dirty="0" err="1">
+                <a:latin typeface="Montserrat" panose="00000500000000000000" pitchFamily="2" charset="-18"/>
+              </a:rPr>
+              <a:t>porttitor</a:t>
+            </a:r>
+            <a:r>
+              <a:rPr lang="hu-HU" sz="1200" dirty="0">
+                <a:latin typeface="Montserrat" panose="00000500000000000000" pitchFamily="2" charset="-18"/>
+              </a:rPr>
+              <a:t>, </a:t>
+            </a:r>
+            <a:r>
+              <a:rPr lang="hu-HU" sz="1200" dirty="0" err="1">
+                <a:latin typeface="Montserrat" panose="00000500000000000000" pitchFamily="2" charset="-18"/>
+              </a:rPr>
+              <a:t>ac</a:t>
+            </a:r>
+            <a:r>
+              <a:rPr lang="hu-HU" sz="1200" dirty="0">
+                <a:latin typeface="Montserrat" panose="00000500000000000000" pitchFamily="2" charset="-18"/>
+              </a:rPr>
+              <a:t> </a:t>
+            </a:r>
+            <a:r>
+              <a:rPr lang="hu-HU" sz="1200" dirty="0" err="1">
+                <a:latin typeface="Montserrat" panose="00000500000000000000" pitchFamily="2" charset="-18"/>
+              </a:rPr>
+              <a:t>lacinia</a:t>
+            </a:r>
+            <a:r>
+              <a:rPr lang="hu-HU" sz="1200" dirty="0">
+                <a:latin typeface="Montserrat" panose="00000500000000000000" pitchFamily="2" charset="-18"/>
+              </a:rPr>
+              <a:t> </a:t>
+            </a:r>
+            <a:r>
+              <a:rPr lang="hu-HU" sz="1200" dirty="0" err="1">
+                <a:latin typeface="Montserrat" panose="00000500000000000000" pitchFamily="2" charset="-18"/>
+              </a:rPr>
+              <a:t>velit</a:t>
+            </a:r>
+            <a:r>
+              <a:rPr lang="hu-HU" sz="1200" dirty="0">
+                <a:latin typeface="Montserrat" panose="00000500000000000000" pitchFamily="2" charset="-18"/>
+              </a:rPr>
+              <a:t> </a:t>
+            </a:r>
+            <a:r>
+              <a:rPr lang="hu-HU" sz="1200" dirty="0" err="1">
+                <a:latin typeface="Montserrat" panose="00000500000000000000" pitchFamily="2" charset="-18"/>
+              </a:rPr>
+              <a:t>volutpat</a:t>
+            </a:r>
+            <a:r>
+              <a:rPr lang="hu-HU" sz="1200" dirty="0">
+                <a:latin typeface="Montserrat" panose="00000500000000000000" pitchFamily="2" charset="-18"/>
+              </a:rPr>
+              <a:t>. Nullam </a:t>
+            </a:r>
+            <a:r>
+              <a:rPr lang="hu-HU" sz="1200" dirty="0" err="1">
+                <a:latin typeface="Montserrat" panose="00000500000000000000" pitchFamily="2" charset="-18"/>
+              </a:rPr>
+              <a:t>sit</a:t>
+            </a:r>
+            <a:r>
+              <a:rPr lang="hu-HU" sz="1200" dirty="0">
+                <a:latin typeface="Montserrat" panose="00000500000000000000" pitchFamily="2" charset="-18"/>
+              </a:rPr>
+              <a:t> </a:t>
+            </a:r>
+            <a:r>
+              <a:rPr lang="hu-HU" sz="1200" dirty="0" err="1">
+                <a:latin typeface="Montserrat" panose="00000500000000000000" pitchFamily="2" charset="-18"/>
+              </a:rPr>
+              <a:t>amet</a:t>
+            </a:r>
+            <a:r>
+              <a:rPr lang="hu-HU" sz="1200" dirty="0">
+                <a:latin typeface="Montserrat" panose="00000500000000000000" pitchFamily="2" charset="-18"/>
+              </a:rPr>
+              <a:t> </a:t>
+            </a:r>
+            <a:r>
+              <a:rPr lang="hu-HU" sz="1200" dirty="0" err="1">
+                <a:latin typeface="Montserrat" panose="00000500000000000000" pitchFamily="2" charset="-18"/>
+              </a:rPr>
+              <a:t>iaculis</a:t>
+            </a:r>
+            <a:r>
+              <a:rPr lang="hu-HU" sz="1200" dirty="0">
+                <a:latin typeface="Montserrat" panose="00000500000000000000" pitchFamily="2" charset="-18"/>
+              </a:rPr>
+              <a:t> </a:t>
+            </a:r>
+            <a:r>
+              <a:rPr lang="hu-HU" sz="1200" dirty="0" err="1">
+                <a:latin typeface="Montserrat" panose="00000500000000000000" pitchFamily="2" charset="-18"/>
+              </a:rPr>
+              <a:t>nunc</a:t>
+            </a:r>
+            <a:r>
+              <a:rPr lang="hu-HU" sz="1200" dirty="0">
+                <a:latin typeface="Montserrat" panose="00000500000000000000" pitchFamily="2" charset="-18"/>
+              </a:rPr>
+              <a:t>. </a:t>
+            </a:r>
+            <a:r>
+              <a:rPr lang="hu-HU" sz="1200" dirty="0" err="1">
+                <a:latin typeface="Montserrat" panose="00000500000000000000" pitchFamily="2" charset="-18"/>
+              </a:rPr>
+              <a:t>Aenean</a:t>
+            </a:r>
+            <a:r>
+              <a:rPr lang="hu-HU" sz="1200" dirty="0">
+                <a:latin typeface="Montserrat" panose="00000500000000000000" pitchFamily="2" charset="-18"/>
+              </a:rPr>
+              <a:t> vitae </a:t>
+            </a:r>
+            <a:r>
+              <a:rPr lang="hu-HU" sz="1200" dirty="0" err="1">
+                <a:latin typeface="Montserrat" panose="00000500000000000000" pitchFamily="2" charset="-18"/>
+              </a:rPr>
+              <a:t>lorem</a:t>
+            </a:r>
+            <a:r>
+              <a:rPr lang="hu-HU" sz="1200" dirty="0">
+                <a:latin typeface="Montserrat" panose="00000500000000000000" pitchFamily="2" charset="-18"/>
+              </a:rPr>
+              <a:t> </a:t>
+            </a:r>
+            <a:r>
+              <a:rPr lang="hu-HU" sz="1200" dirty="0" err="1">
+                <a:latin typeface="Montserrat" panose="00000500000000000000" pitchFamily="2" charset="-18"/>
+              </a:rPr>
+              <a:t>pellentesque</a:t>
+            </a:r>
+            <a:r>
+              <a:rPr lang="hu-HU" sz="1200" dirty="0">
+                <a:latin typeface="Montserrat" panose="00000500000000000000" pitchFamily="2" charset="-18"/>
+              </a:rPr>
+              <a:t>, </a:t>
+            </a:r>
+            <a:r>
+              <a:rPr lang="hu-HU" sz="1200" dirty="0" err="1">
+                <a:latin typeface="Montserrat" panose="00000500000000000000" pitchFamily="2" charset="-18"/>
+              </a:rPr>
+              <a:t>egestas</a:t>
+            </a:r>
+            <a:r>
+              <a:rPr lang="hu-HU" sz="1200" dirty="0">
+                <a:latin typeface="Montserrat" panose="00000500000000000000" pitchFamily="2" charset="-18"/>
+              </a:rPr>
+              <a:t> mi </a:t>
+            </a:r>
+            <a:r>
+              <a:rPr lang="hu-HU" sz="1200" dirty="0" err="1">
+                <a:latin typeface="Montserrat" panose="00000500000000000000" pitchFamily="2" charset="-18"/>
+              </a:rPr>
+              <a:t>at</a:t>
+            </a:r>
+            <a:r>
+              <a:rPr lang="hu-HU" sz="1200" dirty="0">
+                <a:latin typeface="Montserrat" panose="00000500000000000000" pitchFamily="2" charset="-18"/>
+              </a:rPr>
+              <a:t>, </a:t>
+            </a:r>
+            <a:r>
+              <a:rPr lang="hu-HU" sz="1200" dirty="0" err="1">
+                <a:latin typeface="Montserrat" panose="00000500000000000000" pitchFamily="2" charset="-18"/>
+              </a:rPr>
+              <a:t>egestas</a:t>
+            </a:r>
+            <a:r>
+              <a:rPr lang="hu-HU" sz="1200" dirty="0">
+                <a:latin typeface="Montserrat" panose="00000500000000000000" pitchFamily="2" charset="-18"/>
+              </a:rPr>
+              <a:t> </a:t>
+            </a:r>
+            <a:r>
+              <a:rPr lang="hu-HU" sz="1200" dirty="0" err="1">
+                <a:latin typeface="Montserrat" panose="00000500000000000000" pitchFamily="2" charset="-18"/>
+              </a:rPr>
+              <a:t>augue</a:t>
+            </a:r>
+            <a:r>
+              <a:rPr lang="hu-HU" sz="1200" dirty="0">
+                <a:latin typeface="Montserrat" panose="00000500000000000000" pitchFamily="2" charset="-18"/>
+              </a:rPr>
+              <a:t>.</a:t>
+            </a:r>
+          </a:p>
+          <a:p>
+            <a:pPr marL="0" indent="0" algn="just">
+              <a:buNone/>
+            </a:pPr>
+            <a:endParaRPr lang="hu-HU" sz="1200" dirty="0">
+              <a:solidFill>
+                <a:srgbClr val="00FFFF"/>
+              </a:solidFill>
+              <a:latin typeface="Montserrat" panose="00000500000000000000" pitchFamily="2" charset="-18"/>
+            </a:endParaRPr>
+          </a:p>
+          <a:p>
+            <a:pPr marL="0" indent="0" algn="just">
+              <a:buNone/>
+            </a:pPr>
+            <a:r>
+              <a:rPr lang="hu-HU" sz="1200" u="sng" dirty="0">
+                <a:solidFill>
+                  <a:srgbClr val="BF40FF"/>
+                </a:solidFill>
+                <a:latin typeface="Montserrat" panose="00000500000000000000" pitchFamily="2" charset="-18"/>
+              </a:rPr>
+              <a:t>https://www.hivatkozasminta.hu</a:t>
+            </a:r>
+          </a:p>
+        </p:txBody>
+      </p:sp>
+    </p:spTree>
+    <p:extLst>
+      <p:ext uri="{BB962C8B-B14F-4D97-AF65-F5344CB8AC3E}">
+        <p14:creationId xmlns:p14="http://schemas.microsoft.com/office/powerpoint/2010/main" val="1537887581"/>
+      </p:ext>
+    </p:extLst>
+  </p:cSld>
+  <p:clrMapOvr>
+    <a:masterClrMapping/>
+  </p:clrMapOvr>
+</p:sld>
+</file>
+
+<file path=ppt/slides/slide11.xml><?xml version="1.0" encoding="utf-8"?>
+<p:sld xmlns:a="http://schemas.openxmlformats.org/drawingml/2006/main" xmlns:r="http://schemas.openxmlformats.org/officeDocument/2006/relationships" xmlns:p="http://schemas.openxmlformats.org/presentationml/2006/main">
+  <p:cSld>
+    <p:spTree>
+      <p:nvGrpSpPr>
+        <p:cNvPr id="1" name="">
+          <a:extLst>
+            <a:ext uri="{FF2B5EF4-FFF2-40B4-BE49-F238E27FC236}">
+              <a16:creationId xmlns:a16="http://schemas.microsoft.com/office/drawing/2014/main" id="{792C2CB7-F649-E372-FA34-25F1519556A9}"/>
+            </a:ext>
+          </a:extLst>
+        </p:cNvPr>
+        <p:cNvGrpSpPr/>
+        <p:nvPr/>
+      </p:nvGrpSpPr>
+      <p:grpSpPr>
+        <a:xfrm>
+          <a:off x="0" y="0"/>
+          <a:ext cx="0" cy="0"/>
+          <a:chOff x="0" y="0"/>
+          <a:chExt cx="0" cy="0"/>
+        </a:xfrm>
+      </p:grpSpPr>
+      <p:sp>
+        <p:nvSpPr>
+          <p:cNvPr id="2" name="Cím 1">
+            <a:extLst>
+              <a:ext uri="{FF2B5EF4-FFF2-40B4-BE49-F238E27FC236}">
+                <a16:creationId xmlns:a16="http://schemas.microsoft.com/office/drawing/2014/main" id="{6C0A7E7E-1EE6-E3EA-54ED-2514E7692337}"/>
+              </a:ext>
+            </a:extLst>
+          </p:cNvPr>
+          <p:cNvSpPr>
+            <a:spLocks noGrp="1"/>
+          </p:cNvSpPr>
+          <p:nvPr>
+            <p:ph type="title"/>
+          </p:nvPr>
+        </p:nvSpPr>
+        <p:spPr/>
+        <p:txBody>
+          <a:bodyPr/>
+          <a:lstStyle/>
+          <a:p>
+            <a:r>
+              <a:rPr lang="hu-HU" dirty="0">
+                <a:latin typeface="Montserrat" panose="00000500000000000000" pitchFamily="2" charset="-18"/>
+              </a:rPr>
+              <a:t>Ikonok</a:t>
+            </a:r>
+          </a:p>
+        </p:txBody>
+      </p:sp>
+    </p:spTree>
+    <p:extLst>
+      <p:ext uri="{BB962C8B-B14F-4D97-AF65-F5344CB8AC3E}">
+        <p14:creationId xmlns:p14="http://schemas.microsoft.com/office/powerpoint/2010/main" val="4221162758"/>
+      </p:ext>
+    </p:extLst>
+  </p:cSld>
+  <p:clrMapOvr>
+    <a:masterClrMapping/>
+  </p:clrMapOvr>
+</p:sld>
+</file>
+
 <file path=ppt/slides/slide2.xml><?xml version="1.0" encoding="utf-8"?>
 <p:sld xmlns:a="http://schemas.openxmlformats.org/drawingml/2006/main" xmlns:r="http://schemas.openxmlformats.org/officeDocument/2006/relationships" xmlns:p="http://schemas.openxmlformats.org/presentationml/2006/main">
   <p:cSld>
@@ -4218,7 +5831,9 @@
           <a:lstStyle/>
           <a:p>
             <a:r>
-              <a:rPr lang="hu-HU" dirty="0"/>
+              <a:rPr lang="hu-HU" dirty="0">
+                <a:latin typeface="Montserrat" panose="00000500000000000000" pitchFamily="2" charset="-18"/>
+              </a:rPr>
               <a:t>Projekt célja</a:t>
             </a:r>
           </a:p>
@@ -4246,19 +5861,25 @@
           <a:lstStyle/>
           <a:p>
             <a:r>
-              <a:rPr lang="hu-HU" dirty="0"/>
+              <a:rPr lang="hu-HU" dirty="0">
+                <a:latin typeface="Montserrat" panose="00000500000000000000" pitchFamily="2" charset="-18"/>
+              </a:rPr>
               <a:t>Zene streaming alkalmazás létrehozása</a:t>
             </a:r>
           </a:p>
           <a:p>
             <a:r>
-              <a:rPr lang="hu-HU" dirty="0"/>
+              <a:rPr lang="hu-HU" dirty="0">
+                <a:latin typeface="Montserrat" panose="00000500000000000000" pitchFamily="2" charset="-18"/>
+              </a:rPr>
               <a:t>Web, asztali és mobil platformokra</a:t>
             </a:r>
           </a:p>
           <a:p>
             <a:r>
-              <a:rPr lang="hu-HU" dirty="0"/>
+              <a:rPr lang="hu-HU" dirty="0">
+                <a:latin typeface="Montserrat" panose="00000500000000000000" pitchFamily="2" charset="-18"/>
+              </a:rPr>
               <a:t>Ingyenes felhasználói modell</a:t>
             </a:r>
           </a:p>
@@ -4316,7 +5937,9 @@
           <a:lstStyle/>
           <a:p>
             <a:r>
-              <a:rPr lang="hu-HU" dirty="0"/>
+              <a:rPr lang="hu-HU" dirty="0">
+                <a:latin typeface="Montserrat" panose="00000500000000000000" pitchFamily="2" charset="-18"/>
+              </a:rPr>
               <a:t>Projekt készítői</a:t>
             </a:r>
           </a:p>
@@ -4349,7 +5972,9 @@
           <a:lstStyle/>
           <a:p>
             <a:r>
-              <a:rPr lang="hu-HU" dirty="0"/>
+              <a:rPr lang="hu-HU" dirty="0">
+                <a:latin typeface="Montserrat" panose="00000500000000000000" pitchFamily="2" charset="-18"/>
+              </a:rPr>
               <a:t>Bernáth Ábel (beosztás, feladatok)</a:t>
             </a:r>
           </a:p>
@@ -4367,7 +5992,9 @@
           </a:p>
           <a:p>
             <a:r>
-              <a:rPr lang="hu-HU" dirty="0"/>
+              <a:rPr lang="hu-HU" dirty="0">
+                <a:latin typeface="Montserrat" panose="00000500000000000000" pitchFamily="2" charset="-18"/>
+              </a:rPr>
               <a:t>Nagy Ákos (-”-)</a:t>
             </a:r>
           </a:p>
@@ -8359,11 +9986,15 @@
           <a:lstStyle/>
           <a:p>
             <a:r>
-              <a:rPr lang="hu-HU" dirty="0" err="1"/>
+              <a:rPr lang="hu-HU" dirty="0" err="1">
+                <a:latin typeface="Montserrat" panose="00000500000000000000" pitchFamily="2" charset="-18"/>
+              </a:rPr>
               <a:t>Gantt</a:t>
             </a:r>
             <a:r>
-              <a:rPr lang="hu-HU" dirty="0"/>
+              <a:rPr lang="hu-HU" dirty="0">
+                <a:latin typeface="Montserrat" panose="00000500000000000000" pitchFamily="2" charset="-18"/>
+              </a:rPr>
               <a:t> diagram</a:t>
             </a:r>
           </a:p>
@@ -8451,10 +10082,14 @@
           <a:lstStyle/>
           <a:p>
             <a:r>
-              <a:rPr lang="hu-HU" dirty="0" err="1"/>
+              <a:rPr lang="hu-HU" dirty="0" err="1">
+                <a:latin typeface="Montserrat" panose="00000500000000000000" pitchFamily="2" charset="-18"/>
+              </a:rPr>
               <a:t>Wireframe</a:t>
             </a:r>
-            <a:endParaRPr lang="hu-HU" dirty="0"/>
+            <a:endParaRPr lang="hu-HU" dirty="0">
+              <a:latin typeface="Montserrat" panose="00000500000000000000" pitchFamily="2" charset="-18"/>
+            </a:endParaRPr>
           </a:p>
         </p:txBody>
       </p:sp>
@@ -8492,6 +10127,1973 @@
     <p:extLst>
       <p:ext uri="{BB962C8B-B14F-4D97-AF65-F5344CB8AC3E}">
         <p14:creationId xmlns:p14="http://schemas.microsoft.com/office/powerpoint/2010/main" val="238907221"/>
+      </p:ext>
+    </p:extLst>
+  </p:cSld>
+  <p:clrMapOvr>
+    <a:masterClrMapping/>
+  </p:clrMapOvr>
+</p:sld>
+</file>
+
+<file path=ppt/slides/slide7.xml><?xml version="1.0" encoding="utf-8"?>
+<p:sld xmlns:a="http://schemas.openxmlformats.org/drawingml/2006/main" xmlns:r="http://schemas.openxmlformats.org/officeDocument/2006/relationships" xmlns:p="http://schemas.openxmlformats.org/presentationml/2006/main">
+  <p:cSld>
+    <p:spTree>
+      <p:nvGrpSpPr>
+        <p:cNvPr id="1" name=""/>
+        <p:cNvGrpSpPr/>
+        <p:nvPr/>
+      </p:nvGrpSpPr>
+      <p:grpSpPr>
+        <a:xfrm>
+          <a:off x="0" y="0"/>
+          <a:ext cx="0" cy="0"/>
+          <a:chOff x="0" y="0"/>
+          <a:chExt cx="0" cy="0"/>
+        </a:xfrm>
+      </p:grpSpPr>
+      <p:sp>
+        <p:nvSpPr>
+          <p:cNvPr id="2" name="Cím 1">
+            <a:extLst>
+              <a:ext uri="{FF2B5EF4-FFF2-40B4-BE49-F238E27FC236}">
+                <a16:creationId xmlns:a16="http://schemas.microsoft.com/office/drawing/2014/main" id="{7EF01593-0B6B-B035-325B-6ABD2776C307}"/>
+              </a:ext>
+            </a:extLst>
+          </p:cNvPr>
+          <p:cNvSpPr>
+            <a:spLocks noGrp="1"/>
+          </p:cNvSpPr>
+          <p:nvPr>
+            <p:ph type="title"/>
+          </p:nvPr>
+        </p:nvSpPr>
+        <p:spPr>
+          <a:xfrm>
+            <a:off x="958671" y="2612801"/>
+            <a:ext cx="10274657" cy="1632397"/>
+          </a:xfrm>
+        </p:spPr>
+        <p:txBody>
+          <a:bodyPr>
+            <a:normAutofit fontScale="90000"/>
+          </a:bodyPr>
+          <a:lstStyle/>
+          <a:p>
+            <a:r>
+              <a:rPr lang="hu-HU" sz="8000" dirty="0">
+                <a:latin typeface="Montserrat" panose="00000500000000000000" pitchFamily="2" charset="-18"/>
+              </a:rPr>
+              <a:t>Arculat design </a:t>
+            </a:r>
+            <a:r>
+              <a:rPr lang="hu-HU" sz="8000" dirty="0" err="1">
+                <a:latin typeface="Montserrat" panose="00000500000000000000" pitchFamily="2" charset="-18"/>
+              </a:rPr>
+              <a:t>guide</a:t>
+            </a:r>
+            <a:endParaRPr lang="hu-HU" sz="8000" dirty="0">
+              <a:latin typeface="Montserrat" panose="00000500000000000000" pitchFamily="2" charset="-18"/>
+            </a:endParaRPr>
+          </a:p>
+        </p:txBody>
+      </p:sp>
+    </p:spTree>
+    <p:extLst>
+      <p:ext uri="{BB962C8B-B14F-4D97-AF65-F5344CB8AC3E}">
+        <p14:creationId xmlns:p14="http://schemas.microsoft.com/office/powerpoint/2010/main" val="4088233558"/>
+      </p:ext>
+    </p:extLst>
+  </p:cSld>
+  <p:clrMapOvr>
+    <a:masterClrMapping/>
+  </p:clrMapOvr>
+</p:sld>
+</file>
+
+<file path=ppt/slides/slide8.xml><?xml version="1.0" encoding="utf-8"?>
+<p:sld xmlns:a="http://schemas.openxmlformats.org/drawingml/2006/main" xmlns:r="http://schemas.openxmlformats.org/officeDocument/2006/relationships" xmlns:p="http://schemas.openxmlformats.org/presentationml/2006/main">
+  <p:cSld>
+    <p:spTree>
+      <p:nvGrpSpPr>
+        <p:cNvPr id="1" name=""/>
+        <p:cNvGrpSpPr/>
+        <p:nvPr/>
+      </p:nvGrpSpPr>
+      <p:grpSpPr>
+        <a:xfrm>
+          <a:off x="0" y="0"/>
+          <a:ext cx="0" cy="0"/>
+          <a:chOff x="0" y="0"/>
+          <a:chExt cx="0" cy="0"/>
+        </a:xfrm>
+      </p:grpSpPr>
+      <p:sp>
+        <p:nvSpPr>
+          <p:cNvPr id="9" name="Ellipszis 8">
+            <a:extLst>
+              <a:ext uri="{FF2B5EF4-FFF2-40B4-BE49-F238E27FC236}">
+                <a16:creationId xmlns:a16="http://schemas.microsoft.com/office/drawing/2014/main" id="{B414BDAD-30C9-EFC7-1755-89FB684D684A}"/>
+              </a:ext>
+            </a:extLst>
+          </p:cNvPr>
+          <p:cNvSpPr/>
+          <p:nvPr/>
+        </p:nvSpPr>
+        <p:spPr>
+          <a:xfrm>
+            <a:off x="5996856" y="1551905"/>
+            <a:ext cx="5306095" cy="5306095"/>
+          </a:xfrm>
+          <a:prstGeom prst="ellipse">
+            <a:avLst/>
+          </a:prstGeom>
+          <a:solidFill>
+            <a:schemeClr val="tx1"/>
+          </a:solidFill>
+          <a:ln>
+            <a:solidFill>
+              <a:schemeClr val="tx1"/>
+            </a:solidFill>
+          </a:ln>
+        </p:spPr>
+        <p:style>
+          <a:lnRef idx="2">
+            <a:schemeClr val="accent1">
+              <a:shade val="15000"/>
+            </a:schemeClr>
+          </a:lnRef>
+          <a:fillRef idx="1">
+            <a:schemeClr val="accent1"/>
+          </a:fillRef>
+          <a:effectRef idx="0">
+            <a:schemeClr val="accent1"/>
+          </a:effectRef>
+          <a:fontRef idx="minor">
+            <a:schemeClr val="lt1"/>
+          </a:fontRef>
+        </p:style>
+        <p:txBody>
+          <a:bodyPr rtlCol="0" anchor="ctr"/>
+          <a:lstStyle/>
+          <a:p>
+            <a:pPr algn="ctr"/>
+            <a:endParaRPr lang="hu-HU"/>
+          </a:p>
+        </p:txBody>
+      </p:sp>
+      <p:sp>
+        <p:nvSpPr>
+          <p:cNvPr id="2" name="Cím 1">
+            <a:extLst>
+              <a:ext uri="{FF2B5EF4-FFF2-40B4-BE49-F238E27FC236}">
+                <a16:creationId xmlns:a16="http://schemas.microsoft.com/office/drawing/2014/main" id="{4D15DB0F-3D64-569C-C47B-6200024C51CD}"/>
+              </a:ext>
+            </a:extLst>
+          </p:cNvPr>
+          <p:cNvSpPr>
+            <a:spLocks noGrp="1"/>
+          </p:cNvSpPr>
+          <p:nvPr>
+            <p:ph type="title"/>
+          </p:nvPr>
+        </p:nvSpPr>
+        <p:spPr>
+          <a:xfrm>
+            <a:off x="2004405" y="1196178"/>
+            <a:ext cx="7087135" cy="711454"/>
+          </a:xfrm>
+        </p:spPr>
+        <p:txBody>
+          <a:bodyPr/>
+          <a:lstStyle/>
+          <a:p>
+            <a:r>
+              <a:rPr lang="hu-HU" dirty="0">
+                <a:latin typeface="Montserrat" panose="00000500000000000000" pitchFamily="2" charset="-18"/>
+              </a:rPr>
+              <a:t>Logók</a:t>
+            </a:r>
+          </a:p>
+        </p:txBody>
+      </p:sp>
+      <p:pic>
+        <p:nvPicPr>
+          <p:cNvPr id="5" name="Ábra 4">
+            <a:extLst>
+              <a:ext uri="{FF2B5EF4-FFF2-40B4-BE49-F238E27FC236}">
+                <a16:creationId xmlns:a16="http://schemas.microsoft.com/office/drawing/2014/main" id="{2578BB54-4CB7-C644-96F7-C4B3938388E8}"/>
+              </a:ext>
+            </a:extLst>
+          </p:cNvPr>
+          <p:cNvPicPr>
+            <a:picLocks noChangeAspect="1"/>
+          </p:cNvPicPr>
+          <p:nvPr/>
+        </p:nvPicPr>
+        <p:blipFill>
+          <a:blip r:embed="rId2">
+            <a:extLst>
+              <a:ext uri="{96DAC541-7B7A-43D3-8B79-37D633B846F1}">
+                <asvg:svgBlip xmlns:asvg="http://schemas.microsoft.com/office/drawing/2016/SVG/main" r:embed="rId3"/>
+              </a:ext>
+            </a:extLst>
+          </a:blip>
+          <a:stretch>
+            <a:fillRect/>
+          </a:stretch>
+        </p:blipFill>
+        <p:spPr>
+          <a:xfrm>
+            <a:off x="5220903" y="775952"/>
+            <a:ext cx="6858000" cy="6858000"/>
+          </a:xfrm>
+          <a:prstGeom prst="rect">
+            <a:avLst/>
+          </a:prstGeom>
+        </p:spPr>
+      </p:pic>
+      <p:pic>
+        <p:nvPicPr>
+          <p:cNvPr id="7" name="Ábra 6">
+            <a:extLst>
+              <a:ext uri="{FF2B5EF4-FFF2-40B4-BE49-F238E27FC236}">
+                <a16:creationId xmlns:a16="http://schemas.microsoft.com/office/drawing/2014/main" id="{9100729D-17BC-81CD-C488-44CCAC92A6E8}"/>
+              </a:ext>
+            </a:extLst>
+          </p:cNvPr>
+          <p:cNvPicPr>
+            <a:picLocks noChangeAspect="1"/>
+          </p:cNvPicPr>
+          <p:nvPr/>
+        </p:nvPicPr>
+        <p:blipFill>
+          <a:blip r:embed="rId4">
+            <a:extLst>
+              <a:ext uri="{96DAC541-7B7A-43D3-8B79-37D633B846F1}">
+                <asvg:svgBlip xmlns:asvg="http://schemas.microsoft.com/office/drawing/2016/SVG/main" r:embed="rId5"/>
+              </a:ext>
+            </a:extLst>
+          </a:blip>
+          <a:stretch>
+            <a:fillRect/>
+          </a:stretch>
+        </p:blipFill>
+        <p:spPr>
+          <a:xfrm>
+            <a:off x="-420710" y="775952"/>
+            <a:ext cx="6858000" cy="6858000"/>
+          </a:xfrm>
+          <a:prstGeom prst="rect">
+            <a:avLst/>
+          </a:prstGeom>
+        </p:spPr>
+      </p:pic>
+    </p:spTree>
+    <p:extLst>
+      <p:ext uri="{BB962C8B-B14F-4D97-AF65-F5344CB8AC3E}">
+        <p14:creationId xmlns:p14="http://schemas.microsoft.com/office/powerpoint/2010/main" val="3588338528"/>
+      </p:ext>
+    </p:extLst>
+  </p:cSld>
+  <p:clrMapOvr>
+    <a:masterClrMapping/>
+  </p:clrMapOvr>
+</p:sld>
+</file>
+
+<file path=ppt/slides/slide9.xml><?xml version="1.0" encoding="utf-8"?>
+<p:sld xmlns:a="http://schemas.openxmlformats.org/drawingml/2006/main" xmlns:r="http://schemas.openxmlformats.org/officeDocument/2006/relationships" xmlns:p="http://schemas.openxmlformats.org/presentationml/2006/main">
+  <p:cSld>
+    <p:spTree>
+      <p:nvGrpSpPr>
+        <p:cNvPr id="1" name=""/>
+        <p:cNvGrpSpPr/>
+        <p:nvPr/>
+      </p:nvGrpSpPr>
+      <p:grpSpPr>
+        <a:xfrm>
+          <a:off x="0" y="0"/>
+          <a:ext cx="0" cy="0"/>
+          <a:chOff x="0" y="0"/>
+          <a:chExt cx="0" cy="0"/>
+        </a:xfrm>
+      </p:grpSpPr>
+      <p:sp>
+        <p:nvSpPr>
+          <p:cNvPr id="2" name="Cím 1">
+            <a:extLst>
+              <a:ext uri="{FF2B5EF4-FFF2-40B4-BE49-F238E27FC236}">
+                <a16:creationId xmlns:a16="http://schemas.microsoft.com/office/drawing/2014/main" id="{E5B99551-B982-2EFF-9B9A-BBDAF6056BB4}"/>
+              </a:ext>
+            </a:extLst>
+          </p:cNvPr>
+          <p:cNvSpPr>
+            <a:spLocks noGrp="1"/>
+          </p:cNvSpPr>
+          <p:nvPr>
+            <p:ph type="title"/>
+          </p:nvPr>
+        </p:nvSpPr>
+        <p:spPr/>
+        <p:txBody>
+          <a:bodyPr/>
+          <a:lstStyle/>
+          <a:p>
+            <a:r>
+              <a:rPr lang="hu-HU" dirty="0">
+                <a:latin typeface="Montserrat" panose="00000500000000000000" pitchFamily="2" charset="-18"/>
+              </a:rPr>
+              <a:t>Színpaletta</a:t>
+            </a:r>
+          </a:p>
+        </p:txBody>
+      </p:sp>
+      <p:sp>
+        <p:nvSpPr>
+          <p:cNvPr id="4" name="Freeform 5">
+            <a:extLst>
+              <a:ext uri="{FF2B5EF4-FFF2-40B4-BE49-F238E27FC236}">
+                <a16:creationId xmlns:a16="http://schemas.microsoft.com/office/drawing/2014/main" id="{613DC5CD-693B-E391-B34B-7CD5D5976E8D}"/>
+              </a:ext>
+            </a:extLst>
+          </p:cNvPr>
+          <p:cNvSpPr>
+            <a:spLocks/>
+          </p:cNvSpPr>
+          <p:nvPr/>
+        </p:nvSpPr>
+        <p:spPr bwMode="auto">
+          <a:xfrm>
+            <a:off x="1236761" y="2348331"/>
+            <a:ext cx="1704568" cy="1704568"/>
+          </a:xfrm>
+          <a:custGeom>
+            <a:avLst/>
+            <a:gdLst>
+              <a:gd name="T0" fmla="*/ 892 w 1784"/>
+              <a:gd name="T1" fmla="*/ 1784 h 1784"/>
+              <a:gd name="T2" fmla="*/ 261 w 1784"/>
+              <a:gd name="T3" fmla="*/ 1522 h 1784"/>
+              <a:gd name="T4" fmla="*/ 0 w 1784"/>
+              <a:gd name="T5" fmla="*/ 892 h 1784"/>
+              <a:gd name="T6" fmla="*/ 261 w 1784"/>
+              <a:gd name="T7" fmla="*/ 261 h 1784"/>
+              <a:gd name="T8" fmla="*/ 892 w 1784"/>
+              <a:gd name="T9" fmla="*/ 0 h 1784"/>
+              <a:gd name="T10" fmla="*/ 1523 w 1784"/>
+              <a:gd name="T11" fmla="*/ 261 h 1784"/>
+              <a:gd name="T12" fmla="*/ 1784 w 1784"/>
+              <a:gd name="T13" fmla="*/ 892 h 1784"/>
+              <a:gd name="T14" fmla="*/ 1523 w 1784"/>
+              <a:gd name="T15" fmla="*/ 1522 h 1784"/>
+              <a:gd name="T16" fmla="*/ 892 w 1784"/>
+              <a:gd name="T17" fmla="*/ 1784 h 1784"/>
+            </a:gdLst>
+            <a:ahLst/>
+            <a:cxnLst>
+              <a:cxn ang="0">
+                <a:pos x="T0" y="T1"/>
+              </a:cxn>
+              <a:cxn ang="0">
+                <a:pos x="T2" y="T3"/>
+              </a:cxn>
+              <a:cxn ang="0">
+                <a:pos x="T4" y="T5"/>
+              </a:cxn>
+              <a:cxn ang="0">
+                <a:pos x="T6" y="T7"/>
+              </a:cxn>
+              <a:cxn ang="0">
+                <a:pos x="T8" y="T9"/>
+              </a:cxn>
+              <a:cxn ang="0">
+                <a:pos x="T10" y="T11"/>
+              </a:cxn>
+              <a:cxn ang="0">
+                <a:pos x="T12" y="T13"/>
+              </a:cxn>
+              <a:cxn ang="0">
+                <a:pos x="T14" y="T15"/>
+              </a:cxn>
+              <a:cxn ang="0">
+                <a:pos x="T16" y="T17"/>
+              </a:cxn>
+            </a:cxnLst>
+            <a:rect l="0" t="0" r="r" b="b"/>
+            <a:pathLst>
+              <a:path w="1784" h="1784">
+                <a:moveTo>
+                  <a:pt x="892" y="1784"/>
+                </a:moveTo>
+                <a:cubicBezTo>
+                  <a:pt x="654" y="1784"/>
+                  <a:pt x="430" y="1691"/>
+                  <a:pt x="261" y="1522"/>
+                </a:cubicBezTo>
+                <a:cubicBezTo>
+                  <a:pt x="93" y="1354"/>
+                  <a:pt x="0" y="1130"/>
+                  <a:pt x="0" y="892"/>
+                </a:cubicBezTo>
+                <a:cubicBezTo>
+                  <a:pt x="0" y="654"/>
+                  <a:pt x="93" y="430"/>
+                  <a:pt x="261" y="261"/>
+                </a:cubicBezTo>
+                <a:cubicBezTo>
+                  <a:pt x="430" y="93"/>
+                  <a:pt x="654" y="0"/>
+                  <a:pt x="892" y="0"/>
+                </a:cubicBezTo>
+                <a:cubicBezTo>
+                  <a:pt x="1130" y="0"/>
+                  <a:pt x="1354" y="93"/>
+                  <a:pt x="1523" y="261"/>
+                </a:cubicBezTo>
+                <a:cubicBezTo>
+                  <a:pt x="1691" y="430"/>
+                  <a:pt x="1784" y="654"/>
+                  <a:pt x="1784" y="892"/>
+                </a:cubicBezTo>
+                <a:cubicBezTo>
+                  <a:pt x="1784" y="1130"/>
+                  <a:pt x="1691" y="1354"/>
+                  <a:pt x="1523" y="1522"/>
+                </a:cubicBezTo>
+                <a:cubicBezTo>
+                  <a:pt x="1354" y="1691"/>
+                  <a:pt x="1130" y="1784"/>
+                  <a:pt x="892" y="1784"/>
+                </a:cubicBezTo>
+                <a:close/>
+              </a:path>
+            </a:pathLst>
+          </a:custGeom>
+          <a:solidFill>
+            <a:schemeClr val="bg1"/>
+          </a:solidFill>
+          <a:ln>
+            <a:noFill/>
+          </a:ln>
+          <a:effectLst>
+            <a:outerShdw blurRad="152400" sx="102000" sy="102000" algn="ctr" rotWithShape="0">
+              <a:prstClr val="black">
+                <a:alpha val="10000"/>
+              </a:prstClr>
+            </a:outerShdw>
+          </a:effectLst>
+        </p:spPr>
+        <p:style>
+          <a:lnRef idx="2">
+            <a:schemeClr val="accent1">
+              <a:shade val="50000"/>
+            </a:schemeClr>
+          </a:lnRef>
+          <a:fillRef idx="1">
+            <a:schemeClr val="accent1"/>
+          </a:fillRef>
+          <a:effectRef idx="0">
+            <a:schemeClr val="accent1"/>
+          </a:effectRef>
+          <a:fontRef idx="minor">
+            <a:schemeClr val="lt1"/>
+          </a:fontRef>
+        </p:style>
+        <p:txBody>
+          <a:bodyPr rtlCol="0" anchor="ctr"/>
+          <a:lstStyle/>
+          <a:p>
+            <a:pPr algn="ctr"/>
+            <a:endParaRPr lang="en-US">
+              <a:solidFill>
+                <a:schemeClr val="tx1"/>
+              </a:solidFill>
+            </a:endParaRPr>
+          </a:p>
+        </p:txBody>
+      </p:sp>
+      <p:sp>
+        <p:nvSpPr>
+          <p:cNvPr id="5" name="Oval 45">
+            <a:extLst>
+              <a:ext uri="{FF2B5EF4-FFF2-40B4-BE49-F238E27FC236}">
+                <a16:creationId xmlns:a16="http://schemas.microsoft.com/office/drawing/2014/main" id="{95FAE627-E920-70B1-3A3A-ED91CE894040}"/>
+              </a:ext>
+            </a:extLst>
+          </p:cNvPr>
+          <p:cNvSpPr/>
+          <p:nvPr/>
+        </p:nvSpPr>
+        <p:spPr>
+          <a:xfrm>
+            <a:off x="1388295" y="2498173"/>
+            <a:ext cx="1401500" cy="1401500"/>
+          </a:xfrm>
+          <a:prstGeom prst="ellipse">
+            <a:avLst/>
+          </a:prstGeom>
+          <a:solidFill>
+            <a:schemeClr val="bg1"/>
+          </a:solidFill>
+          <a:ln>
+            <a:noFill/>
+          </a:ln>
+          <a:effectLst>
+            <a:outerShdw blurRad="152400" sx="102000" sy="102000" algn="ctr" rotWithShape="0">
+              <a:prstClr val="black">
+                <a:alpha val="10000"/>
+              </a:prstClr>
+            </a:outerShdw>
+          </a:effectLst>
+        </p:spPr>
+        <p:style>
+          <a:lnRef idx="2">
+            <a:schemeClr val="accent1">
+              <a:shade val="50000"/>
+            </a:schemeClr>
+          </a:lnRef>
+          <a:fillRef idx="1">
+            <a:schemeClr val="accent1"/>
+          </a:fillRef>
+          <a:effectRef idx="0">
+            <a:schemeClr val="accent1"/>
+          </a:effectRef>
+          <a:fontRef idx="minor">
+            <a:schemeClr val="lt1"/>
+          </a:fontRef>
+        </p:style>
+        <p:txBody>
+          <a:bodyPr rtlCol="0" anchor="ctr"/>
+          <a:lstStyle/>
+          <a:p>
+            <a:pPr algn="ctr"/>
+            <a:endParaRPr lang="en-US">
+              <a:solidFill>
+                <a:schemeClr val="tx1"/>
+              </a:solidFill>
+            </a:endParaRPr>
+          </a:p>
+        </p:txBody>
+      </p:sp>
+      <p:sp>
+        <p:nvSpPr>
+          <p:cNvPr id="6" name="Oval 49">
+            <a:extLst>
+              <a:ext uri="{FF2B5EF4-FFF2-40B4-BE49-F238E27FC236}">
+                <a16:creationId xmlns:a16="http://schemas.microsoft.com/office/drawing/2014/main" id="{1BAD7F67-1ECA-752F-40B6-89AA75F91AE2}"/>
+              </a:ext>
+            </a:extLst>
+          </p:cNvPr>
+          <p:cNvSpPr/>
+          <p:nvPr/>
+        </p:nvSpPr>
+        <p:spPr>
+          <a:xfrm>
+            <a:off x="1531908" y="2641786"/>
+            <a:ext cx="1114274" cy="1114274"/>
+          </a:xfrm>
+          <a:prstGeom prst="ellipse">
+            <a:avLst/>
+          </a:prstGeom>
+          <a:solidFill>
+            <a:schemeClr val="tx1"/>
+          </a:solidFill>
+          <a:ln>
+            <a:solidFill>
+              <a:schemeClr val="tx1"/>
+            </a:solidFill>
+          </a:ln>
+        </p:spPr>
+        <p:style>
+          <a:lnRef idx="2">
+            <a:schemeClr val="accent1">
+              <a:shade val="50000"/>
+            </a:schemeClr>
+          </a:lnRef>
+          <a:fillRef idx="1">
+            <a:schemeClr val="accent1"/>
+          </a:fillRef>
+          <a:effectRef idx="0">
+            <a:schemeClr val="accent1"/>
+          </a:effectRef>
+          <a:fontRef idx="minor">
+            <a:schemeClr val="lt1"/>
+          </a:fontRef>
+        </p:style>
+        <p:txBody>
+          <a:bodyPr rtlCol="0" anchor="ctr"/>
+          <a:lstStyle/>
+          <a:p>
+            <a:pPr algn="ctr"/>
+            <a:endParaRPr lang="en-US"/>
+          </a:p>
+        </p:txBody>
+      </p:sp>
+      <p:sp>
+        <p:nvSpPr>
+          <p:cNvPr id="7" name="Freeform 5">
+            <a:extLst>
+              <a:ext uri="{FF2B5EF4-FFF2-40B4-BE49-F238E27FC236}">
+                <a16:creationId xmlns:a16="http://schemas.microsoft.com/office/drawing/2014/main" id="{FFC88AED-0705-0A6F-B537-F4F2F3FA4785}"/>
+              </a:ext>
+            </a:extLst>
+          </p:cNvPr>
+          <p:cNvSpPr>
+            <a:spLocks/>
+          </p:cNvSpPr>
+          <p:nvPr/>
+        </p:nvSpPr>
+        <p:spPr bwMode="auto">
+          <a:xfrm>
+            <a:off x="3240239" y="2346638"/>
+            <a:ext cx="1704568" cy="1704568"/>
+          </a:xfrm>
+          <a:custGeom>
+            <a:avLst/>
+            <a:gdLst>
+              <a:gd name="T0" fmla="*/ 892 w 1784"/>
+              <a:gd name="T1" fmla="*/ 1784 h 1784"/>
+              <a:gd name="T2" fmla="*/ 261 w 1784"/>
+              <a:gd name="T3" fmla="*/ 1522 h 1784"/>
+              <a:gd name="T4" fmla="*/ 0 w 1784"/>
+              <a:gd name="T5" fmla="*/ 892 h 1784"/>
+              <a:gd name="T6" fmla="*/ 261 w 1784"/>
+              <a:gd name="T7" fmla="*/ 261 h 1784"/>
+              <a:gd name="T8" fmla="*/ 892 w 1784"/>
+              <a:gd name="T9" fmla="*/ 0 h 1784"/>
+              <a:gd name="T10" fmla="*/ 1523 w 1784"/>
+              <a:gd name="T11" fmla="*/ 261 h 1784"/>
+              <a:gd name="T12" fmla="*/ 1784 w 1784"/>
+              <a:gd name="T13" fmla="*/ 892 h 1784"/>
+              <a:gd name="T14" fmla="*/ 1523 w 1784"/>
+              <a:gd name="T15" fmla="*/ 1522 h 1784"/>
+              <a:gd name="T16" fmla="*/ 892 w 1784"/>
+              <a:gd name="T17" fmla="*/ 1784 h 1784"/>
+            </a:gdLst>
+            <a:ahLst/>
+            <a:cxnLst>
+              <a:cxn ang="0">
+                <a:pos x="T0" y="T1"/>
+              </a:cxn>
+              <a:cxn ang="0">
+                <a:pos x="T2" y="T3"/>
+              </a:cxn>
+              <a:cxn ang="0">
+                <a:pos x="T4" y="T5"/>
+              </a:cxn>
+              <a:cxn ang="0">
+                <a:pos x="T6" y="T7"/>
+              </a:cxn>
+              <a:cxn ang="0">
+                <a:pos x="T8" y="T9"/>
+              </a:cxn>
+              <a:cxn ang="0">
+                <a:pos x="T10" y="T11"/>
+              </a:cxn>
+              <a:cxn ang="0">
+                <a:pos x="T12" y="T13"/>
+              </a:cxn>
+              <a:cxn ang="0">
+                <a:pos x="T14" y="T15"/>
+              </a:cxn>
+              <a:cxn ang="0">
+                <a:pos x="T16" y="T17"/>
+              </a:cxn>
+            </a:cxnLst>
+            <a:rect l="0" t="0" r="r" b="b"/>
+            <a:pathLst>
+              <a:path w="1784" h="1784">
+                <a:moveTo>
+                  <a:pt x="892" y="1784"/>
+                </a:moveTo>
+                <a:cubicBezTo>
+                  <a:pt x="654" y="1784"/>
+                  <a:pt x="430" y="1691"/>
+                  <a:pt x="261" y="1522"/>
+                </a:cubicBezTo>
+                <a:cubicBezTo>
+                  <a:pt x="93" y="1354"/>
+                  <a:pt x="0" y="1130"/>
+                  <a:pt x="0" y="892"/>
+                </a:cubicBezTo>
+                <a:cubicBezTo>
+                  <a:pt x="0" y="654"/>
+                  <a:pt x="93" y="430"/>
+                  <a:pt x="261" y="261"/>
+                </a:cubicBezTo>
+                <a:cubicBezTo>
+                  <a:pt x="430" y="93"/>
+                  <a:pt x="654" y="0"/>
+                  <a:pt x="892" y="0"/>
+                </a:cubicBezTo>
+                <a:cubicBezTo>
+                  <a:pt x="1130" y="0"/>
+                  <a:pt x="1354" y="93"/>
+                  <a:pt x="1523" y="261"/>
+                </a:cubicBezTo>
+                <a:cubicBezTo>
+                  <a:pt x="1691" y="430"/>
+                  <a:pt x="1784" y="654"/>
+                  <a:pt x="1784" y="892"/>
+                </a:cubicBezTo>
+                <a:cubicBezTo>
+                  <a:pt x="1784" y="1130"/>
+                  <a:pt x="1691" y="1354"/>
+                  <a:pt x="1523" y="1522"/>
+                </a:cubicBezTo>
+                <a:cubicBezTo>
+                  <a:pt x="1354" y="1691"/>
+                  <a:pt x="1130" y="1784"/>
+                  <a:pt x="892" y="1784"/>
+                </a:cubicBezTo>
+                <a:close/>
+              </a:path>
+            </a:pathLst>
+          </a:custGeom>
+          <a:solidFill>
+            <a:schemeClr val="bg1"/>
+          </a:solidFill>
+          <a:ln>
+            <a:noFill/>
+          </a:ln>
+          <a:effectLst>
+            <a:outerShdw blurRad="152400" sx="102000" sy="102000" algn="ctr" rotWithShape="0">
+              <a:prstClr val="black">
+                <a:alpha val="10000"/>
+              </a:prstClr>
+            </a:outerShdw>
+          </a:effectLst>
+        </p:spPr>
+        <p:style>
+          <a:lnRef idx="2">
+            <a:schemeClr val="accent1">
+              <a:shade val="50000"/>
+            </a:schemeClr>
+          </a:lnRef>
+          <a:fillRef idx="1">
+            <a:schemeClr val="accent1"/>
+          </a:fillRef>
+          <a:effectRef idx="0">
+            <a:schemeClr val="accent1"/>
+          </a:effectRef>
+          <a:fontRef idx="minor">
+            <a:schemeClr val="lt1"/>
+          </a:fontRef>
+        </p:style>
+        <p:txBody>
+          <a:bodyPr rtlCol="0" anchor="ctr"/>
+          <a:lstStyle/>
+          <a:p>
+            <a:pPr algn="ctr"/>
+            <a:endParaRPr lang="en-US">
+              <a:solidFill>
+                <a:schemeClr val="tx1"/>
+              </a:solidFill>
+            </a:endParaRPr>
+          </a:p>
+        </p:txBody>
+      </p:sp>
+      <p:sp>
+        <p:nvSpPr>
+          <p:cNvPr id="8" name="Oval 51">
+            <a:extLst>
+              <a:ext uri="{FF2B5EF4-FFF2-40B4-BE49-F238E27FC236}">
+                <a16:creationId xmlns:a16="http://schemas.microsoft.com/office/drawing/2014/main" id="{43C9236F-42D7-0915-3CBE-B2CB04291EC9}"/>
+              </a:ext>
+            </a:extLst>
+          </p:cNvPr>
+          <p:cNvSpPr/>
+          <p:nvPr/>
+        </p:nvSpPr>
+        <p:spPr>
+          <a:xfrm>
+            <a:off x="3391773" y="2496480"/>
+            <a:ext cx="1401500" cy="1401500"/>
+          </a:xfrm>
+          <a:prstGeom prst="ellipse">
+            <a:avLst/>
+          </a:prstGeom>
+          <a:solidFill>
+            <a:schemeClr val="bg1"/>
+          </a:solidFill>
+          <a:ln>
+            <a:noFill/>
+          </a:ln>
+          <a:effectLst>
+            <a:outerShdw blurRad="152400" sx="102000" sy="102000" algn="ctr" rotWithShape="0">
+              <a:prstClr val="black">
+                <a:alpha val="10000"/>
+              </a:prstClr>
+            </a:outerShdw>
+          </a:effectLst>
+        </p:spPr>
+        <p:style>
+          <a:lnRef idx="2">
+            <a:schemeClr val="accent1">
+              <a:shade val="50000"/>
+            </a:schemeClr>
+          </a:lnRef>
+          <a:fillRef idx="1">
+            <a:schemeClr val="accent1"/>
+          </a:fillRef>
+          <a:effectRef idx="0">
+            <a:schemeClr val="accent1"/>
+          </a:effectRef>
+          <a:fontRef idx="minor">
+            <a:schemeClr val="lt1"/>
+          </a:fontRef>
+        </p:style>
+        <p:txBody>
+          <a:bodyPr rtlCol="0" anchor="ctr"/>
+          <a:lstStyle/>
+          <a:p>
+            <a:pPr algn="ctr"/>
+            <a:endParaRPr lang="en-US">
+              <a:solidFill>
+                <a:schemeClr val="tx1"/>
+              </a:solidFill>
+            </a:endParaRPr>
+          </a:p>
+        </p:txBody>
+      </p:sp>
+      <p:sp>
+        <p:nvSpPr>
+          <p:cNvPr id="9" name="Oval 52">
+            <a:extLst>
+              <a:ext uri="{FF2B5EF4-FFF2-40B4-BE49-F238E27FC236}">
+                <a16:creationId xmlns:a16="http://schemas.microsoft.com/office/drawing/2014/main" id="{031D03D0-D9CA-9F7A-EFC1-012B76E1639D}"/>
+              </a:ext>
+            </a:extLst>
+          </p:cNvPr>
+          <p:cNvSpPr/>
+          <p:nvPr/>
+        </p:nvSpPr>
+        <p:spPr>
+          <a:xfrm>
+            <a:off x="3535386" y="2640093"/>
+            <a:ext cx="1114274" cy="1114274"/>
+          </a:xfrm>
+          <a:prstGeom prst="ellipse">
+            <a:avLst/>
+          </a:prstGeom>
+          <a:solidFill>
+            <a:schemeClr val="bg1"/>
+          </a:solidFill>
+          <a:ln>
+            <a:solidFill>
+              <a:schemeClr val="tx1"/>
+            </a:solidFill>
+          </a:ln>
+        </p:spPr>
+        <p:style>
+          <a:lnRef idx="2">
+            <a:schemeClr val="accent1">
+              <a:shade val="50000"/>
+            </a:schemeClr>
+          </a:lnRef>
+          <a:fillRef idx="1">
+            <a:schemeClr val="accent1"/>
+          </a:fillRef>
+          <a:effectRef idx="0">
+            <a:schemeClr val="accent1"/>
+          </a:effectRef>
+          <a:fontRef idx="minor">
+            <a:schemeClr val="lt1"/>
+          </a:fontRef>
+        </p:style>
+        <p:txBody>
+          <a:bodyPr rtlCol="0" anchor="ctr"/>
+          <a:lstStyle/>
+          <a:p>
+            <a:pPr algn="ctr"/>
+            <a:endParaRPr lang="en-US"/>
+          </a:p>
+        </p:txBody>
+      </p:sp>
+      <p:sp>
+        <p:nvSpPr>
+          <p:cNvPr id="10" name="Freeform 5">
+            <a:extLst>
+              <a:ext uri="{FF2B5EF4-FFF2-40B4-BE49-F238E27FC236}">
+                <a16:creationId xmlns:a16="http://schemas.microsoft.com/office/drawing/2014/main" id="{45D8553C-C699-2367-1D09-430E918428D4}"/>
+              </a:ext>
+            </a:extLst>
+          </p:cNvPr>
+          <p:cNvSpPr>
+            <a:spLocks/>
+          </p:cNvSpPr>
+          <p:nvPr/>
+        </p:nvSpPr>
+        <p:spPr bwMode="auto">
+          <a:xfrm>
+            <a:off x="7247195" y="2343253"/>
+            <a:ext cx="1704568" cy="1704568"/>
+          </a:xfrm>
+          <a:custGeom>
+            <a:avLst/>
+            <a:gdLst>
+              <a:gd name="T0" fmla="*/ 892 w 1784"/>
+              <a:gd name="T1" fmla="*/ 1784 h 1784"/>
+              <a:gd name="T2" fmla="*/ 261 w 1784"/>
+              <a:gd name="T3" fmla="*/ 1522 h 1784"/>
+              <a:gd name="T4" fmla="*/ 0 w 1784"/>
+              <a:gd name="T5" fmla="*/ 892 h 1784"/>
+              <a:gd name="T6" fmla="*/ 261 w 1784"/>
+              <a:gd name="T7" fmla="*/ 261 h 1784"/>
+              <a:gd name="T8" fmla="*/ 892 w 1784"/>
+              <a:gd name="T9" fmla="*/ 0 h 1784"/>
+              <a:gd name="T10" fmla="*/ 1523 w 1784"/>
+              <a:gd name="T11" fmla="*/ 261 h 1784"/>
+              <a:gd name="T12" fmla="*/ 1784 w 1784"/>
+              <a:gd name="T13" fmla="*/ 892 h 1784"/>
+              <a:gd name="T14" fmla="*/ 1523 w 1784"/>
+              <a:gd name="T15" fmla="*/ 1522 h 1784"/>
+              <a:gd name="T16" fmla="*/ 892 w 1784"/>
+              <a:gd name="T17" fmla="*/ 1784 h 1784"/>
+            </a:gdLst>
+            <a:ahLst/>
+            <a:cxnLst>
+              <a:cxn ang="0">
+                <a:pos x="T0" y="T1"/>
+              </a:cxn>
+              <a:cxn ang="0">
+                <a:pos x="T2" y="T3"/>
+              </a:cxn>
+              <a:cxn ang="0">
+                <a:pos x="T4" y="T5"/>
+              </a:cxn>
+              <a:cxn ang="0">
+                <a:pos x="T6" y="T7"/>
+              </a:cxn>
+              <a:cxn ang="0">
+                <a:pos x="T8" y="T9"/>
+              </a:cxn>
+              <a:cxn ang="0">
+                <a:pos x="T10" y="T11"/>
+              </a:cxn>
+              <a:cxn ang="0">
+                <a:pos x="T12" y="T13"/>
+              </a:cxn>
+              <a:cxn ang="0">
+                <a:pos x="T14" y="T15"/>
+              </a:cxn>
+              <a:cxn ang="0">
+                <a:pos x="T16" y="T17"/>
+              </a:cxn>
+            </a:cxnLst>
+            <a:rect l="0" t="0" r="r" b="b"/>
+            <a:pathLst>
+              <a:path w="1784" h="1784">
+                <a:moveTo>
+                  <a:pt x="892" y="1784"/>
+                </a:moveTo>
+                <a:cubicBezTo>
+                  <a:pt x="654" y="1784"/>
+                  <a:pt x="430" y="1691"/>
+                  <a:pt x="261" y="1522"/>
+                </a:cubicBezTo>
+                <a:cubicBezTo>
+                  <a:pt x="93" y="1354"/>
+                  <a:pt x="0" y="1130"/>
+                  <a:pt x="0" y="892"/>
+                </a:cubicBezTo>
+                <a:cubicBezTo>
+                  <a:pt x="0" y="654"/>
+                  <a:pt x="93" y="430"/>
+                  <a:pt x="261" y="261"/>
+                </a:cubicBezTo>
+                <a:cubicBezTo>
+                  <a:pt x="430" y="93"/>
+                  <a:pt x="654" y="0"/>
+                  <a:pt x="892" y="0"/>
+                </a:cubicBezTo>
+                <a:cubicBezTo>
+                  <a:pt x="1130" y="0"/>
+                  <a:pt x="1354" y="93"/>
+                  <a:pt x="1523" y="261"/>
+                </a:cubicBezTo>
+                <a:cubicBezTo>
+                  <a:pt x="1691" y="430"/>
+                  <a:pt x="1784" y="654"/>
+                  <a:pt x="1784" y="892"/>
+                </a:cubicBezTo>
+                <a:cubicBezTo>
+                  <a:pt x="1784" y="1130"/>
+                  <a:pt x="1691" y="1354"/>
+                  <a:pt x="1523" y="1522"/>
+                </a:cubicBezTo>
+                <a:cubicBezTo>
+                  <a:pt x="1354" y="1691"/>
+                  <a:pt x="1130" y="1784"/>
+                  <a:pt x="892" y="1784"/>
+                </a:cubicBezTo>
+                <a:close/>
+              </a:path>
+            </a:pathLst>
+          </a:custGeom>
+          <a:solidFill>
+            <a:schemeClr val="bg1"/>
+          </a:solidFill>
+          <a:ln>
+            <a:noFill/>
+          </a:ln>
+          <a:effectLst>
+            <a:outerShdw blurRad="152400" sx="102000" sy="102000" algn="ctr" rotWithShape="0">
+              <a:prstClr val="black">
+                <a:alpha val="10000"/>
+              </a:prstClr>
+            </a:outerShdw>
+          </a:effectLst>
+        </p:spPr>
+        <p:style>
+          <a:lnRef idx="2">
+            <a:schemeClr val="accent1">
+              <a:shade val="50000"/>
+            </a:schemeClr>
+          </a:lnRef>
+          <a:fillRef idx="1">
+            <a:schemeClr val="accent1"/>
+          </a:fillRef>
+          <a:effectRef idx="0">
+            <a:schemeClr val="accent1"/>
+          </a:effectRef>
+          <a:fontRef idx="minor">
+            <a:schemeClr val="lt1"/>
+          </a:fontRef>
+        </p:style>
+        <p:txBody>
+          <a:bodyPr rtlCol="0" anchor="ctr"/>
+          <a:lstStyle/>
+          <a:p>
+            <a:pPr algn="ctr"/>
+            <a:endParaRPr lang="en-US">
+              <a:solidFill>
+                <a:schemeClr val="tx1"/>
+              </a:solidFill>
+            </a:endParaRPr>
+          </a:p>
+        </p:txBody>
+      </p:sp>
+      <p:sp>
+        <p:nvSpPr>
+          <p:cNvPr id="11" name="Oval 54">
+            <a:extLst>
+              <a:ext uri="{FF2B5EF4-FFF2-40B4-BE49-F238E27FC236}">
+                <a16:creationId xmlns:a16="http://schemas.microsoft.com/office/drawing/2014/main" id="{CCEC9820-B6A2-4960-C3F0-2010F200D6A7}"/>
+              </a:ext>
+            </a:extLst>
+          </p:cNvPr>
+          <p:cNvSpPr/>
+          <p:nvPr/>
+        </p:nvSpPr>
+        <p:spPr>
+          <a:xfrm>
+            <a:off x="7398729" y="2493095"/>
+            <a:ext cx="1401500" cy="1401500"/>
+          </a:xfrm>
+          <a:prstGeom prst="ellipse">
+            <a:avLst/>
+          </a:prstGeom>
+          <a:solidFill>
+            <a:schemeClr val="bg1"/>
+          </a:solidFill>
+          <a:ln>
+            <a:noFill/>
+          </a:ln>
+          <a:effectLst>
+            <a:outerShdw blurRad="152400" sx="102000" sy="102000" algn="ctr" rotWithShape="0">
+              <a:prstClr val="black">
+                <a:alpha val="10000"/>
+              </a:prstClr>
+            </a:outerShdw>
+          </a:effectLst>
+        </p:spPr>
+        <p:style>
+          <a:lnRef idx="2">
+            <a:schemeClr val="accent1">
+              <a:shade val="50000"/>
+            </a:schemeClr>
+          </a:lnRef>
+          <a:fillRef idx="1">
+            <a:schemeClr val="accent1"/>
+          </a:fillRef>
+          <a:effectRef idx="0">
+            <a:schemeClr val="accent1"/>
+          </a:effectRef>
+          <a:fontRef idx="minor">
+            <a:schemeClr val="lt1"/>
+          </a:fontRef>
+        </p:style>
+        <p:txBody>
+          <a:bodyPr rtlCol="0" anchor="ctr"/>
+          <a:lstStyle/>
+          <a:p>
+            <a:pPr algn="ctr"/>
+            <a:endParaRPr lang="en-US">
+              <a:solidFill>
+                <a:schemeClr val="tx1"/>
+              </a:solidFill>
+            </a:endParaRPr>
+          </a:p>
+        </p:txBody>
+      </p:sp>
+      <p:sp>
+        <p:nvSpPr>
+          <p:cNvPr id="12" name="Oval 55">
+            <a:extLst>
+              <a:ext uri="{FF2B5EF4-FFF2-40B4-BE49-F238E27FC236}">
+                <a16:creationId xmlns:a16="http://schemas.microsoft.com/office/drawing/2014/main" id="{692E475C-BBB3-BDE9-651B-0EE3F2E49533}"/>
+              </a:ext>
+            </a:extLst>
+          </p:cNvPr>
+          <p:cNvSpPr/>
+          <p:nvPr/>
+        </p:nvSpPr>
+        <p:spPr>
+          <a:xfrm>
+            <a:off x="7542342" y="2636708"/>
+            <a:ext cx="1114274" cy="1114274"/>
+          </a:xfrm>
+          <a:prstGeom prst="ellipse">
+            <a:avLst/>
+          </a:prstGeom>
+          <a:solidFill>
+            <a:srgbClr val="00FFFF"/>
+          </a:solidFill>
+          <a:ln>
+            <a:solidFill>
+              <a:srgbClr val="00FFFF"/>
+            </a:solidFill>
+          </a:ln>
+        </p:spPr>
+        <p:style>
+          <a:lnRef idx="2">
+            <a:schemeClr val="accent1">
+              <a:shade val="50000"/>
+            </a:schemeClr>
+          </a:lnRef>
+          <a:fillRef idx="1">
+            <a:schemeClr val="accent1"/>
+          </a:fillRef>
+          <a:effectRef idx="0">
+            <a:schemeClr val="accent1"/>
+          </a:effectRef>
+          <a:fontRef idx="minor">
+            <a:schemeClr val="lt1"/>
+          </a:fontRef>
+        </p:style>
+        <p:txBody>
+          <a:bodyPr rtlCol="0" anchor="ctr"/>
+          <a:lstStyle/>
+          <a:p>
+            <a:pPr algn="ctr"/>
+            <a:endParaRPr lang="en-US"/>
+          </a:p>
+        </p:txBody>
+      </p:sp>
+      <p:sp>
+        <p:nvSpPr>
+          <p:cNvPr id="13" name="Freeform 5">
+            <a:extLst>
+              <a:ext uri="{FF2B5EF4-FFF2-40B4-BE49-F238E27FC236}">
+                <a16:creationId xmlns:a16="http://schemas.microsoft.com/office/drawing/2014/main" id="{DC4322F5-6833-1038-09FF-32C980185417}"/>
+              </a:ext>
+            </a:extLst>
+          </p:cNvPr>
+          <p:cNvSpPr>
+            <a:spLocks/>
+          </p:cNvSpPr>
+          <p:nvPr/>
+        </p:nvSpPr>
+        <p:spPr bwMode="auto">
+          <a:xfrm>
+            <a:off x="9250671" y="2341561"/>
+            <a:ext cx="1704568" cy="1704568"/>
+          </a:xfrm>
+          <a:custGeom>
+            <a:avLst/>
+            <a:gdLst>
+              <a:gd name="T0" fmla="*/ 892 w 1784"/>
+              <a:gd name="T1" fmla="*/ 1784 h 1784"/>
+              <a:gd name="T2" fmla="*/ 261 w 1784"/>
+              <a:gd name="T3" fmla="*/ 1522 h 1784"/>
+              <a:gd name="T4" fmla="*/ 0 w 1784"/>
+              <a:gd name="T5" fmla="*/ 892 h 1784"/>
+              <a:gd name="T6" fmla="*/ 261 w 1784"/>
+              <a:gd name="T7" fmla="*/ 261 h 1784"/>
+              <a:gd name="T8" fmla="*/ 892 w 1784"/>
+              <a:gd name="T9" fmla="*/ 0 h 1784"/>
+              <a:gd name="T10" fmla="*/ 1523 w 1784"/>
+              <a:gd name="T11" fmla="*/ 261 h 1784"/>
+              <a:gd name="T12" fmla="*/ 1784 w 1784"/>
+              <a:gd name="T13" fmla="*/ 892 h 1784"/>
+              <a:gd name="T14" fmla="*/ 1523 w 1784"/>
+              <a:gd name="T15" fmla="*/ 1522 h 1784"/>
+              <a:gd name="T16" fmla="*/ 892 w 1784"/>
+              <a:gd name="T17" fmla="*/ 1784 h 1784"/>
+            </a:gdLst>
+            <a:ahLst/>
+            <a:cxnLst>
+              <a:cxn ang="0">
+                <a:pos x="T0" y="T1"/>
+              </a:cxn>
+              <a:cxn ang="0">
+                <a:pos x="T2" y="T3"/>
+              </a:cxn>
+              <a:cxn ang="0">
+                <a:pos x="T4" y="T5"/>
+              </a:cxn>
+              <a:cxn ang="0">
+                <a:pos x="T6" y="T7"/>
+              </a:cxn>
+              <a:cxn ang="0">
+                <a:pos x="T8" y="T9"/>
+              </a:cxn>
+              <a:cxn ang="0">
+                <a:pos x="T10" y="T11"/>
+              </a:cxn>
+              <a:cxn ang="0">
+                <a:pos x="T12" y="T13"/>
+              </a:cxn>
+              <a:cxn ang="0">
+                <a:pos x="T14" y="T15"/>
+              </a:cxn>
+              <a:cxn ang="0">
+                <a:pos x="T16" y="T17"/>
+              </a:cxn>
+            </a:cxnLst>
+            <a:rect l="0" t="0" r="r" b="b"/>
+            <a:pathLst>
+              <a:path w="1784" h="1784">
+                <a:moveTo>
+                  <a:pt x="892" y="1784"/>
+                </a:moveTo>
+                <a:cubicBezTo>
+                  <a:pt x="654" y="1784"/>
+                  <a:pt x="430" y="1691"/>
+                  <a:pt x="261" y="1522"/>
+                </a:cubicBezTo>
+                <a:cubicBezTo>
+                  <a:pt x="93" y="1354"/>
+                  <a:pt x="0" y="1130"/>
+                  <a:pt x="0" y="892"/>
+                </a:cubicBezTo>
+                <a:cubicBezTo>
+                  <a:pt x="0" y="654"/>
+                  <a:pt x="93" y="430"/>
+                  <a:pt x="261" y="261"/>
+                </a:cubicBezTo>
+                <a:cubicBezTo>
+                  <a:pt x="430" y="93"/>
+                  <a:pt x="654" y="0"/>
+                  <a:pt x="892" y="0"/>
+                </a:cubicBezTo>
+                <a:cubicBezTo>
+                  <a:pt x="1130" y="0"/>
+                  <a:pt x="1354" y="93"/>
+                  <a:pt x="1523" y="261"/>
+                </a:cubicBezTo>
+                <a:cubicBezTo>
+                  <a:pt x="1691" y="430"/>
+                  <a:pt x="1784" y="654"/>
+                  <a:pt x="1784" y="892"/>
+                </a:cubicBezTo>
+                <a:cubicBezTo>
+                  <a:pt x="1784" y="1130"/>
+                  <a:pt x="1691" y="1354"/>
+                  <a:pt x="1523" y="1522"/>
+                </a:cubicBezTo>
+                <a:cubicBezTo>
+                  <a:pt x="1354" y="1691"/>
+                  <a:pt x="1130" y="1784"/>
+                  <a:pt x="892" y="1784"/>
+                </a:cubicBezTo>
+                <a:close/>
+              </a:path>
+            </a:pathLst>
+          </a:custGeom>
+          <a:solidFill>
+            <a:schemeClr val="bg1"/>
+          </a:solidFill>
+          <a:ln>
+            <a:noFill/>
+          </a:ln>
+          <a:effectLst>
+            <a:outerShdw blurRad="152400" sx="102000" sy="102000" algn="ctr" rotWithShape="0">
+              <a:prstClr val="black">
+                <a:alpha val="10000"/>
+              </a:prstClr>
+            </a:outerShdw>
+          </a:effectLst>
+        </p:spPr>
+        <p:style>
+          <a:lnRef idx="2">
+            <a:schemeClr val="accent1">
+              <a:shade val="50000"/>
+            </a:schemeClr>
+          </a:lnRef>
+          <a:fillRef idx="1">
+            <a:schemeClr val="accent1"/>
+          </a:fillRef>
+          <a:effectRef idx="0">
+            <a:schemeClr val="accent1"/>
+          </a:effectRef>
+          <a:fontRef idx="minor">
+            <a:schemeClr val="lt1"/>
+          </a:fontRef>
+        </p:style>
+        <p:txBody>
+          <a:bodyPr rtlCol="0" anchor="ctr"/>
+          <a:lstStyle/>
+          <a:p>
+            <a:pPr algn="ctr"/>
+            <a:endParaRPr lang="en-US">
+              <a:solidFill>
+                <a:schemeClr val="tx1"/>
+              </a:solidFill>
+            </a:endParaRPr>
+          </a:p>
+        </p:txBody>
+      </p:sp>
+      <p:sp>
+        <p:nvSpPr>
+          <p:cNvPr id="14" name="Oval 57">
+            <a:extLst>
+              <a:ext uri="{FF2B5EF4-FFF2-40B4-BE49-F238E27FC236}">
+                <a16:creationId xmlns:a16="http://schemas.microsoft.com/office/drawing/2014/main" id="{ECAE1546-3AB9-9C24-8032-CAEFC35A5EB5}"/>
+              </a:ext>
+            </a:extLst>
+          </p:cNvPr>
+          <p:cNvSpPr/>
+          <p:nvPr/>
+        </p:nvSpPr>
+        <p:spPr>
+          <a:xfrm>
+            <a:off x="9402205" y="2491403"/>
+            <a:ext cx="1401500" cy="1401500"/>
+          </a:xfrm>
+          <a:prstGeom prst="ellipse">
+            <a:avLst/>
+          </a:prstGeom>
+          <a:solidFill>
+            <a:schemeClr val="bg1"/>
+          </a:solidFill>
+          <a:ln>
+            <a:noFill/>
+          </a:ln>
+          <a:effectLst>
+            <a:outerShdw blurRad="152400" sx="102000" sy="102000" algn="ctr" rotWithShape="0">
+              <a:prstClr val="black">
+                <a:alpha val="10000"/>
+              </a:prstClr>
+            </a:outerShdw>
+          </a:effectLst>
+        </p:spPr>
+        <p:style>
+          <a:lnRef idx="2">
+            <a:schemeClr val="accent1">
+              <a:shade val="50000"/>
+            </a:schemeClr>
+          </a:lnRef>
+          <a:fillRef idx="1">
+            <a:schemeClr val="accent1"/>
+          </a:fillRef>
+          <a:effectRef idx="0">
+            <a:schemeClr val="accent1"/>
+          </a:effectRef>
+          <a:fontRef idx="minor">
+            <a:schemeClr val="lt1"/>
+          </a:fontRef>
+        </p:style>
+        <p:txBody>
+          <a:bodyPr rtlCol="0" anchor="ctr"/>
+          <a:lstStyle/>
+          <a:p>
+            <a:pPr algn="ctr"/>
+            <a:endParaRPr lang="en-US">
+              <a:solidFill>
+                <a:schemeClr val="tx1"/>
+              </a:solidFill>
+            </a:endParaRPr>
+          </a:p>
+        </p:txBody>
+      </p:sp>
+      <p:sp>
+        <p:nvSpPr>
+          <p:cNvPr id="15" name="Oval 58">
+            <a:extLst>
+              <a:ext uri="{FF2B5EF4-FFF2-40B4-BE49-F238E27FC236}">
+                <a16:creationId xmlns:a16="http://schemas.microsoft.com/office/drawing/2014/main" id="{45E8685F-E7BC-6B0F-009A-F07423DE2665}"/>
+              </a:ext>
+            </a:extLst>
+          </p:cNvPr>
+          <p:cNvSpPr/>
+          <p:nvPr/>
+        </p:nvSpPr>
+        <p:spPr>
+          <a:xfrm>
+            <a:off x="9545818" y="2635016"/>
+            <a:ext cx="1114274" cy="1114274"/>
+          </a:xfrm>
+          <a:prstGeom prst="ellipse">
+            <a:avLst/>
+          </a:prstGeom>
+          <a:solidFill>
+            <a:srgbClr val="FF00FF"/>
+          </a:solidFill>
+          <a:ln>
+            <a:solidFill>
+              <a:srgbClr val="FF00FF"/>
+            </a:solidFill>
+          </a:ln>
+        </p:spPr>
+        <p:style>
+          <a:lnRef idx="2">
+            <a:schemeClr val="accent1">
+              <a:shade val="50000"/>
+            </a:schemeClr>
+          </a:lnRef>
+          <a:fillRef idx="1">
+            <a:schemeClr val="accent1"/>
+          </a:fillRef>
+          <a:effectRef idx="0">
+            <a:schemeClr val="accent1"/>
+          </a:effectRef>
+          <a:fontRef idx="minor">
+            <a:schemeClr val="lt1"/>
+          </a:fontRef>
+        </p:style>
+        <p:txBody>
+          <a:bodyPr rtlCol="0" anchor="ctr"/>
+          <a:lstStyle/>
+          <a:p>
+            <a:pPr algn="ctr"/>
+            <a:endParaRPr lang="en-US"/>
+          </a:p>
+        </p:txBody>
+      </p:sp>
+      <p:sp>
+        <p:nvSpPr>
+          <p:cNvPr id="16" name="Freeform 5">
+            <a:extLst>
+              <a:ext uri="{FF2B5EF4-FFF2-40B4-BE49-F238E27FC236}">
+                <a16:creationId xmlns:a16="http://schemas.microsoft.com/office/drawing/2014/main" id="{7D5439FC-FE66-4650-D83E-FC8636E76659}"/>
+              </a:ext>
+            </a:extLst>
+          </p:cNvPr>
+          <p:cNvSpPr>
+            <a:spLocks/>
+          </p:cNvSpPr>
+          <p:nvPr/>
+        </p:nvSpPr>
+        <p:spPr bwMode="auto">
+          <a:xfrm>
+            <a:off x="5237588" y="2344946"/>
+            <a:ext cx="1704568" cy="1704568"/>
+          </a:xfrm>
+          <a:custGeom>
+            <a:avLst/>
+            <a:gdLst>
+              <a:gd name="T0" fmla="*/ 892 w 1784"/>
+              <a:gd name="T1" fmla="*/ 1784 h 1784"/>
+              <a:gd name="T2" fmla="*/ 261 w 1784"/>
+              <a:gd name="T3" fmla="*/ 1522 h 1784"/>
+              <a:gd name="T4" fmla="*/ 0 w 1784"/>
+              <a:gd name="T5" fmla="*/ 892 h 1784"/>
+              <a:gd name="T6" fmla="*/ 261 w 1784"/>
+              <a:gd name="T7" fmla="*/ 261 h 1784"/>
+              <a:gd name="T8" fmla="*/ 892 w 1784"/>
+              <a:gd name="T9" fmla="*/ 0 h 1784"/>
+              <a:gd name="T10" fmla="*/ 1523 w 1784"/>
+              <a:gd name="T11" fmla="*/ 261 h 1784"/>
+              <a:gd name="T12" fmla="*/ 1784 w 1784"/>
+              <a:gd name="T13" fmla="*/ 892 h 1784"/>
+              <a:gd name="T14" fmla="*/ 1523 w 1784"/>
+              <a:gd name="T15" fmla="*/ 1522 h 1784"/>
+              <a:gd name="T16" fmla="*/ 892 w 1784"/>
+              <a:gd name="T17" fmla="*/ 1784 h 1784"/>
+            </a:gdLst>
+            <a:ahLst/>
+            <a:cxnLst>
+              <a:cxn ang="0">
+                <a:pos x="T0" y="T1"/>
+              </a:cxn>
+              <a:cxn ang="0">
+                <a:pos x="T2" y="T3"/>
+              </a:cxn>
+              <a:cxn ang="0">
+                <a:pos x="T4" y="T5"/>
+              </a:cxn>
+              <a:cxn ang="0">
+                <a:pos x="T6" y="T7"/>
+              </a:cxn>
+              <a:cxn ang="0">
+                <a:pos x="T8" y="T9"/>
+              </a:cxn>
+              <a:cxn ang="0">
+                <a:pos x="T10" y="T11"/>
+              </a:cxn>
+              <a:cxn ang="0">
+                <a:pos x="T12" y="T13"/>
+              </a:cxn>
+              <a:cxn ang="0">
+                <a:pos x="T14" y="T15"/>
+              </a:cxn>
+              <a:cxn ang="0">
+                <a:pos x="T16" y="T17"/>
+              </a:cxn>
+            </a:cxnLst>
+            <a:rect l="0" t="0" r="r" b="b"/>
+            <a:pathLst>
+              <a:path w="1784" h="1784">
+                <a:moveTo>
+                  <a:pt x="892" y="1784"/>
+                </a:moveTo>
+                <a:cubicBezTo>
+                  <a:pt x="654" y="1784"/>
+                  <a:pt x="430" y="1691"/>
+                  <a:pt x="261" y="1522"/>
+                </a:cubicBezTo>
+                <a:cubicBezTo>
+                  <a:pt x="93" y="1354"/>
+                  <a:pt x="0" y="1130"/>
+                  <a:pt x="0" y="892"/>
+                </a:cubicBezTo>
+                <a:cubicBezTo>
+                  <a:pt x="0" y="654"/>
+                  <a:pt x="93" y="430"/>
+                  <a:pt x="261" y="261"/>
+                </a:cubicBezTo>
+                <a:cubicBezTo>
+                  <a:pt x="430" y="93"/>
+                  <a:pt x="654" y="0"/>
+                  <a:pt x="892" y="0"/>
+                </a:cubicBezTo>
+                <a:cubicBezTo>
+                  <a:pt x="1130" y="0"/>
+                  <a:pt x="1354" y="93"/>
+                  <a:pt x="1523" y="261"/>
+                </a:cubicBezTo>
+                <a:cubicBezTo>
+                  <a:pt x="1691" y="430"/>
+                  <a:pt x="1784" y="654"/>
+                  <a:pt x="1784" y="892"/>
+                </a:cubicBezTo>
+                <a:cubicBezTo>
+                  <a:pt x="1784" y="1130"/>
+                  <a:pt x="1691" y="1354"/>
+                  <a:pt x="1523" y="1522"/>
+                </a:cubicBezTo>
+                <a:cubicBezTo>
+                  <a:pt x="1354" y="1691"/>
+                  <a:pt x="1130" y="1784"/>
+                  <a:pt x="892" y="1784"/>
+                </a:cubicBezTo>
+                <a:close/>
+              </a:path>
+            </a:pathLst>
+          </a:custGeom>
+          <a:solidFill>
+            <a:schemeClr val="bg1"/>
+          </a:solidFill>
+          <a:ln>
+            <a:noFill/>
+          </a:ln>
+          <a:effectLst>
+            <a:outerShdw blurRad="152400" sx="102000" sy="102000" algn="ctr" rotWithShape="0">
+              <a:prstClr val="black">
+                <a:alpha val="10000"/>
+              </a:prstClr>
+            </a:outerShdw>
+          </a:effectLst>
+        </p:spPr>
+        <p:style>
+          <a:lnRef idx="2">
+            <a:schemeClr val="accent1">
+              <a:shade val="50000"/>
+            </a:schemeClr>
+          </a:lnRef>
+          <a:fillRef idx="1">
+            <a:schemeClr val="accent1"/>
+          </a:fillRef>
+          <a:effectRef idx="0">
+            <a:schemeClr val="accent1"/>
+          </a:effectRef>
+          <a:fontRef idx="minor">
+            <a:schemeClr val="lt1"/>
+          </a:fontRef>
+        </p:style>
+        <p:txBody>
+          <a:bodyPr rtlCol="0" anchor="ctr"/>
+          <a:lstStyle/>
+          <a:p>
+            <a:pPr algn="ctr"/>
+            <a:endParaRPr lang="en-US">
+              <a:solidFill>
+                <a:schemeClr val="tx1"/>
+              </a:solidFill>
+            </a:endParaRPr>
+          </a:p>
+        </p:txBody>
+      </p:sp>
+      <p:sp>
+        <p:nvSpPr>
+          <p:cNvPr id="17" name="Oval 60">
+            <a:extLst>
+              <a:ext uri="{FF2B5EF4-FFF2-40B4-BE49-F238E27FC236}">
+                <a16:creationId xmlns:a16="http://schemas.microsoft.com/office/drawing/2014/main" id="{FBD07944-0635-CDD3-C13E-B286FB5209CE}"/>
+              </a:ext>
+            </a:extLst>
+          </p:cNvPr>
+          <p:cNvSpPr/>
+          <p:nvPr/>
+        </p:nvSpPr>
+        <p:spPr>
+          <a:xfrm>
+            <a:off x="5389122" y="2494788"/>
+            <a:ext cx="1401500" cy="1401500"/>
+          </a:xfrm>
+          <a:prstGeom prst="ellipse">
+            <a:avLst/>
+          </a:prstGeom>
+          <a:solidFill>
+            <a:schemeClr val="bg1"/>
+          </a:solidFill>
+          <a:ln>
+            <a:noFill/>
+          </a:ln>
+          <a:effectLst>
+            <a:outerShdw blurRad="152400" sx="102000" sy="102000" algn="ctr" rotWithShape="0">
+              <a:prstClr val="black">
+                <a:alpha val="10000"/>
+              </a:prstClr>
+            </a:outerShdw>
+          </a:effectLst>
+        </p:spPr>
+        <p:style>
+          <a:lnRef idx="2">
+            <a:schemeClr val="accent1">
+              <a:shade val="50000"/>
+            </a:schemeClr>
+          </a:lnRef>
+          <a:fillRef idx="1">
+            <a:schemeClr val="accent1"/>
+          </a:fillRef>
+          <a:effectRef idx="0">
+            <a:schemeClr val="accent1"/>
+          </a:effectRef>
+          <a:fontRef idx="minor">
+            <a:schemeClr val="lt1"/>
+          </a:fontRef>
+        </p:style>
+        <p:txBody>
+          <a:bodyPr rtlCol="0" anchor="ctr"/>
+          <a:lstStyle/>
+          <a:p>
+            <a:pPr algn="ctr"/>
+            <a:endParaRPr lang="en-US">
+              <a:solidFill>
+                <a:schemeClr val="tx1"/>
+              </a:solidFill>
+            </a:endParaRPr>
+          </a:p>
+        </p:txBody>
+      </p:sp>
+      <p:sp>
+        <p:nvSpPr>
+          <p:cNvPr id="18" name="Oval 61">
+            <a:extLst>
+              <a:ext uri="{FF2B5EF4-FFF2-40B4-BE49-F238E27FC236}">
+                <a16:creationId xmlns:a16="http://schemas.microsoft.com/office/drawing/2014/main" id="{18B9EE15-12C2-576F-D907-5D449534B533}"/>
+              </a:ext>
+            </a:extLst>
+          </p:cNvPr>
+          <p:cNvSpPr/>
+          <p:nvPr/>
+        </p:nvSpPr>
+        <p:spPr>
+          <a:xfrm>
+            <a:off x="5532735" y="2638401"/>
+            <a:ext cx="1114274" cy="1114274"/>
+          </a:xfrm>
+          <a:prstGeom prst="ellipse">
+            <a:avLst/>
+          </a:prstGeom>
+          <a:solidFill>
+            <a:srgbClr val="5D28FE"/>
+          </a:solidFill>
+          <a:ln>
+            <a:solidFill>
+              <a:srgbClr val="5D28FE"/>
+            </a:solidFill>
+          </a:ln>
+        </p:spPr>
+        <p:style>
+          <a:lnRef idx="2">
+            <a:schemeClr val="accent1">
+              <a:shade val="50000"/>
+            </a:schemeClr>
+          </a:lnRef>
+          <a:fillRef idx="1">
+            <a:schemeClr val="accent1"/>
+          </a:fillRef>
+          <a:effectRef idx="0">
+            <a:schemeClr val="accent1"/>
+          </a:effectRef>
+          <a:fontRef idx="minor">
+            <a:schemeClr val="lt1"/>
+          </a:fontRef>
+        </p:style>
+        <p:txBody>
+          <a:bodyPr rtlCol="0" anchor="ctr"/>
+          <a:lstStyle/>
+          <a:p>
+            <a:pPr algn="ctr"/>
+            <a:endParaRPr lang="en-US"/>
+          </a:p>
+        </p:txBody>
+      </p:sp>
+      <p:sp>
+        <p:nvSpPr>
+          <p:cNvPr id="99" name="Szövegdoboz 98">
+            <a:extLst>
+              <a:ext uri="{FF2B5EF4-FFF2-40B4-BE49-F238E27FC236}">
+                <a16:creationId xmlns:a16="http://schemas.microsoft.com/office/drawing/2014/main" id="{2E92D029-3B1D-D38C-9006-DEB84121215F}"/>
+              </a:ext>
+            </a:extLst>
+          </p:cNvPr>
+          <p:cNvSpPr txBox="1"/>
+          <p:nvPr/>
+        </p:nvSpPr>
+        <p:spPr>
+          <a:xfrm>
+            <a:off x="1236761" y="4370231"/>
+            <a:ext cx="1704568" cy="369332"/>
+          </a:xfrm>
+          <a:prstGeom prst="rect">
+            <a:avLst/>
+          </a:prstGeom>
+          <a:noFill/>
+        </p:spPr>
+        <p:txBody>
+          <a:bodyPr wrap="square" rtlCol="0">
+            <a:spAutoFit/>
+          </a:bodyPr>
+          <a:lstStyle/>
+          <a:p>
+            <a:pPr algn="ctr"/>
+            <a:r>
+              <a:rPr lang="hu-HU" b="1" dirty="0">
+                <a:latin typeface="Montserrat" panose="00000500000000000000" pitchFamily="2" charset="-18"/>
+              </a:rPr>
+              <a:t>#</a:t>
+            </a:r>
+            <a:r>
+              <a:rPr lang="en-US" b="1" dirty="0">
+                <a:latin typeface="Montserrat" panose="00000500000000000000" pitchFamily="2" charset="-18"/>
+              </a:rPr>
+              <a:t>000000</a:t>
+            </a:r>
+            <a:endParaRPr lang="hu-HU" b="1" dirty="0">
+              <a:latin typeface="Montserrat" panose="00000500000000000000" pitchFamily="2" charset="-18"/>
+            </a:endParaRPr>
+          </a:p>
+        </p:txBody>
+      </p:sp>
+      <p:sp>
+        <p:nvSpPr>
+          <p:cNvPr id="100" name="Szövegdoboz 99">
+            <a:extLst>
+              <a:ext uri="{FF2B5EF4-FFF2-40B4-BE49-F238E27FC236}">
+                <a16:creationId xmlns:a16="http://schemas.microsoft.com/office/drawing/2014/main" id="{4762BF07-2C39-2E9B-8EDE-EB94871F84F9}"/>
+              </a:ext>
+            </a:extLst>
+          </p:cNvPr>
+          <p:cNvSpPr txBox="1"/>
+          <p:nvPr/>
+        </p:nvSpPr>
+        <p:spPr>
+          <a:xfrm>
+            <a:off x="3240239" y="4370231"/>
+            <a:ext cx="1704568" cy="369332"/>
+          </a:xfrm>
+          <a:prstGeom prst="rect">
+            <a:avLst/>
+          </a:prstGeom>
+          <a:noFill/>
+        </p:spPr>
+        <p:txBody>
+          <a:bodyPr wrap="square" rtlCol="0">
+            <a:spAutoFit/>
+          </a:bodyPr>
+          <a:lstStyle/>
+          <a:p>
+            <a:pPr algn="ctr"/>
+            <a:r>
+              <a:rPr lang="hu-HU" b="1" dirty="0">
+                <a:latin typeface="Montserrat" panose="00000500000000000000" pitchFamily="2" charset="-18"/>
+              </a:rPr>
+              <a:t>#</a:t>
+            </a:r>
+            <a:r>
+              <a:rPr lang="en-US" b="1" dirty="0">
+                <a:latin typeface="Montserrat" panose="00000500000000000000" pitchFamily="2" charset="-18"/>
+              </a:rPr>
+              <a:t>FFFFFF</a:t>
+            </a:r>
+            <a:endParaRPr lang="hu-HU" b="1" dirty="0">
+              <a:latin typeface="Montserrat" panose="00000500000000000000" pitchFamily="2" charset="-18"/>
+            </a:endParaRPr>
+          </a:p>
+        </p:txBody>
+      </p:sp>
+      <p:sp>
+        <p:nvSpPr>
+          <p:cNvPr id="101" name="Szövegdoboz 100">
+            <a:extLst>
+              <a:ext uri="{FF2B5EF4-FFF2-40B4-BE49-F238E27FC236}">
+                <a16:creationId xmlns:a16="http://schemas.microsoft.com/office/drawing/2014/main" id="{5F650E00-289C-70B1-8F06-615ECC0EB90A}"/>
+              </a:ext>
+            </a:extLst>
+          </p:cNvPr>
+          <p:cNvSpPr txBox="1"/>
+          <p:nvPr/>
+        </p:nvSpPr>
+        <p:spPr>
+          <a:xfrm>
+            <a:off x="5237588" y="4370231"/>
+            <a:ext cx="1704568" cy="369332"/>
+          </a:xfrm>
+          <a:prstGeom prst="rect">
+            <a:avLst/>
+          </a:prstGeom>
+          <a:noFill/>
+        </p:spPr>
+        <p:txBody>
+          <a:bodyPr wrap="square" rtlCol="0">
+            <a:spAutoFit/>
+          </a:bodyPr>
+          <a:lstStyle/>
+          <a:p>
+            <a:pPr algn="ctr"/>
+            <a:r>
+              <a:rPr lang="hu-HU" b="1" dirty="0">
+                <a:latin typeface="Montserrat" panose="00000500000000000000" pitchFamily="2" charset="-18"/>
+              </a:rPr>
+              <a:t>#</a:t>
+            </a:r>
+            <a:r>
+              <a:rPr lang="en-US" b="1" dirty="0">
+                <a:latin typeface="Montserrat" panose="00000500000000000000" pitchFamily="2" charset="-18"/>
+              </a:rPr>
+              <a:t>5D28FE</a:t>
+            </a:r>
+            <a:endParaRPr lang="hu-HU" b="1" dirty="0">
+              <a:latin typeface="Montserrat" panose="00000500000000000000" pitchFamily="2" charset="-18"/>
+            </a:endParaRPr>
+          </a:p>
+        </p:txBody>
+      </p:sp>
+      <p:sp>
+        <p:nvSpPr>
+          <p:cNvPr id="102" name="Szövegdoboz 101">
+            <a:extLst>
+              <a:ext uri="{FF2B5EF4-FFF2-40B4-BE49-F238E27FC236}">
+                <a16:creationId xmlns:a16="http://schemas.microsoft.com/office/drawing/2014/main" id="{ACA30E87-0C24-0E0A-25A5-27EC084FAE33}"/>
+              </a:ext>
+            </a:extLst>
+          </p:cNvPr>
+          <p:cNvSpPr txBox="1"/>
+          <p:nvPr/>
+        </p:nvSpPr>
+        <p:spPr>
+          <a:xfrm>
+            <a:off x="7247195" y="4370231"/>
+            <a:ext cx="1704568" cy="369332"/>
+          </a:xfrm>
+          <a:prstGeom prst="rect">
+            <a:avLst/>
+          </a:prstGeom>
+          <a:noFill/>
+        </p:spPr>
+        <p:txBody>
+          <a:bodyPr wrap="square" rtlCol="0">
+            <a:spAutoFit/>
+          </a:bodyPr>
+          <a:lstStyle/>
+          <a:p>
+            <a:pPr algn="ctr"/>
+            <a:r>
+              <a:rPr lang="hu-HU" b="1" dirty="0">
+                <a:latin typeface="Montserrat" panose="00000500000000000000" pitchFamily="2" charset="-18"/>
+              </a:rPr>
+              <a:t>#</a:t>
+            </a:r>
+            <a:r>
+              <a:rPr lang="en-US" b="1" dirty="0">
+                <a:latin typeface="Montserrat" panose="00000500000000000000" pitchFamily="2" charset="-18"/>
+              </a:rPr>
+              <a:t>00FFFF</a:t>
+            </a:r>
+            <a:endParaRPr lang="hu-HU" b="1" dirty="0">
+              <a:latin typeface="Montserrat" panose="00000500000000000000" pitchFamily="2" charset="-18"/>
+            </a:endParaRPr>
+          </a:p>
+        </p:txBody>
+      </p:sp>
+      <p:sp>
+        <p:nvSpPr>
+          <p:cNvPr id="103" name="Szövegdoboz 102">
+            <a:extLst>
+              <a:ext uri="{FF2B5EF4-FFF2-40B4-BE49-F238E27FC236}">
+                <a16:creationId xmlns:a16="http://schemas.microsoft.com/office/drawing/2014/main" id="{2ACE293A-4535-3A8B-D690-A0E164FC841E}"/>
+              </a:ext>
+            </a:extLst>
+          </p:cNvPr>
+          <p:cNvSpPr txBox="1"/>
+          <p:nvPr/>
+        </p:nvSpPr>
+        <p:spPr>
+          <a:xfrm>
+            <a:off x="9250671" y="4370231"/>
+            <a:ext cx="1704568" cy="369332"/>
+          </a:xfrm>
+          <a:prstGeom prst="rect">
+            <a:avLst/>
+          </a:prstGeom>
+          <a:noFill/>
+        </p:spPr>
+        <p:txBody>
+          <a:bodyPr wrap="square" rtlCol="0">
+            <a:spAutoFit/>
+          </a:bodyPr>
+          <a:lstStyle/>
+          <a:p>
+            <a:pPr algn="ctr"/>
+            <a:r>
+              <a:rPr lang="hu-HU" b="1" dirty="0">
+                <a:latin typeface="Montserrat" panose="00000500000000000000" pitchFamily="2" charset="-18"/>
+              </a:rPr>
+              <a:t>#</a:t>
+            </a:r>
+            <a:r>
+              <a:rPr lang="en-US" b="1" dirty="0">
+                <a:latin typeface="Montserrat" panose="00000500000000000000" pitchFamily="2" charset="-18"/>
+              </a:rPr>
+              <a:t>FF00FF</a:t>
+            </a:r>
+            <a:endParaRPr lang="hu-HU" b="1" dirty="0">
+              <a:latin typeface="Montserrat" panose="00000500000000000000" pitchFamily="2" charset="-18"/>
+            </a:endParaRPr>
+          </a:p>
+        </p:txBody>
+      </p:sp>
+    </p:spTree>
+    <p:extLst>
+      <p:ext uri="{BB962C8B-B14F-4D97-AF65-F5344CB8AC3E}">
+        <p14:creationId xmlns:p14="http://schemas.microsoft.com/office/powerpoint/2010/main" val="47627406"/>
       </p:ext>
     </p:extLst>
   </p:cSld>

</xml_diff>

<commit_message>
Added discussed elements to the presentation
</commit_message>
<xml_diff>
--- a/documentation/mytunes presentation.pptx
+++ b/documentation/mytunes presentation.pptx
@@ -278,7 +278,7 @@
           <a:p>
             <a:fld id="{6444479B-705B-4489-957E-7E8A228BDFA0}" type="datetime1">
               <a:rPr lang="en-US" smtClean="0"/>
-              <a:t>11/24/2025</a:t>
+              <a:t>12/8/2025</a:t>
             </a:fld>
             <a:endParaRPr lang="en-US"/>
           </a:p>
@@ -478,7 +478,7 @@
           <a:p>
             <a:fld id="{C07B66AD-7C08-490A-ADA4-B47E10FB2407}" type="datetime1">
               <a:rPr lang="en-US" smtClean="0"/>
-              <a:t>11/24/2025</a:t>
+              <a:t>12/8/2025</a:t>
             </a:fld>
             <a:endParaRPr lang="en-US"/>
           </a:p>
@@ -737,7 +737,7 @@
           <a:p>
             <a:fld id="{05B95027-4255-49E7-9841-CD21BCC99996}" type="datetime1">
               <a:rPr lang="en-US" smtClean="0"/>
-              <a:t>11/24/2025</a:t>
+              <a:t>12/8/2025</a:t>
             </a:fld>
             <a:endParaRPr lang="en-US"/>
           </a:p>
@@ -982,7 +982,7 @@
           <a:p>
             <a:fld id="{9F89F774-3FA6-43B8-9241-99959C8FD463}" type="datetime1">
               <a:rPr lang="en-US" smtClean="0"/>
-              <a:t>11/24/2025</a:t>
+              <a:t>12/8/2025</a:t>
             </a:fld>
             <a:endParaRPr lang="en-US"/>
           </a:p>
@@ -1309,7 +1309,7 @@
           <a:p>
             <a:fld id="{F9504452-5DCC-4FE2-A5C9-8A5EF6714D65}" type="datetime1">
               <a:rPr lang="en-US" smtClean="0"/>
-              <a:t>11/24/2025</a:t>
+              <a:t>12/8/2025</a:t>
             </a:fld>
             <a:endParaRPr lang="en-US"/>
           </a:p>
@@ -1619,7 +1619,7 @@
           <a:p>
             <a:fld id="{E579ABC2-0180-4F3A-A895-A85BC724D472}" type="datetime1">
               <a:rPr lang="en-US" smtClean="0"/>
-              <a:t>11/24/2025</a:t>
+              <a:t>12/8/2025</a:t>
             </a:fld>
             <a:endParaRPr lang="en-US"/>
           </a:p>
@@ -2037,7 +2037,7 @@
           <a:p>
             <a:fld id="{6AEEA9BA-4E8F-439E-BEA4-91FBA01E3F5F}" type="datetime1">
               <a:rPr lang="en-US" smtClean="0"/>
-              <a:t>11/24/2025</a:t>
+              <a:t>12/8/2025</a:t>
             </a:fld>
             <a:endParaRPr lang="en-US"/>
           </a:p>
@@ -2179,7 +2179,7 @@
           <a:p>
             <a:fld id="{BE15BF18-0007-481C-AA29-413124BC3EE7}" type="datetime1">
               <a:rPr lang="en-US" smtClean="0"/>
-              <a:t>11/24/2025</a:t>
+              <a:t>12/8/2025</a:t>
             </a:fld>
             <a:endParaRPr lang="en-US"/>
           </a:p>
@@ -2341,7 +2341,7 @@
           <a:p>
             <a:fld id="{09BE9870-3748-43AD-B547-02A075CB4A1D}" type="datetime1">
               <a:rPr lang="en-US" smtClean="0"/>
-              <a:t>11/24/2025</a:t>
+              <a:t>12/8/2025</a:t>
             </a:fld>
             <a:endParaRPr lang="en-US"/>
           </a:p>
@@ -2658,7 +2658,7 @@
           <a:p>
             <a:fld id="{558E7897-33C5-4F1A-9307-D068E37F3DC7}" type="datetime1">
               <a:rPr lang="en-US" smtClean="0"/>
-              <a:t>11/24/2025</a:t>
+              <a:t>12/8/2025</a:t>
             </a:fld>
             <a:endParaRPr lang="en-US"/>
           </a:p>
@@ -2953,7 +2953,7 @@
           <a:p>
             <a:fld id="{82E171BA-CC09-47C8-A6DF-F5C5CB59CEEC}" type="datetime1">
               <a:rPr lang="en-US" smtClean="0"/>
-              <a:t>11/24/2025</a:t>
+              <a:t>12/8/2025</a:t>
             </a:fld>
             <a:endParaRPr lang="en-US"/>
           </a:p>
@@ -3240,7 +3240,7 @@
           <a:p>
             <a:fld id="{7DA38F49-B3E2-4BF0-BEC7-C30D34ABBB8D}" type="datetime1">
               <a:rPr lang="en-US" smtClean="0"/>
-              <a:t>11/24/2025</a:t>
+              <a:t>12/8/2025</a:t>
             </a:fld>
             <a:endParaRPr lang="en-US"/>
           </a:p>
@@ -4255,63 +4255,111 @@
         </p:spPr>
         <p:txBody>
           <a:bodyPr>
-            <a:normAutofit fontScale="92500" lnSpcReduction="10000"/>
+            <a:normAutofit fontScale="77500" lnSpcReduction="20000"/>
           </a:bodyPr>
           <a:lstStyle/>
           <a:p>
             <a:r>
-              <a:rPr lang="hu-HU" sz="6000" dirty="0">
+              <a:rPr lang="hu-HU" sz="5700" dirty="0" err="1">
                 <a:solidFill>
                   <a:srgbClr val="FF00FF"/>
                 </a:solidFill>
                 <a:latin typeface="Montserrat" panose="00000500000000000000" pitchFamily="2" charset="-18"/>
               </a:rPr>
-              <a:t>Címsor 1</a:t>
-            </a:r>
-          </a:p>
-          <a:p>
-            <a:r>
-              <a:rPr lang="hu-HU" sz="4800" dirty="0">
+              <a:t>Monsterrat</a:t>
+            </a:r>
+            <a:endParaRPr lang="hu-HU" sz="5700" dirty="0">
+              <a:solidFill>
+                <a:srgbClr val="FF00FF"/>
+              </a:solidFill>
+              <a:latin typeface="Montserrat" panose="00000500000000000000" pitchFamily="2" charset="-18"/>
+            </a:endParaRPr>
+          </a:p>
+          <a:p>
+            <a:r>
+              <a:rPr lang="hu-HU" sz="4800" b="1" dirty="0" err="1">
                 <a:solidFill>
                   <a:srgbClr val="BF40FF"/>
                 </a:solidFill>
                 <a:latin typeface="Montserrat" panose="00000500000000000000" pitchFamily="2" charset="-18"/>
               </a:rPr>
-              <a:t>Címsor 2</a:t>
-            </a:r>
-          </a:p>
-          <a:p>
-            <a:r>
-              <a:rPr lang="hu-HU" sz="3900" dirty="0">
+              <a:t>Bold</a:t>
+            </a:r>
+            <a:endParaRPr lang="hu-HU" sz="4800" b="1" dirty="0">
+              <a:solidFill>
+                <a:srgbClr val="BF40FF"/>
+              </a:solidFill>
+              <a:latin typeface="Montserrat" panose="00000500000000000000" pitchFamily="2" charset="-18"/>
+            </a:endParaRPr>
+          </a:p>
+          <a:p>
+            <a:r>
+              <a:rPr lang="hu-HU" sz="3900" i="1" dirty="0" err="1">
                 <a:solidFill>
                   <a:srgbClr val="8080FF"/>
                 </a:solidFill>
                 <a:latin typeface="Montserrat" panose="00000500000000000000" pitchFamily="2" charset="-18"/>
               </a:rPr>
-              <a:t>Címsor 3</a:t>
-            </a:r>
-          </a:p>
-          <a:p>
-            <a:r>
-              <a:rPr lang="hu-HU" sz="2400" dirty="0">
+              <a:t>Italic</a:t>
+            </a:r>
+            <a:endParaRPr lang="hu-HU" sz="3900" i="1" dirty="0">
+              <a:solidFill>
+                <a:srgbClr val="8080FF"/>
+              </a:solidFill>
+              <a:latin typeface="Montserrat" panose="00000500000000000000" pitchFamily="2" charset="-18"/>
+            </a:endParaRPr>
+          </a:p>
+          <a:p>
+            <a:r>
+              <a:rPr lang="hu-HU" sz="2400" u="sng" dirty="0" err="1">
                 <a:solidFill>
                   <a:srgbClr val="40BFFF"/>
                 </a:solidFill>
                 <a:latin typeface="Montserrat" panose="00000500000000000000" pitchFamily="2" charset="-18"/>
               </a:rPr>
-              <a:t>Címsor 4</a:t>
-            </a:r>
-          </a:p>
-          <a:p>
-            <a:r>
-              <a:rPr lang="hu-HU" sz="1500" dirty="0">
+              <a:t>Underlined</a:t>
+            </a:r>
+            <a:endParaRPr lang="hu-HU" sz="2400" u="sng" dirty="0">
+              <a:solidFill>
+                <a:srgbClr val="40BFFF"/>
+              </a:solidFill>
+              <a:latin typeface="Montserrat" panose="00000500000000000000" pitchFamily="2" charset="-18"/>
+            </a:endParaRPr>
+          </a:p>
+          <a:p>
+            <a:r>
+              <a:rPr lang="hu-HU" sz="1500" cap="small" dirty="0" err="1">
                 <a:solidFill>
                   <a:srgbClr val="00FFFF"/>
                 </a:solidFill>
                 <a:latin typeface="Montserrat" panose="00000500000000000000" pitchFamily="2" charset="-18"/>
               </a:rPr>
-              <a:t>Címsor 5</a:t>
-            </a:r>
+              <a:t>Small</a:t>
+            </a:r>
+            <a:r>
+              <a:rPr lang="hu-HU" sz="1500" cap="small" dirty="0">
+                <a:solidFill>
+                  <a:srgbClr val="00FFFF"/>
+                </a:solidFill>
+                <a:latin typeface="Montserrat" panose="00000500000000000000" pitchFamily="2" charset="-18"/>
+              </a:rPr>
+              <a:t> </a:t>
+            </a:r>
+            <a:r>
+              <a:rPr lang="hu-HU" sz="1500" cap="small" dirty="0" err="1">
+                <a:solidFill>
+                  <a:srgbClr val="00FFFF"/>
+                </a:solidFill>
+                <a:latin typeface="Montserrat" panose="00000500000000000000" pitchFamily="2" charset="-18"/>
+              </a:rPr>
+              <a:t>caps</a:t>
+            </a:r>
+            <a:endParaRPr lang="hu-HU" sz="1500" cap="small" dirty="0">
+              <a:solidFill>
+                <a:srgbClr val="00FFFF"/>
+              </a:solidFill>
+              <a:latin typeface="Montserrat" panose="00000500000000000000" pitchFamily="2" charset="-18"/>
+            </a:endParaRPr>
           </a:p>
         </p:txBody>
       </p:sp>
@@ -4340,7 +4388,7 @@
         </p:spPr>
         <p:txBody>
           <a:bodyPr vert="horz" lIns="91440" tIns="45720" rIns="91440" bIns="45720" rtlCol="0">
-            <a:normAutofit/>
+            <a:normAutofit fontScale="92500" lnSpcReduction="20000"/>
           </a:bodyPr>
           <a:lstStyle>
             <a:lvl1pPr marL="228600" indent="-228600" algn="l" defTabSz="914400" rtl="0" eaLnBrk="1" latinLnBrk="0" hangingPunct="1">
@@ -4517,1184 +4565,57 @@
             </a:pPr>
             <a:r>
               <a:rPr lang="hu-HU" sz="1200" dirty="0">
-                <a:latin typeface="Montserrat" panose="00000500000000000000" pitchFamily="2" charset="-18"/>
+                <a:latin typeface="Monsterrrat"/>
               </a:rPr>
               <a:t>	</a:t>
             </a:r>
             <a:r>
-              <a:rPr lang="hu-HU" sz="1200" dirty="0" err="1">
-                <a:latin typeface="Montserrat" panose="00000500000000000000" pitchFamily="2" charset="-18"/>
+              <a:rPr lang="en-US" dirty="0">
+                <a:latin typeface="Monsterrrat"/>
               </a:rPr>
-              <a:t>Lorem</a:t>
-            </a:r>
-            <a:r>
-              <a:rPr lang="hu-HU" sz="1200" dirty="0">
-                <a:latin typeface="Montserrat" panose="00000500000000000000" pitchFamily="2" charset="-18"/>
+              <a:t>Inspired by the old posters and signs in the traditional Montserrat </a:t>
+            </a:r>
+            <a:r>
+              <a:rPr lang="en-US" dirty="0" err="1">
+                <a:latin typeface="Monsterrrat"/>
               </a:rPr>
-              <a:t> </a:t>
-            </a:r>
-            <a:r>
-              <a:rPr lang="hu-HU" sz="1200" dirty="0" err="1">
-                <a:latin typeface="Montserrat" panose="00000500000000000000" pitchFamily="2" charset="-18"/>
+              <a:t>neighbourhood</a:t>
+            </a:r>
+            <a:r>
+              <a:rPr lang="en-US" dirty="0">
+                <a:latin typeface="Monsterrrat"/>
               </a:rPr>
-              <a:t>ipsum</a:t>
-            </a:r>
-            <a:r>
-              <a:rPr lang="hu-HU" sz="1200" dirty="0">
-                <a:latin typeface="Montserrat" panose="00000500000000000000" pitchFamily="2" charset="-18"/>
+              <a:t> of Buenos Aires, Montserrat Font was created in 2010 by Argentine artist Julieta </a:t>
+            </a:r>
+            <a:r>
+              <a:rPr lang="en-US" dirty="0" err="1">
+                <a:latin typeface="Monsterrrat"/>
               </a:rPr>
-              <a:t> </a:t>
-            </a:r>
-            <a:r>
-              <a:rPr lang="hu-HU" sz="1200" dirty="0" err="1">
-                <a:latin typeface="Montserrat" panose="00000500000000000000" pitchFamily="2" charset="-18"/>
+              <a:t>Ulanovsky</a:t>
+            </a:r>
+            <a:r>
+              <a:rPr lang="en-US" dirty="0">
+                <a:latin typeface="Monsterrrat"/>
               </a:rPr>
-              <a:t>dolor</a:t>
-            </a:r>
-            <a:r>
-              <a:rPr lang="hu-HU" sz="1200" dirty="0">
-                <a:latin typeface="Montserrat" panose="00000500000000000000" pitchFamily="2" charset="-18"/>
+              <a:t> in a homage to the beauty of the urban typography that emerged in the </a:t>
+            </a:r>
+            <a:r>
+              <a:rPr lang="en-US" dirty="0" err="1">
+                <a:latin typeface="Monsterrrat"/>
               </a:rPr>
-              <a:t> </a:t>
-            </a:r>
-            <a:r>
-              <a:rPr lang="hu-HU" sz="1200" dirty="0" err="1">
-                <a:latin typeface="Montserrat" panose="00000500000000000000" pitchFamily="2" charset="-18"/>
+              <a:t>neighbourhood</a:t>
+            </a:r>
+            <a:r>
+              <a:rPr lang="en-US" dirty="0">
+                <a:latin typeface="Monsterrrat"/>
               </a:rPr>
-              <a:t>sit</a:t>
-            </a:r>
-            <a:r>
-              <a:rPr lang="hu-HU" sz="1200" dirty="0">
-                <a:latin typeface="Montserrat" panose="00000500000000000000" pitchFamily="2" charset="-18"/>
-              </a:rPr>
-              <a:t> </a:t>
-            </a:r>
-            <a:r>
-              <a:rPr lang="hu-HU" sz="1200" dirty="0" err="1">
-                <a:latin typeface="Montserrat" panose="00000500000000000000" pitchFamily="2" charset="-18"/>
-              </a:rPr>
-              <a:t>amet</a:t>
-            </a:r>
-            <a:r>
-              <a:rPr lang="hu-HU" sz="1200" dirty="0">
-                <a:latin typeface="Montserrat" panose="00000500000000000000" pitchFamily="2" charset="-18"/>
-              </a:rPr>
-              <a:t>, </a:t>
-            </a:r>
-            <a:r>
-              <a:rPr lang="hu-HU" sz="1200" dirty="0" err="1">
-                <a:latin typeface="Montserrat" panose="00000500000000000000" pitchFamily="2" charset="-18"/>
-              </a:rPr>
-              <a:t>consectetur</a:t>
-            </a:r>
-            <a:r>
-              <a:rPr lang="hu-HU" sz="1200" dirty="0">
-                <a:latin typeface="Montserrat" panose="00000500000000000000" pitchFamily="2" charset="-18"/>
-              </a:rPr>
-              <a:t> </a:t>
-            </a:r>
-            <a:r>
-              <a:rPr lang="hu-HU" sz="1200" dirty="0" err="1">
-                <a:latin typeface="Montserrat" panose="00000500000000000000" pitchFamily="2" charset="-18"/>
-              </a:rPr>
-              <a:t>adipiscing</a:t>
-            </a:r>
-            <a:r>
-              <a:rPr lang="hu-HU" sz="1200" dirty="0">
-                <a:latin typeface="Montserrat" panose="00000500000000000000" pitchFamily="2" charset="-18"/>
-              </a:rPr>
-              <a:t> elit. </a:t>
-            </a:r>
-            <a:r>
-              <a:rPr lang="hu-HU" sz="1200" dirty="0" err="1">
-                <a:latin typeface="Montserrat" panose="00000500000000000000" pitchFamily="2" charset="-18"/>
-              </a:rPr>
-              <a:t>Suspendisse</a:t>
-            </a:r>
-            <a:r>
-              <a:rPr lang="hu-HU" sz="1200" dirty="0">
-                <a:latin typeface="Montserrat" panose="00000500000000000000" pitchFamily="2" charset="-18"/>
-              </a:rPr>
-              <a:t> </a:t>
-            </a:r>
-            <a:r>
-              <a:rPr lang="hu-HU" sz="1200" dirty="0" err="1">
-                <a:latin typeface="Montserrat" panose="00000500000000000000" pitchFamily="2" charset="-18"/>
-              </a:rPr>
-              <a:t>ac</a:t>
-            </a:r>
-            <a:r>
-              <a:rPr lang="hu-HU" sz="1200" dirty="0">
-                <a:latin typeface="Montserrat" panose="00000500000000000000" pitchFamily="2" charset="-18"/>
-              </a:rPr>
-              <a:t> est </a:t>
-            </a:r>
-            <a:r>
-              <a:rPr lang="hu-HU" sz="1200" dirty="0" err="1">
-                <a:latin typeface="Montserrat" panose="00000500000000000000" pitchFamily="2" charset="-18"/>
-              </a:rPr>
-              <a:t>ornare</a:t>
-            </a:r>
-            <a:r>
-              <a:rPr lang="hu-HU" sz="1200" dirty="0">
-                <a:latin typeface="Montserrat" panose="00000500000000000000" pitchFamily="2" charset="-18"/>
-              </a:rPr>
-              <a:t>, </a:t>
-            </a:r>
-            <a:r>
-              <a:rPr lang="hu-HU" sz="1200" dirty="0" err="1">
-                <a:latin typeface="Montserrat" panose="00000500000000000000" pitchFamily="2" charset="-18"/>
-              </a:rPr>
-              <a:t>tempor</a:t>
-            </a:r>
-            <a:r>
-              <a:rPr lang="hu-HU" sz="1200" dirty="0">
-                <a:latin typeface="Montserrat" panose="00000500000000000000" pitchFamily="2" charset="-18"/>
-              </a:rPr>
-              <a:t> </a:t>
-            </a:r>
-            <a:r>
-              <a:rPr lang="hu-HU" sz="1200" dirty="0" err="1">
-                <a:latin typeface="Montserrat" panose="00000500000000000000" pitchFamily="2" charset="-18"/>
-              </a:rPr>
-              <a:t>velit</a:t>
-            </a:r>
-            <a:r>
-              <a:rPr lang="hu-HU" sz="1200" dirty="0">
-                <a:latin typeface="Montserrat" panose="00000500000000000000" pitchFamily="2" charset="-18"/>
-              </a:rPr>
-              <a:t> </a:t>
-            </a:r>
-            <a:r>
-              <a:rPr lang="hu-HU" sz="1200" dirty="0" err="1">
-                <a:latin typeface="Montserrat" panose="00000500000000000000" pitchFamily="2" charset="-18"/>
-              </a:rPr>
-              <a:t>id</a:t>
-            </a:r>
-            <a:r>
-              <a:rPr lang="hu-HU" sz="1200" dirty="0">
-                <a:latin typeface="Montserrat" panose="00000500000000000000" pitchFamily="2" charset="-18"/>
-              </a:rPr>
-              <a:t>, </a:t>
-            </a:r>
-            <a:r>
-              <a:rPr lang="hu-HU" sz="1200" dirty="0" err="1">
-                <a:latin typeface="Montserrat" panose="00000500000000000000" pitchFamily="2" charset="-18"/>
-              </a:rPr>
-              <a:t>hendrerit</a:t>
-            </a:r>
-            <a:r>
-              <a:rPr lang="hu-HU" sz="1200" dirty="0">
-                <a:latin typeface="Montserrat" panose="00000500000000000000" pitchFamily="2" charset="-18"/>
-              </a:rPr>
-              <a:t> </a:t>
-            </a:r>
-            <a:r>
-              <a:rPr lang="hu-HU" sz="1200" dirty="0" err="1">
-                <a:latin typeface="Montserrat" panose="00000500000000000000" pitchFamily="2" charset="-18"/>
-              </a:rPr>
-              <a:t>risus</a:t>
-            </a:r>
-            <a:r>
-              <a:rPr lang="hu-HU" sz="1200" dirty="0">
-                <a:latin typeface="Montserrat" panose="00000500000000000000" pitchFamily="2" charset="-18"/>
-              </a:rPr>
-              <a:t>. </a:t>
-            </a:r>
-            <a:r>
-              <a:rPr lang="hu-HU" sz="1200" dirty="0" err="1">
-                <a:latin typeface="Montserrat" panose="00000500000000000000" pitchFamily="2" charset="-18"/>
-              </a:rPr>
-              <a:t>Vestibulum</a:t>
-            </a:r>
-            <a:r>
-              <a:rPr lang="hu-HU" sz="1200" dirty="0">
-                <a:latin typeface="Montserrat" panose="00000500000000000000" pitchFamily="2" charset="-18"/>
-              </a:rPr>
-              <a:t> ante </a:t>
-            </a:r>
-            <a:r>
-              <a:rPr lang="hu-HU" sz="1200" dirty="0" err="1">
-                <a:latin typeface="Montserrat" panose="00000500000000000000" pitchFamily="2" charset="-18"/>
-              </a:rPr>
-              <a:t>ipsum</a:t>
-            </a:r>
-            <a:r>
-              <a:rPr lang="hu-HU" sz="1200" dirty="0">
-                <a:latin typeface="Montserrat" panose="00000500000000000000" pitchFamily="2" charset="-18"/>
-              </a:rPr>
-              <a:t> </a:t>
-            </a:r>
-            <a:r>
-              <a:rPr lang="hu-HU" sz="1200" dirty="0" err="1">
-                <a:latin typeface="Montserrat" panose="00000500000000000000" pitchFamily="2" charset="-18"/>
-              </a:rPr>
-              <a:t>primis</a:t>
-            </a:r>
-            <a:r>
-              <a:rPr lang="hu-HU" sz="1200" dirty="0">
-                <a:latin typeface="Montserrat" panose="00000500000000000000" pitchFamily="2" charset="-18"/>
-              </a:rPr>
-              <a:t> in </a:t>
-            </a:r>
-            <a:r>
-              <a:rPr lang="hu-HU" sz="1200" dirty="0" err="1">
-                <a:latin typeface="Montserrat" panose="00000500000000000000" pitchFamily="2" charset="-18"/>
-              </a:rPr>
-              <a:t>faucibus</a:t>
-            </a:r>
-            <a:r>
-              <a:rPr lang="hu-HU" sz="1200" dirty="0">
-                <a:latin typeface="Montserrat" panose="00000500000000000000" pitchFamily="2" charset="-18"/>
-              </a:rPr>
-              <a:t> </a:t>
-            </a:r>
-            <a:r>
-              <a:rPr lang="hu-HU" sz="1200" dirty="0" err="1">
-                <a:latin typeface="Montserrat" panose="00000500000000000000" pitchFamily="2" charset="-18"/>
-              </a:rPr>
-              <a:t>orci</a:t>
-            </a:r>
-            <a:r>
-              <a:rPr lang="hu-HU" sz="1200" dirty="0">
-                <a:latin typeface="Montserrat" panose="00000500000000000000" pitchFamily="2" charset="-18"/>
-              </a:rPr>
-              <a:t> </a:t>
-            </a:r>
-            <a:r>
-              <a:rPr lang="hu-HU" sz="1200" dirty="0" err="1">
-                <a:latin typeface="Montserrat" panose="00000500000000000000" pitchFamily="2" charset="-18"/>
-              </a:rPr>
-              <a:t>luctus</a:t>
-            </a:r>
-            <a:r>
-              <a:rPr lang="hu-HU" sz="1200" dirty="0">
-                <a:latin typeface="Montserrat" panose="00000500000000000000" pitchFamily="2" charset="-18"/>
-              </a:rPr>
-              <a:t> </a:t>
-            </a:r>
-            <a:r>
-              <a:rPr lang="hu-HU" sz="1200" dirty="0" err="1">
-                <a:latin typeface="Montserrat" panose="00000500000000000000" pitchFamily="2" charset="-18"/>
-              </a:rPr>
-              <a:t>et</a:t>
-            </a:r>
-            <a:r>
-              <a:rPr lang="hu-HU" sz="1200" dirty="0">
-                <a:latin typeface="Montserrat" panose="00000500000000000000" pitchFamily="2" charset="-18"/>
-              </a:rPr>
-              <a:t> </a:t>
-            </a:r>
-            <a:r>
-              <a:rPr lang="hu-HU" sz="1200" dirty="0" err="1">
-                <a:latin typeface="Montserrat" panose="00000500000000000000" pitchFamily="2" charset="-18"/>
-              </a:rPr>
-              <a:t>ultrices</a:t>
-            </a:r>
-            <a:r>
-              <a:rPr lang="hu-HU" sz="1200" dirty="0">
-                <a:latin typeface="Montserrat" panose="00000500000000000000" pitchFamily="2" charset="-18"/>
-              </a:rPr>
-              <a:t> </a:t>
-            </a:r>
-            <a:r>
-              <a:rPr lang="hu-HU" sz="1200" dirty="0" err="1">
-                <a:latin typeface="Montserrat" panose="00000500000000000000" pitchFamily="2" charset="-18"/>
-              </a:rPr>
-              <a:t>posuere</a:t>
-            </a:r>
-            <a:r>
-              <a:rPr lang="hu-HU" sz="1200" dirty="0">
-                <a:latin typeface="Montserrat" panose="00000500000000000000" pitchFamily="2" charset="-18"/>
-              </a:rPr>
-              <a:t> </a:t>
-            </a:r>
-            <a:r>
-              <a:rPr lang="hu-HU" sz="1200" dirty="0" err="1">
-                <a:latin typeface="Montserrat" panose="00000500000000000000" pitchFamily="2" charset="-18"/>
-              </a:rPr>
-              <a:t>cubilia</a:t>
-            </a:r>
-            <a:r>
-              <a:rPr lang="hu-HU" sz="1200" dirty="0">
-                <a:latin typeface="Montserrat" panose="00000500000000000000" pitchFamily="2" charset="-18"/>
-              </a:rPr>
-              <a:t> </a:t>
-            </a:r>
-            <a:r>
-              <a:rPr lang="hu-HU" sz="1200" dirty="0" err="1">
-                <a:latin typeface="Montserrat" panose="00000500000000000000" pitchFamily="2" charset="-18"/>
-              </a:rPr>
-              <a:t>curae</a:t>
-            </a:r>
-            <a:r>
-              <a:rPr lang="hu-HU" sz="1200" dirty="0">
-                <a:latin typeface="Montserrat" panose="00000500000000000000" pitchFamily="2" charset="-18"/>
-              </a:rPr>
-              <a:t>; </a:t>
-            </a:r>
-            <a:r>
-              <a:rPr lang="hu-HU" sz="1200" dirty="0" err="1">
-                <a:latin typeface="Montserrat" panose="00000500000000000000" pitchFamily="2" charset="-18"/>
-              </a:rPr>
-              <a:t>Mauris</a:t>
-            </a:r>
-            <a:r>
-              <a:rPr lang="hu-HU" sz="1200" dirty="0">
-                <a:latin typeface="Montserrat" panose="00000500000000000000" pitchFamily="2" charset="-18"/>
-              </a:rPr>
-              <a:t> </a:t>
-            </a:r>
-            <a:r>
-              <a:rPr lang="hu-HU" sz="1200" dirty="0" err="1">
-                <a:latin typeface="Montserrat" panose="00000500000000000000" pitchFamily="2" charset="-18"/>
-              </a:rPr>
-              <a:t>volutpat</a:t>
-            </a:r>
-            <a:r>
-              <a:rPr lang="hu-HU" sz="1200" dirty="0">
-                <a:latin typeface="Montserrat" panose="00000500000000000000" pitchFamily="2" charset="-18"/>
-              </a:rPr>
-              <a:t> </a:t>
-            </a:r>
-            <a:r>
-              <a:rPr lang="hu-HU" sz="1200" dirty="0" err="1">
-                <a:latin typeface="Montserrat" panose="00000500000000000000" pitchFamily="2" charset="-18"/>
-              </a:rPr>
-              <a:t>justo</a:t>
-            </a:r>
-            <a:r>
-              <a:rPr lang="hu-HU" sz="1200" dirty="0">
-                <a:latin typeface="Montserrat" panose="00000500000000000000" pitchFamily="2" charset="-18"/>
-              </a:rPr>
-              <a:t> </a:t>
-            </a:r>
-            <a:r>
-              <a:rPr lang="hu-HU" sz="1200" dirty="0" err="1">
-                <a:latin typeface="Montserrat" panose="00000500000000000000" pitchFamily="2" charset="-18"/>
-              </a:rPr>
-              <a:t>lacus</a:t>
-            </a:r>
-            <a:r>
-              <a:rPr lang="hu-HU" sz="1200" dirty="0">
-                <a:latin typeface="Montserrat" panose="00000500000000000000" pitchFamily="2" charset="-18"/>
-              </a:rPr>
-              <a:t>, </a:t>
-            </a:r>
-            <a:r>
-              <a:rPr lang="hu-HU" sz="1200" dirty="0" err="1">
-                <a:latin typeface="Montserrat" panose="00000500000000000000" pitchFamily="2" charset="-18"/>
-              </a:rPr>
-              <a:t>ac</a:t>
-            </a:r>
-            <a:r>
-              <a:rPr lang="hu-HU" sz="1200" dirty="0">
-                <a:latin typeface="Montserrat" panose="00000500000000000000" pitchFamily="2" charset="-18"/>
-              </a:rPr>
-              <a:t> </a:t>
-            </a:r>
-            <a:r>
-              <a:rPr lang="hu-HU" sz="1200" dirty="0" err="1">
-                <a:latin typeface="Montserrat" panose="00000500000000000000" pitchFamily="2" charset="-18"/>
-              </a:rPr>
-              <a:t>vestibulum</a:t>
-            </a:r>
-            <a:r>
-              <a:rPr lang="hu-HU" sz="1200" dirty="0">
-                <a:latin typeface="Montserrat" panose="00000500000000000000" pitchFamily="2" charset="-18"/>
-              </a:rPr>
-              <a:t> tortor </a:t>
-            </a:r>
-            <a:r>
-              <a:rPr lang="hu-HU" sz="1200" dirty="0" err="1">
-                <a:latin typeface="Montserrat" panose="00000500000000000000" pitchFamily="2" charset="-18"/>
-              </a:rPr>
-              <a:t>rhoncus</a:t>
-            </a:r>
-            <a:r>
-              <a:rPr lang="hu-HU" sz="1200" dirty="0">
-                <a:latin typeface="Montserrat" panose="00000500000000000000" pitchFamily="2" charset="-18"/>
-              </a:rPr>
-              <a:t> non. In </a:t>
-            </a:r>
-            <a:r>
-              <a:rPr lang="hu-HU" sz="1200" dirty="0" err="1">
-                <a:latin typeface="Montserrat" panose="00000500000000000000" pitchFamily="2" charset="-18"/>
-              </a:rPr>
-              <a:t>quis</a:t>
-            </a:r>
-            <a:r>
-              <a:rPr lang="hu-HU" sz="1200" dirty="0">
-                <a:latin typeface="Montserrat" panose="00000500000000000000" pitchFamily="2" charset="-18"/>
-              </a:rPr>
-              <a:t> </a:t>
-            </a:r>
-            <a:r>
-              <a:rPr lang="hu-HU" sz="1200" dirty="0" err="1">
-                <a:latin typeface="Montserrat" panose="00000500000000000000" pitchFamily="2" charset="-18"/>
-              </a:rPr>
-              <a:t>tincidunt</a:t>
-            </a:r>
-            <a:r>
-              <a:rPr lang="hu-HU" sz="1200" dirty="0">
-                <a:latin typeface="Montserrat" panose="00000500000000000000" pitchFamily="2" charset="-18"/>
-              </a:rPr>
-              <a:t> </a:t>
-            </a:r>
-            <a:r>
-              <a:rPr lang="hu-HU" sz="1200" dirty="0" err="1">
-                <a:latin typeface="Montserrat" panose="00000500000000000000" pitchFamily="2" charset="-18"/>
-              </a:rPr>
-              <a:t>lorem</a:t>
-            </a:r>
-            <a:r>
-              <a:rPr lang="hu-HU" sz="1200" dirty="0">
-                <a:latin typeface="Montserrat" panose="00000500000000000000" pitchFamily="2" charset="-18"/>
-              </a:rPr>
-              <a:t>. Nulla </a:t>
-            </a:r>
-            <a:r>
-              <a:rPr lang="hu-HU" sz="1200" dirty="0" err="1">
-                <a:latin typeface="Montserrat" panose="00000500000000000000" pitchFamily="2" charset="-18"/>
-              </a:rPr>
-              <a:t>efficitur</a:t>
-            </a:r>
-            <a:r>
-              <a:rPr lang="hu-HU" sz="1200" dirty="0">
-                <a:latin typeface="Montserrat" panose="00000500000000000000" pitchFamily="2" charset="-18"/>
-              </a:rPr>
-              <a:t> </a:t>
-            </a:r>
-            <a:r>
-              <a:rPr lang="hu-HU" sz="1200" dirty="0" err="1">
-                <a:latin typeface="Montserrat" panose="00000500000000000000" pitchFamily="2" charset="-18"/>
-              </a:rPr>
-              <a:t>hendrerit</a:t>
-            </a:r>
-            <a:r>
-              <a:rPr lang="hu-HU" sz="1200" dirty="0">
-                <a:latin typeface="Montserrat" panose="00000500000000000000" pitchFamily="2" charset="-18"/>
-              </a:rPr>
-              <a:t> </a:t>
-            </a:r>
-            <a:r>
-              <a:rPr lang="hu-HU" sz="1200" dirty="0" err="1">
-                <a:latin typeface="Montserrat" panose="00000500000000000000" pitchFamily="2" charset="-18"/>
-              </a:rPr>
-              <a:t>efficitur</a:t>
-            </a:r>
-            <a:r>
-              <a:rPr lang="hu-HU" sz="1200" dirty="0">
-                <a:latin typeface="Montserrat" panose="00000500000000000000" pitchFamily="2" charset="-18"/>
-              </a:rPr>
-              <a:t>. </a:t>
-            </a:r>
-            <a:r>
-              <a:rPr lang="hu-HU" sz="1200" dirty="0" err="1">
-                <a:latin typeface="Montserrat" panose="00000500000000000000" pitchFamily="2" charset="-18"/>
-              </a:rPr>
-              <a:t>Vivamus</a:t>
-            </a:r>
-            <a:r>
-              <a:rPr lang="hu-HU" sz="1200" dirty="0">
-                <a:latin typeface="Montserrat" panose="00000500000000000000" pitchFamily="2" charset="-18"/>
-              </a:rPr>
-              <a:t> </a:t>
-            </a:r>
-            <a:r>
-              <a:rPr lang="hu-HU" sz="1200" dirty="0" err="1">
-                <a:latin typeface="Montserrat" panose="00000500000000000000" pitchFamily="2" charset="-18"/>
-              </a:rPr>
-              <a:t>ut</a:t>
-            </a:r>
-            <a:r>
-              <a:rPr lang="hu-HU" sz="1200" dirty="0">
-                <a:latin typeface="Montserrat" panose="00000500000000000000" pitchFamily="2" charset="-18"/>
-              </a:rPr>
-              <a:t> </a:t>
-            </a:r>
-            <a:r>
-              <a:rPr lang="hu-HU" sz="1200" dirty="0" err="1">
-                <a:latin typeface="Montserrat" panose="00000500000000000000" pitchFamily="2" charset="-18"/>
-              </a:rPr>
-              <a:t>euismod</a:t>
-            </a:r>
-            <a:r>
-              <a:rPr lang="hu-HU" sz="1200" dirty="0">
-                <a:latin typeface="Montserrat" panose="00000500000000000000" pitchFamily="2" charset="-18"/>
-              </a:rPr>
-              <a:t> est. </a:t>
-            </a:r>
-            <a:r>
-              <a:rPr lang="hu-HU" sz="1200" dirty="0" err="1">
-                <a:latin typeface="Montserrat" panose="00000500000000000000" pitchFamily="2" charset="-18"/>
-              </a:rPr>
-              <a:t>Etiam</a:t>
-            </a:r>
-            <a:r>
-              <a:rPr lang="hu-HU" sz="1200" dirty="0">
-                <a:latin typeface="Montserrat" panose="00000500000000000000" pitchFamily="2" charset="-18"/>
-              </a:rPr>
-              <a:t> </a:t>
-            </a:r>
-            <a:r>
-              <a:rPr lang="hu-HU" sz="1200" dirty="0" err="1">
-                <a:latin typeface="Montserrat" panose="00000500000000000000" pitchFamily="2" charset="-18"/>
-              </a:rPr>
-              <a:t>viverra</a:t>
-            </a:r>
-            <a:r>
-              <a:rPr lang="hu-HU" sz="1200" dirty="0">
-                <a:latin typeface="Montserrat" panose="00000500000000000000" pitchFamily="2" charset="-18"/>
-              </a:rPr>
-              <a:t>, </a:t>
-            </a:r>
-            <a:r>
-              <a:rPr lang="hu-HU" sz="1200" dirty="0" err="1">
-                <a:latin typeface="Montserrat" panose="00000500000000000000" pitchFamily="2" charset="-18"/>
-              </a:rPr>
-              <a:t>eros</a:t>
-            </a:r>
-            <a:r>
-              <a:rPr lang="hu-HU" sz="1200" dirty="0">
-                <a:latin typeface="Montserrat" panose="00000500000000000000" pitchFamily="2" charset="-18"/>
-              </a:rPr>
-              <a:t> </a:t>
-            </a:r>
-            <a:r>
-              <a:rPr lang="hu-HU" sz="1200" dirty="0" err="1">
-                <a:latin typeface="Montserrat" panose="00000500000000000000" pitchFamily="2" charset="-18"/>
-              </a:rPr>
-              <a:t>sit</a:t>
-            </a:r>
-            <a:r>
-              <a:rPr lang="hu-HU" sz="1200" dirty="0">
-                <a:latin typeface="Montserrat" panose="00000500000000000000" pitchFamily="2" charset="-18"/>
-              </a:rPr>
-              <a:t> </a:t>
-            </a:r>
-            <a:r>
-              <a:rPr lang="hu-HU" sz="1200" dirty="0" err="1">
-                <a:latin typeface="Montserrat" panose="00000500000000000000" pitchFamily="2" charset="-18"/>
-              </a:rPr>
-              <a:t>amet</a:t>
-            </a:r>
-            <a:r>
-              <a:rPr lang="hu-HU" sz="1200" dirty="0">
-                <a:latin typeface="Montserrat" panose="00000500000000000000" pitchFamily="2" charset="-18"/>
-              </a:rPr>
-              <a:t> </a:t>
-            </a:r>
-            <a:r>
-              <a:rPr lang="hu-HU" sz="1200" dirty="0" err="1">
-                <a:latin typeface="Montserrat" panose="00000500000000000000" pitchFamily="2" charset="-18"/>
-              </a:rPr>
-              <a:t>maximus</a:t>
-            </a:r>
-            <a:r>
-              <a:rPr lang="hu-HU" sz="1200" dirty="0">
-                <a:latin typeface="Montserrat" panose="00000500000000000000" pitchFamily="2" charset="-18"/>
-              </a:rPr>
-              <a:t> </a:t>
-            </a:r>
-            <a:r>
-              <a:rPr lang="hu-HU" sz="1200" dirty="0" err="1">
-                <a:latin typeface="Montserrat" panose="00000500000000000000" pitchFamily="2" charset="-18"/>
-              </a:rPr>
-              <a:t>pellentesque</a:t>
-            </a:r>
-            <a:r>
-              <a:rPr lang="hu-HU" sz="1200" dirty="0">
-                <a:latin typeface="Montserrat" panose="00000500000000000000" pitchFamily="2" charset="-18"/>
-              </a:rPr>
-              <a:t>, </a:t>
-            </a:r>
-            <a:r>
-              <a:rPr lang="hu-HU" sz="1200" dirty="0" err="1">
-                <a:latin typeface="Montserrat" panose="00000500000000000000" pitchFamily="2" charset="-18"/>
-              </a:rPr>
-              <a:t>orci</a:t>
-            </a:r>
-            <a:r>
-              <a:rPr lang="hu-HU" sz="1200" dirty="0">
-                <a:latin typeface="Montserrat" panose="00000500000000000000" pitchFamily="2" charset="-18"/>
-              </a:rPr>
-              <a:t> </a:t>
-            </a:r>
-            <a:r>
-              <a:rPr lang="hu-HU" sz="1200" dirty="0" err="1">
-                <a:latin typeface="Montserrat" panose="00000500000000000000" pitchFamily="2" charset="-18"/>
-              </a:rPr>
-              <a:t>dui</a:t>
-            </a:r>
-            <a:r>
-              <a:rPr lang="hu-HU" sz="1200" dirty="0">
-                <a:latin typeface="Montserrat" panose="00000500000000000000" pitchFamily="2" charset="-18"/>
-              </a:rPr>
-              <a:t> </a:t>
-            </a:r>
-            <a:r>
-              <a:rPr lang="hu-HU" sz="1200" dirty="0" err="1">
-                <a:latin typeface="Montserrat" panose="00000500000000000000" pitchFamily="2" charset="-18"/>
-              </a:rPr>
-              <a:t>auctor</a:t>
-            </a:r>
-            <a:r>
-              <a:rPr lang="hu-HU" sz="1200" dirty="0">
-                <a:latin typeface="Montserrat" panose="00000500000000000000" pitchFamily="2" charset="-18"/>
-              </a:rPr>
-              <a:t> </a:t>
-            </a:r>
-            <a:r>
-              <a:rPr lang="hu-HU" sz="1200" dirty="0" err="1">
-                <a:latin typeface="Montserrat" panose="00000500000000000000" pitchFamily="2" charset="-18"/>
-              </a:rPr>
-              <a:t>massa</a:t>
-            </a:r>
-            <a:r>
-              <a:rPr lang="hu-HU" sz="1200" dirty="0">
-                <a:latin typeface="Montserrat" panose="00000500000000000000" pitchFamily="2" charset="-18"/>
-              </a:rPr>
-              <a:t>, </a:t>
-            </a:r>
-            <a:r>
-              <a:rPr lang="hu-HU" sz="1200" dirty="0" err="1">
-                <a:latin typeface="Montserrat" panose="00000500000000000000" pitchFamily="2" charset="-18"/>
-              </a:rPr>
-              <a:t>sit</a:t>
-            </a:r>
-            <a:r>
-              <a:rPr lang="hu-HU" sz="1200" dirty="0">
-                <a:latin typeface="Montserrat" panose="00000500000000000000" pitchFamily="2" charset="-18"/>
-              </a:rPr>
-              <a:t> </a:t>
-            </a:r>
-            <a:r>
-              <a:rPr lang="hu-HU" sz="1200" dirty="0" err="1">
-                <a:latin typeface="Montserrat" panose="00000500000000000000" pitchFamily="2" charset="-18"/>
-              </a:rPr>
-              <a:t>amet</a:t>
-            </a:r>
-            <a:r>
-              <a:rPr lang="hu-HU" sz="1200" dirty="0">
-                <a:latin typeface="Montserrat" panose="00000500000000000000" pitchFamily="2" charset="-18"/>
-              </a:rPr>
-              <a:t> </a:t>
-            </a:r>
-            <a:r>
-              <a:rPr lang="hu-HU" sz="1200" dirty="0" err="1">
-                <a:latin typeface="Montserrat" panose="00000500000000000000" pitchFamily="2" charset="-18"/>
-              </a:rPr>
-              <a:t>sollicitudin</a:t>
-            </a:r>
-            <a:r>
-              <a:rPr lang="hu-HU" sz="1200" dirty="0">
-                <a:latin typeface="Montserrat" panose="00000500000000000000" pitchFamily="2" charset="-18"/>
-              </a:rPr>
-              <a:t> mi </a:t>
-            </a:r>
-            <a:r>
-              <a:rPr lang="hu-HU" sz="1200" dirty="0" err="1">
-                <a:latin typeface="Montserrat" panose="00000500000000000000" pitchFamily="2" charset="-18"/>
-              </a:rPr>
-              <a:t>nibh</a:t>
-            </a:r>
-            <a:r>
-              <a:rPr lang="hu-HU" sz="1200" dirty="0">
-                <a:latin typeface="Montserrat" panose="00000500000000000000" pitchFamily="2" charset="-18"/>
-              </a:rPr>
-              <a:t> non </a:t>
-            </a:r>
-            <a:r>
-              <a:rPr lang="hu-HU" sz="1200" dirty="0" err="1">
-                <a:latin typeface="Montserrat" panose="00000500000000000000" pitchFamily="2" charset="-18"/>
-              </a:rPr>
-              <a:t>nisi</a:t>
-            </a:r>
-            <a:r>
-              <a:rPr lang="hu-HU" sz="1200" dirty="0">
-                <a:latin typeface="Montserrat" panose="00000500000000000000" pitchFamily="2" charset="-18"/>
-              </a:rPr>
-              <a:t>. Nullam dictum ante </a:t>
-            </a:r>
-            <a:r>
-              <a:rPr lang="hu-HU" sz="1200" dirty="0" err="1">
-                <a:latin typeface="Montserrat" panose="00000500000000000000" pitchFamily="2" charset="-18"/>
-              </a:rPr>
-              <a:t>sit</a:t>
-            </a:r>
-            <a:r>
-              <a:rPr lang="hu-HU" sz="1200" dirty="0">
-                <a:latin typeface="Montserrat" panose="00000500000000000000" pitchFamily="2" charset="-18"/>
-              </a:rPr>
-              <a:t> </a:t>
-            </a:r>
-            <a:r>
-              <a:rPr lang="hu-HU" sz="1200" dirty="0" err="1">
-                <a:latin typeface="Montserrat" panose="00000500000000000000" pitchFamily="2" charset="-18"/>
-              </a:rPr>
-              <a:t>amet</a:t>
-            </a:r>
-            <a:r>
-              <a:rPr lang="hu-HU" sz="1200" dirty="0">
-                <a:latin typeface="Montserrat" panose="00000500000000000000" pitchFamily="2" charset="-18"/>
-              </a:rPr>
-              <a:t> mi </a:t>
-            </a:r>
-            <a:r>
-              <a:rPr lang="hu-HU" sz="1200" dirty="0" err="1">
-                <a:latin typeface="Montserrat" panose="00000500000000000000" pitchFamily="2" charset="-18"/>
-              </a:rPr>
-              <a:t>aliquam</a:t>
-            </a:r>
-            <a:r>
-              <a:rPr lang="hu-HU" sz="1200" dirty="0">
-                <a:latin typeface="Montserrat" panose="00000500000000000000" pitchFamily="2" charset="-18"/>
-              </a:rPr>
-              <a:t>, in </a:t>
-            </a:r>
-            <a:r>
-              <a:rPr lang="hu-HU" sz="1200" dirty="0" err="1">
-                <a:latin typeface="Montserrat" panose="00000500000000000000" pitchFamily="2" charset="-18"/>
-              </a:rPr>
-              <a:t>gravida</a:t>
-            </a:r>
-            <a:r>
-              <a:rPr lang="hu-HU" sz="1200" dirty="0">
-                <a:latin typeface="Montserrat" panose="00000500000000000000" pitchFamily="2" charset="-18"/>
-              </a:rPr>
-              <a:t> </a:t>
-            </a:r>
-            <a:r>
-              <a:rPr lang="hu-HU" sz="1200" dirty="0" err="1">
-                <a:latin typeface="Montserrat" panose="00000500000000000000" pitchFamily="2" charset="-18"/>
-              </a:rPr>
-              <a:t>ipsum</a:t>
-            </a:r>
-            <a:r>
-              <a:rPr lang="hu-HU" sz="1200" dirty="0">
-                <a:latin typeface="Montserrat" panose="00000500000000000000" pitchFamily="2" charset="-18"/>
-              </a:rPr>
-              <a:t> </a:t>
-            </a:r>
-            <a:r>
-              <a:rPr lang="hu-HU" sz="1200" dirty="0" err="1">
-                <a:latin typeface="Montserrat" panose="00000500000000000000" pitchFamily="2" charset="-18"/>
-              </a:rPr>
-              <a:t>consequat</a:t>
-            </a:r>
-            <a:r>
-              <a:rPr lang="hu-HU" sz="1200" dirty="0">
-                <a:latin typeface="Montserrat" panose="00000500000000000000" pitchFamily="2" charset="-18"/>
-              </a:rPr>
-              <a:t>. </a:t>
-            </a:r>
-            <a:r>
-              <a:rPr lang="hu-HU" sz="1200" dirty="0" err="1">
-                <a:latin typeface="Montserrat" panose="00000500000000000000" pitchFamily="2" charset="-18"/>
-              </a:rPr>
-              <a:t>Morbi</a:t>
-            </a:r>
-            <a:r>
-              <a:rPr lang="hu-HU" sz="1200" dirty="0">
-                <a:latin typeface="Montserrat" panose="00000500000000000000" pitchFamily="2" charset="-18"/>
-              </a:rPr>
-              <a:t> </a:t>
-            </a:r>
-            <a:r>
-              <a:rPr lang="hu-HU" sz="1200" dirty="0" err="1">
-                <a:latin typeface="Montserrat" panose="00000500000000000000" pitchFamily="2" charset="-18"/>
-              </a:rPr>
-              <a:t>sodales</a:t>
-            </a:r>
-            <a:r>
-              <a:rPr lang="hu-HU" sz="1200" dirty="0">
-                <a:latin typeface="Montserrat" panose="00000500000000000000" pitchFamily="2" charset="-18"/>
-              </a:rPr>
-              <a:t> </a:t>
-            </a:r>
-            <a:r>
-              <a:rPr lang="hu-HU" sz="1200" dirty="0" err="1">
-                <a:latin typeface="Montserrat" panose="00000500000000000000" pitchFamily="2" charset="-18"/>
-              </a:rPr>
-              <a:t>luctus</a:t>
-            </a:r>
-            <a:r>
-              <a:rPr lang="hu-HU" sz="1200" dirty="0">
-                <a:latin typeface="Montserrat" panose="00000500000000000000" pitchFamily="2" charset="-18"/>
-              </a:rPr>
-              <a:t> </a:t>
-            </a:r>
-            <a:r>
-              <a:rPr lang="hu-HU" sz="1200" dirty="0" err="1">
-                <a:latin typeface="Montserrat" panose="00000500000000000000" pitchFamily="2" charset="-18"/>
-              </a:rPr>
-              <a:t>ligula</a:t>
-            </a:r>
-            <a:r>
-              <a:rPr lang="hu-HU" sz="1200" dirty="0">
-                <a:latin typeface="Montserrat" panose="00000500000000000000" pitchFamily="2" charset="-18"/>
-              </a:rPr>
-              <a:t> non </a:t>
-            </a:r>
-            <a:r>
-              <a:rPr lang="hu-HU" sz="1200" dirty="0" err="1">
-                <a:latin typeface="Montserrat" panose="00000500000000000000" pitchFamily="2" charset="-18"/>
-              </a:rPr>
-              <a:t>bibendum</a:t>
-            </a:r>
-            <a:r>
-              <a:rPr lang="hu-HU" sz="1200" dirty="0">
-                <a:latin typeface="Montserrat" panose="00000500000000000000" pitchFamily="2" charset="-18"/>
-              </a:rPr>
-              <a:t>. </a:t>
-            </a:r>
-            <a:r>
-              <a:rPr lang="hu-HU" sz="1200" dirty="0" err="1">
-                <a:latin typeface="Montserrat" panose="00000500000000000000" pitchFamily="2" charset="-18"/>
-              </a:rPr>
-              <a:t>Curabitur</a:t>
-            </a:r>
-            <a:r>
-              <a:rPr lang="hu-HU" sz="1200" dirty="0">
-                <a:latin typeface="Montserrat" panose="00000500000000000000" pitchFamily="2" charset="-18"/>
-              </a:rPr>
-              <a:t> </a:t>
-            </a:r>
-            <a:r>
-              <a:rPr lang="hu-HU" sz="1200" dirty="0" err="1">
-                <a:latin typeface="Montserrat" panose="00000500000000000000" pitchFamily="2" charset="-18"/>
-              </a:rPr>
-              <a:t>laoreet</a:t>
-            </a:r>
-            <a:r>
-              <a:rPr lang="hu-HU" sz="1200" dirty="0">
-                <a:latin typeface="Montserrat" panose="00000500000000000000" pitchFamily="2" charset="-18"/>
-              </a:rPr>
-              <a:t> </a:t>
-            </a:r>
-            <a:r>
-              <a:rPr lang="hu-HU" sz="1200" dirty="0" err="1">
-                <a:latin typeface="Montserrat" panose="00000500000000000000" pitchFamily="2" charset="-18"/>
-              </a:rPr>
-              <a:t>placerat</a:t>
-            </a:r>
-            <a:r>
-              <a:rPr lang="hu-HU" sz="1200" dirty="0">
-                <a:latin typeface="Montserrat" panose="00000500000000000000" pitchFamily="2" charset="-18"/>
-              </a:rPr>
-              <a:t> </a:t>
-            </a:r>
-            <a:r>
-              <a:rPr lang="hu-HU" sz="1200" dirty="0" err="1">
-                <a:latin typeface="Montserrat" panose="00000500000000000000" pitchFamily="2" charset="-18"/>
-              </a:rPr>
-              <a:t>augue</a:t>
-            </a:r>
-            <a:r>
-              <a:rPr lang="hu-HU" sz="1200" dirty="0">
-                <a:latin typeface="Montserrat" panose="00000500000000000000" pitchFamily="2" charset="-18"/>
-              </a:rPr>
-              <a:t>, a </a:t>
-            </a:r>
-            <a:r>
-              <a:rPr lang="hu-HU" sz="1200" dirty="0" err="1">
-                <a:latin typeface="Montserrat" panose="00000500000000000000" pitchFamily="2" charset="-18"/>
-              </a:rPr>
-              <a:t>feugiat</a:t>
-            </a:r>
-            <a:r>
-              <a:rPr lang="hu-HU" sz="1200" dirty="0">
-                <a:latin typeface="Montserrat" panose="00000500000000000000" pitchFamily="2" charset="-18"/>
-              </a:rPr>
-              <a:t> </a:t>
-            </a:r>
-            <a:r>
-              <a:rPr lang="hu-HU" sz="1200" dirty="0" err="1">
-                <a:latin typeface="Montserrat" panose="00000500000000000000" pitchFamily="2" charset="-18"/>
-              </a:rPr>
-              <a:t>ipsum</a:t>
-            </a:r>
-            <a:r>
-              <a:rPr lang="hu-HU" sz="1200" dirty="0">
-                <a:latin typeface="Montserrat" panose="00000500000000000000" pitchFamily="2" charset="-18"/>
-              </a:rPr>
-              <a:t> </a:t>
-            </a:r>
-            <a:r>
-              <a:rPr lang="hu-HU" sz="1200" dirty="0" err="1">
-                <a:latin typeface="Montserrat" panose="00000500000000000000" pitchFamily="2" charset="-18"/>
-              </a:rPr>
-              <a:t>consequat</a:t>
-            </a:r>
-            <a:r>
-              <a:rPr lang="hu-HU" sz="1200" dirty="0">
-                <a:latin typeface="Montserrat" panose="00000500000000000000" pitchFamily="2" charset="-18"/>
-              </a:rPr>
-              <a:t> </a:t>
-            </a:r>
-            <a:r>
-              <a:rPr lang="hu-HU" sz="1200" dirty="0" err="1">
-                <a:latin typeface="Montserrat" panose="00000500000000000000" pitchFamily="2" charset="-18"/>
-              </a:rPr>
-              <a:t>pulvinar</a:t>
-            </a:r>
-            <a:r>
-              <a:rPr lang="hu-HU" sz="1200" dirty="0">
-                <a:latin typeface="Montserrat" panose="00000500000000000000" pitchFamily="2" charset="-18"/>
-              </a:rPr>
-              <a:t>. </a:t>
-            </a:r>
-            <a:r>
-              <a:rPr lang="hu-HU" sz="1200" dirty="0" err="1">
-                <a:latin typeface="Montserrat" panose="00000500000000000000" pitchFamily="2" charset="-18"/>
-              </a:rPr>
-              <a:t>Etiam</a:t>
-            </a:r>
-            <a:r>
-              <a:rPr lang="hu-HU" sz="1200" dirty="0">
-                <a:latin typeface="Montserrat" panose="00000500000000000000" pitchFamily="2" charset="-18"/>
-              </a:rPr>
-              <a:t> </a:t>
-            </a:r>
-            <a:r>
-              <a:rPr lang="hu-HU" sz="1200" dirty="0" err="1">
-                <a:latin typeface="Montserrat" panose="00000500000000000000" pitchFamily="2" charset="-18"/>
-              </a:rPr>
-              <a:t>efficitur</a:t>
-            </a:r>
-            <a:r>
-              <a:rPr lang="hu-HU" sz="1200" dirty="0">
-                <a:latin typeface="Montserrat" panose="00000500000000000000" pitchFamily="2" charset="-18"/>
-              </a:rPr>
-              <a:t> </a:t>
-            </a:r>
-            <a:r>
-              <a:rPr lang="hu-HU" sz="1200" dirty="0" err="1">
-                <a:latin typeface="Montserrat" panose="00000500000000000000" pitchFamily="2" charset="-18"/>
-              </a:rPr>
-              <a:t>nunc</a:t>
-            </a:r>
-            <a:r>
-              <a:rPr lang="hu-HU" sz="1200" dirty="0">
-                <a:latin typeface="Montserrat" panose="00000500000000000000" pitchFamily="2" charset="-18"/>
-              </a:rPr>
-              <a:t> vel </a:t>
-            </a:r>
-            <a:r>
-              <a:rPr lang="hu-HU" sz="1200" dirty="0" err="1">
-                <a:latin typeface="Montserrat" panose="00000500000000000000" pitchFamily="2" charset="-18"/>
-              </a:rPr>
-              <a:t>dui</a:t>
-            </a:r>
-            <a:r>
-              <a:rPr lang="hu-HU" sz="1200" dirty="0">
-                <a:latin typeface="Montserrat" panose="00000500000000000000" pitchFamily="2" charset="-18"/>
-              </a:rPr>
-              <a:t> </a:t>
-            </a:r>
-            <a:r>
-              <a:rPr lang="hu-HU" sz="1200" dirty="0" err="1">
-                <a:latin typeface="Montserrat" panose="00000500000000000000" pitchFamily="2" charset="-18"/>
-              </a:rPr>
-              <a:t>porttitor</a:t>
-            </a:r>
-            <a:r>
-              <a:rPr lang="hu-HU" sz="1200" dirty="0">
-                <a:latin typeface="Montserrat" panose="00000500000000000000" pitchFamily="2" charset="-18"/>
-              </a:rPr>
-              <a:t>, </a:t>
-            </a:r>
-            <a:r>
-              <a:rPr lang="hu-HU" sz="1200" dirty="0" err="1">
-                <a:latin typeface="Montserrat" panose="00000500000000000000" pitchFamily="2" charset="-18"/>
-              </a:rPr>
-              <a:t>ac</a:t>
-            </a:r>
-            <a:r>
-              <a:rPr lang="hu-HU" sz="1200" dirty="0">
-                <a:latin typeface="Montserrat" panose="00000500000000000000" pitchFamily="2" charset="-18"/>
-              </a:rPr>
-              <a:t> </a:t>
-            </a:r>
-            <a:r>
-              <a:rPr lang="hu-HU" sz="1200" dirty="0" err="1">
-                <a:latin typeface="Montserrat" panose="00000500000000000000" pitchFamily="2" charset="-18"/>
-              </a:rPr>
-              <a:t>lacinia</a:t>
-            </a:r>
-            <a:r>
-              <a:rPr lang="hu-HU" sz="1200" dirty="0">
-                <a:latin typeface="Montserrat" panose="00000500000000000000" pitchFamily="2" charset="-18"/>
-              </a:rPr>
-              <a:t> </a:t>
-            </a:r>
-            <a:r>
-              <a:rPr lang="hu-HU" sz="1200" dirty="0" err="1">
-                <a:latin typeface="Montserrat" panose="00000500000000000000" pitchFamily="2" charset="-18"/>
-              </a:rPr>
-              <a:t>velit</a:t>
-            </a:r>
-            <a:r>
-              <a:rPr lang="hu-HU" sz="1200" dirty="0">
-                <a:latin typeface="Montserrat" panose="00000500000000000000" pitchFamily="2" charset="-18"/>
-              </a:rPr>
-              <a:t> </a:t>
-            </a:r>
-            <a:r>
-              <a:rPr lang="hu-HU" sz="1200" dirty="0" err="1">
-                <a:latin typeface="Montserrat" panose="00000500000000000000" pitchFamily="2" charset="-18"/>
-              </a:rPr>
-              <a:t>volutpat</a:t>
-            </a:r>
-            <a:r>
-              <a:rPr lang="hu-HU" sz="1200" dirty="0">
-                <a:latin typeface="Montserrat" panose="00000500000000000000" pitchFamily="2" charset="-18"/>
-              </a:rPr>
-              <a:t>. Nullam </a:t>
-            </a:r>
-            <a:r>
-              <a:rPr lang="hu-HU" sz="1200" dirty="0" err="1">
-                <a:latin typeface="Montserrat" panose="00000500000000000000" pitchFamily="2" charset="-18"/>
-              </a:rPr>
-              <a:t>sit</a:t>
-            </a:r>
-            <a:r>
-              <a:rPr lang="hu-HU" sz="1200" dirty="0">
-                <a:latin typeface="Montserrat" panose="00000500000000000000" pitchFamily="2" charset="-18"/>
-              </a:rPr>
-              <a:t> </a:t>
-            </a:r>
-            <a:r>
-              <a:rPr lang="hu-HU" sz="1200" dirty="0" err="1">
-                <a:latin typeface="Montserrat" panose="00000500000000000000" pitchFamily="2" charset="-18"/>
-              </a:rPr>
-              <a:t>amet</a:t>
-            </a:r>
-            <a:r>
-              <a:rPr lang="hu-HU" sz="1200" dirty="0">
-                <a:latin typeface="Montserrat" panose="00000500000000000000" pitchFamily="2" charset="-18"/>
-              </a:rPr>
-              <a:t> </a:t>
-            </a:r>
-            <a:r>
-              <a:rPr lang="hu-HU" sz="1200" dirty="0" err="1">
-                <a:latin typeface="Montserrat" panose="00000500000000000000" pitchFamily="2" charset="-18"/>
-              </a:rPr>
-              <a:t>iaculis</a:t>
-            </a:r>
-            <a:r>
-              <a:rPr lang="hu-HU" sz="1200" dirty="0">
-                <a:latin typeface="Montserrat" panose="00000500000000000000" pitchFamily="2" charset="-18"/>
-              </a:rPr>
-              <a:t> </a:t>
-            </a:r>
-            <a:r>
-              <a:rPr lang="hu-HU" sz="1200" dirty="0" err="1">
-                <a:latin typeface="Montserrat" panose="00000500000000000000" pitchFamily="2" charset="-18"/>
-              </a:rPr>
-              <a:t>nunc</a:t>
-            </a:r>
-            <a:r>
-              <a:rPr lang="hu-HU" sz="1200" dirty="0">
-                <a:latin typeface="Montserrat" panose="00000500000000000000" pitchFamily="2" charset="-18"/>
-              </a:rPr>
-              <a:t>. </a:t>
-            </a:r>
-            <a:r>
-              <a:rPr lang="hu-HU" sz="1200" dirty="0" err="1">
-                <a:latin typeface="Montserrat" panose="00000500000000000000" pitchFamily="2" charset="-18"/>
-              </a:rPr>
-              <a:t>Aenean</a:t>
-            </a:r>
-            <a:r>
-              <a:rPr lang="hu-HU" sz="1200" dirty="0">
-                <a:latin typeface="Montserrat" panose="00000500000000000000" pitchFamily="2" charset="-18"/>
-              </a:rPr>
-              <a:t> vitae </a:t>
-            </a:r>
-            <a:r>
-              <a:rPr lang="hu-HU" sz="1200" dirty="0" err="1">
-                <a:latin typeface="Montserrat" panose="00000500000000000000" pitchFamily="2" charset="-18"/>
-              </a:rPr>
-              <a:t>lorem</a:t>
-            </a:r>
-            <a:r>
-              <a:rPr lang="hu-HU" sz="1200" dirty="0">
-                <a:latin typeface="Montserrat" panose="00000500000000000000" pitchFamily="2" charset="-18"/>
-              </a:rPr>
-              <a:t> </a:t>
-            </a:r>
-            <a:r>
-              <a:rPr lang="hu-HU" sz="1200" dirty="0" err="1">
-                <a:latin typeface="Montserrat" panose="00000500000000000000" pitchFamily="2" charset="-18"/>
-              </a:rPr>
-              <a:t>pellentesque</a:t>
-            </a:r>
-            <a:r>
-              <a:rPr lang="hu-HU" sz="1200" dirty="0">
-                <a:latin typeface="Montserrat" panose="00000500000000000000" pitchFamily="2" charset="-18"/>
-              </a:rPr>
-              <a:t>, </a:t>
-            </a:r>
-            <a:r>
-              <a:rPr lang="hu-HU" sz="1200" dirty="0" err="1">
-                <a:latin typeface="Montserrat" panose="00000500000000000000" pitchFamily="2" charset="-18"/>
-              </a:rPr>
-              <a:t>egestas</a:t>
-            </a:r>
-            <a:r>
-              <a:rPr lang="hu-HU" sz="1200" dirty="0">
-                <a:latin typeface="Montserrat" panose="00000500000000000000" pitchFamily="2" charset="-18"/>
-              </a:rPr>
-              <a:t> mi </a:t>
-            </a:r>
-            <a:r>
-              <a:rPr lang="hu-HU" sz="1200" dirty="0" err="1">
-                <a:latin typeface="Montserrat" panose="00000500000000000000" pitchFamily="2" charset="-18"/>
-              </a:rPr>
-              <a:t>at</a:t>
-            </a:r>
-            <a:r>
-              <a:rPr lang="hu-HU" sz="1200" dirty="0">
-                <a:latin typeface="Montserrat" panose="00000500000000000000" pitchFamily="2" charset="-18"/>
-              </a:rPr>
-              <a:t>, </a:t>
-            </a:r>
-            <a:r>
-              <a:rPr lang="hu-HU" sz="1200" dirty="0" err="1">
-                <a:latin typeface="Montserrat" panose="00000500000000000000" pitchFamily="2" charset="-18"/>
-              </a:rPr>
-              <a:t>egestas</a:t>
-            </a:r>
-            <a:r>
-              <a:rPr lang="hu-HU" sz="1200" dirty="0">
-                <a:latin typeface="Montserrat" panose="00000500000000000000" pitchFamily="2" charset="-18"/>
-              </a:rPr>
-              <a:t> </a:t>
-            </a:r>
-            <a:r>
-              <a:rPr lang="hu-HU" sz="1200" dirty="0" err="1">
-                <a:latin typeface="Montserrat" panose="00000500000000000000" pitchFamily="2" charset="-18"/>
-              </a:rPr>
-              <a:t>augue</a:t>
-            </a:r>
-            <a:r>
-              <a:rPr lang="hu-HU" sz="1200" dirty="0">
-                <a:latin typeface="Montserrat" panose="00000500000000000000" pitchFamily="2" charset="-18"/>
-              </a:rPr>
-              <a:t>.</a:t>
-            </a:r>
-          </a:p>
-          <a:p>
-            <a:pPr marL="0" indent="0" algn="just">
-              <a:buNone/>
-            </a:pPr>
+              <a:t> in the first half of the twentieth century. In 2018 Montserrat Font became the official font for documentation, presentations and publicity for the Government of Mexico and since 2021 has been Puerto Rico’s official typeface for body text and its agency’s logos.</a:t>
+            </a:r>
             <a:endParaRPr lang="hu-HU" sz="1200" dirty="0">
               <a:solidFill>
                 <a:srgbClr val="00FFFF"/>
               </a:solidFill>
-              <a:latin typeface="Montserrat" panose="00000500000000000000" pitchFamily="2" charset="-18"/>
+              <a:latin typeface="Monsterrrat"/>
             </a:endParaRPr>
           </a:p>
           <a:p>
@@ -5708,7 +4629,7 @@
                 </a:solidFill>
                 <a:latin typeface="Montserrat" panose="00000500000000000000" pitchFamily="2" charset="-18"/>
               </a:rPr>
-              <a:t>https://www.hivatkozasminta.hu</a:t>
+              <a:t>https://fontandswatch.com.au/resources/montserrat-font/</a:t>
             </a:r>
           </a:p>
         </p:txBody>
@@ -8495,7 +7416,7 @@
                                     </p:set>
                                     <p:anim calcmode="lin" valueType="num">
                                       <p:cBhvr additive="base">
-                                        <p:cTn id="7" dur="750" fill="hold"/>
+                                        <p:cTn id="7" dur="500" fill="hold"/>
                                         <p:tgtEl>
                                           <p:spTgt spid="95"/>
                                         </p:tgtEl>
@@ -8518,7 +7439,7 @@
                                     </p:anim>
                                     <p:anim calcmode="lin" valueType="num">
                                       <p:cBhvr additive="base">
-                                        <p:cTn id="8" dur="750" fill="hold"/>
+                                        <p:cTn id="8" dur="500" fill="hold"/>
                                         <p:tgtEl>
                                           <p:spTgt spid="95"/>
                                         </p:tgtEl>
@@ -8568,7 +7489,7 @@
                                     </p:set>
                                     <p:anim calcmode="lin" valueType="num">
                                       <p:cBhvr additive="base">
-                                        <p:cTn id="11" dur="750" fill="hold"/>
+                                        <p:cTn id="11" dur="500" fill="hold"/>
                                         <p:tgtEl>
                                           <p:spTgt spid="96"/>
                                         </p:tgtEl>
@@ -8591,7 +7512,7 @@
                                     </p:anim>
                                     <p:anim calcmode="lin" valueType="num">
                                       <p:cBhvr additive="base">
-                                        <p:cTn id="12" dur="750" fill="hold"/>
+                                        <p:cTn id="12" dur="500" fill="hold"/>
                                         <p:tgtEl>
                                           <p:spTgt spid="96"/>
                                         </p:tgtEl>
@@ -8803,7 +7724,7 @@
                                     </p:set>
                                     <p:anim calcmode="lin" valueType="num">
                                       <p:cBhvr additive="base">
-                                        <p:cTn id="25" dur="750" fill="hold"/>
+                                        <p:cTn id="25" dur="500" fill="hold"/>
                                         <p:tgtEl>
                                           <p:spTgt spid="99"/>
                                         </p:tgtEl>
@@ -8826,7 +7747,7 @@
                                     </p:anim>
                                     <p:anim calcmode="lin" valueType="num">
                                       <p:cBhvr additive="base">
-                                        <p:cTn id="26" dur="750" fill="hold"/>
+                                        <p:cTn id="26" dur="500" fill="hold"/>
                                         <p:tgtEl>
                                           <p:spTgt spid="99"/>
                                         </p:tgtEl>
@@ -8876,7 +7797,7 @@
                                     </p:set>
                                     <p:anim calcmode="lin" valueType="num">
                                       <p:cBhvr additive="base">
-                                        <p:cTn id="29" dur="750" fill="hold"/>
+                                        <p:cTn id="29" dur="500" fill="hold"/>
                                         <p:tgtEl>
                                           <p:spTgt spid="93"/>
                                         </p:tgtEl>
@@ -8899,7 +7820,7 @@
                                     </p:anim>
                                     <p:anim calcmode="lin" valueType="num">
                                       <p:cBhvr additive="base">
-                                        <p:cTn id="30" dur="750" fill="hold"/>
+                                        <p:cTn id="30" dur="500" fill="hold"/>
                                         <p:tgtEl>
                                           <p:spTgt spid="93"/>
                                         </p:tgtEl>
@@ -8984,7 +7905,7 @@
                                     </p:set>
                                     <p:anim calcmode="lin" valueType="num">
                                       <p:cBhvr additive="base">
-                                        <p:cTn id="36" dur="750" fill="hold"/>
+                                        <p:cTn id="36" dur="500" fill="hold"/>
                                         <p:tgtEl>
                                           <p:spTgt spid="92"/>
                                         </p:tgtEl>
@@ -9007,7 +7928,7 @@
                                     </p:anim>
                                     <p:anim calcmode="lin" valueType="num">
                                       <p:cBhvr additive="base">
-                                        <p:cTn id="37" dur="750" fill="hold"/>
+                                        <p:cTn id="37" dur="500" fill="hold"/>
                                         <p:tgtEl>
                                           <p:spTgt spid="92"/>
                                         </p:tgtEl>
@@ -9057,7 +7978,7 @@
                                     </p:set>
                                     <p:anim calcmode="lin" valueType="num">
                                       <p:cBhvr additive="base">
-                                        <p:cTn id="40" dur="750" fill="hold"/>
+                                        <p:cTn id="40" dur="500" fill="hold"/>
                                         <p:tgtEl>
                                           <p:spTgt spid="91"/>
                                         </p:tgtEl>
@@ -9080,7 +8001,7 @@
                                     </p:anim>
                                     <p:anim calcmode="lin" valueType="num">
                                       <p:cBhvr additive="base">
-                                        <p:cTn id="41" dur="750" fill="hold"/>
+                                        <p:cTn id="41" dur="500" fill="hold"/>
                                         <p:tgtEl>
                                           <p:spTgt spid="91"/>
                                         </p:tgtEl>
@@ -9110,7 +8031,7 @@
                         <p:par>
                           <p:cTn id="42" fill="hold">
                             <p:stCondLst>
-                              <p:cond delay="2400"/>
+                              <p:cond delay="2150"/>
                             </p:stCondLst>
                             <p:childTnLst>
                               <p:par>
@@ -9139,7 +8060,7 @@
                                     </p:set>
                                     <p:anim calcmode="lin" valueType="num">
                                       <p:cBhvr additive="base">
-                                        <p:cTn id="45" dur="750" fill="hold"/>
+                                        <p:cTn id="45" dur="500" fill="hold"/>
                                         <p:tgtEl>
                                           <p:spTgt spid="89"/>
                                         </p:tgtEl>
@@ -9162,7 +8083,7 @@
                                     </p:anim>
                                     <p:anim calcmode="lin" valueType="num">
                                       <p:cBhvr additive="base">
-                                        <p:cTn id="46" dur="750" fill="hold"/>
+                                        <p:cTn id="46" dur="500" fill="hold"/>
                                         <p:tgtEl>
                                           <p:spTgt spid="89"/>
                                         </p:tgtEl>
@@ -9247,7 +8168,7 @@
                                     </p:set>
                                     <p:anim calcmode="lin" valueType="num">
                                       <p:cBhvr additive="base">
-                                        <p:cTn id="52" dur="750" fill="hold"/>
+                                        <p:cTn id="52" dur="500" fill="hold"/>
                                         <p:tgtEl>
                                           <p:spTgt spid="28"/>
                                         </p:tgtEl>
@@ -9270,7 +8191,7 @@
                                     </p:anim>
                                     <p:anim calcmode="lin" valueType="num">
                                       <p:cBhvr additive="base">
-                                        <p:cTn id="53" dur="750" fill="hold"/>
+                                        <p:cTn id="53" dur="500" fill="hold"/>
                                         <p:tgtEl>
                                           <p:spTgt spid="28"/>
                                         </p:tgtEl>
@@ -9320,7 +8241,7 @@
                                     </p:set>
                                     <p:anim calcmode="lin" valueType="num">
                                       <p:cBhvr additive="base">
-                                        <p:cTn id="56" dur="750" fill="hold"/>
+                                        <p:cTn id="56" dur="500" fill="hold"/>
                                         <p:tgtEl>
                                           <p:spTgt spid="27"/>
                                         </p:tgtEl>
@@ -9343,7 +8264,7 @@
                                     </p:anim>
                                     <p:anim calcmode="lin" valueType="num">
                                       <p:cBhvr additive="base">
-                                        <p:cTn id="57" dur="750" fill="hold"/>
+                                        <p:cTn id="57" dur="500" fill="hold"/>
                                         <p:tgtEl>
                                           <p:spTgt spid="27"/>
                                         </p:tgtEl>
@@ -9373,7 +8294,7 @@
                         <p:par>
                           <p:cTn id="58" fill="hold">
                             <p:stCondLst>
-                              <p:cond delay="3800"/>
+                              <p:cond delay="3300"/>
                             </p:stCondLst>
                             <p:childTnLst>
                               <p:par>
@@ -9402,7 +8323,7 @@
                                     </p:set>
                                     <p:anim calcmode="lin" valueType="num">
                                       <p:cBhvr additive="base">
-                                        <p:cTn id="61" dur="750" fill="hold"/>
+                                        <p:cTn id="61" dur="500" fill="hold"/>
                                         <p:tgtEl>
                                           <p:spTgt spid="81"/>
                                         </p:tgtEl>
@@ -9425,7 +8346,7 @@
                                     </p:anim>
                                     <p:anim calcmode="lin" valueType="num">
                                       <p:cBhvr additive="base">
-                                        <p:cTn id="62" dur="750" fill="hold"/>
+                                        <p:cTn id="62" dur="500" fill="hold"/>
                                         <p:tgtEl>
                                           <p:spTgt spid="81"/>
                                         </p:tgtEl>
@@ -9510,7 +8431,7 @@
                                     </p:set>
                                     <p:anim calcmode="lin" valueType="num">
                                       <p:cBhvr additive="base">
-                                        <p:cTn id="68" dur="750" fill="hold"/>
+                                        <p:cTn id="68" dur="500" fill="hold"/>
                                         <p:tgtEl>
                                           <p:spTgt spid="40"/>
                                         </p:tgtEl>
@@ -9533,7 +8454,7 @@
                                     </p:anim>
                                     <p:anim calcmode="lin" valueType="num">
                                       <p:cBhvr additive="base">
-                                        <p:cTn id="69" dur="750" fill="hold"/>
+                                        <p:cTn id="69" dur="500" fill="hold"/>
                                         <p:tgtEl>
                                           <p:spTgt spid="40"/>
                                         </p:tgtEl>
@@ -9583,7 +8504,7 @@
                                     </p:set>
                                     <p:anim calcmode="lin" valueType="num">
                                       <p:cBhvr additive="base">
-                                        <p:cTn id="72" dur="750" fill="hold"/>
+                                        <p:cTn id="72" dur="500" fill="hold"/>
                                         <p:tgtEl>
                                           <p:spTgt spid="39"/>
                                         </p:tgtEl>
@@ -9606,7 +8527,7 @@
                                     </p:anim>
                                     <p:anim calcmode="lin" valueType="num">
                                       <p:cBhvr additive="base">
-                                        <p:cTn id="73" dur="750" fill="hold"/>
+                                        <p:cTn id="73" dur="500" fill="hold"/>
                                         <p:tgtEl>
                                           <p:spTgt spid="39"/>
                                         </p:tgtEl>
@@ -9636,7 +8557,7 @@
                         <p:par>
                           <p:cTn id="74" fill="hold">
                             <p:stCondLst>
-                              <p:cond delay="5200"/>
+                              <p:cond delay="4450"/>
                             </p:stCondLst>
                             <p:childTnLst>
                               <p:par>
@@ -9665,7 +8586,7 @@
                                     </p:set>
                                     <p:anim calcmode="lin" valueType="num">
                                       <p:cBhvr additive="base">
-                                        <p:cTn id="77" dur="750" fill="hold"/>
+                                        <p:cTn id="77" dur="500" fill="hold"/>
                                         <p:tgtEl>
                                           <p:spTgt spid="85"/>
                                         </p:tgtEl>
@@ -9688,7 +8609,7 @@
                                     </p:anim>
                                     <p:anim calcmode="lin" valueType="num">
                                       <p:cBhvr additive="base">
-                                        <p:cTn id="78" dur="750" fill="hold"/>
+                                        <p:cTn id="78" dur="500" fill="hold"/>
                                         <p:tgtEl>
                                           <p:spTgt spid="85"/>
                                         </p:tgtEl>
@@ -9773,7 +8694,7 @@
                                     </p:set>
                                     <p:anim calcmode="lin" valueType="num">
                                       <p:cBhvr additive="base">
-                                        <p:cTn id="84" dur="750" fill="hold"/>
+                                        <p:cTn id="84" dur="500" fill="hold"/>
                                         <p:tgtEl>
                                           <p:spTgt spid="43"/>
                                         </p:tgtEl>
@@ -9796,7 +8717,7 @@
                                     </p:anim>
                                     <p:anim calcmode="lin" valueType="num">
                                       <p:cBhvr additive="base">
-                                        <p:cTn id="85" dur="750" fill="hold"/>
+                                        <p:cTn id="85" dur="500" fill="hold"/>
                                         <p:tgtEl>
                                           <p:spTgt spid="43"/>
                                         </p:tgtEl>
@@ -9846,7 +8767,7 @@
                                     </p:set>
                                     <p:anim calcmode="lin" valueType="num">
                                       <p:cBhvr additive="base">
-                                        <p:cTn id="88" dur="750" fill="hold"/>
+                                        <p:cTn id="88" dur="500" fill="hold"/>
                                         <p:tgtEl>
                                           <p:spTgt spid="42"/>
                                         </p:tgtEl>
@@ -9869,7 +8790,7 @@
                                     </p:anim>
                                     <p:anim calcmode="lin" valueType="num">
                                       <p:cBhvr additive="base">
-                                        <p:cTn id="89" dur="750" fill="hold"/>
+                                        <p:cTn id="89" dur="500" fill="hold"/>
                                         <p:tgtEl>
                                           <p:spTgt spid="42"/>
                                         </p:tgtEl>
@@ -10002,10 +8923,10 @@
       </p:sp>
       <p:pic>
         <p:nvPicPr>
-          <p:cNvPr id="7" name="Kép 6">
-            <a:extLst>
-              <a:ext uri="{FF2B5EF4-FFF2-40B4-BE49-F238E27FC236}">
-                <a16:creationId xmlns:a16="http://schemas.microsoft.com/office/drawing/2014/main" id="{F4C608AC-6F66-3610-3B61-0811CC976258}"/>
+          <p:cNvPr id="4" name="Kép 3" descr="A képen képernyőkép, sor, Diagram, szöveg látható&#10;&#10;Előfordulhat, hogy az AI által létrehozott tartalom helytelen.">
+            <a:extLst>
+              <a:ext uri="{FF2B5EF4-FFF2-40B4-BE49-F238E27FC236}">
+                <a16:creationId xmlns:a16="http://schemas.microsoft.com/office/drawing/2014/main" id="{D915E45D-55EC-C631-24A3-FF4754CA5887}"/>
               </a:ext>
             </a:extLst>
           </p:cNvPr>
@@ -10015,15 +8936,21 @@
           <p:nvPr/>
         </p:nvPicPr>
         <p:blipFill>
-          <a:blip r:embed="rId2"/>
+          <a:blip r:embed="rId2">
+            <a:extLst>
+              <a:ext uri="{28A0092B-C50C-407E-A947-70E740481C1C}">
+                <a14:useLocalDpi xmlns:a14="http://schemas.microsoft.com/office/drawing/2010/main" val="0"/>
+              </a:ext>
+            </a:extLst>
+          </a:blip>
           <a:stretch>
             <a:fillRect/>
           </a:stretch>
         </p:blipFill>
         <p:spPr>
           <a:xfrm>
-            <a:off x="284408" y="2818561"/>
-            <a:ext cx="11623183" cy="2586038"/>
+            <a:off x="0" y="2743571"/>
+            <a:ext cx="12192000" cy="3416403"/>
           </a:xfrm>
           <a:prstGeom prst="rect">
             <a:avLst/>
@@ -10243,7 +9170,7 @@
         </p:nvSpPr>
         <p:spPr>
           <a:xfrm>
-            <a:off x="5996856" y="1551905"/>
+            <a:off x="5996855" y="1410237"/>
             <a:ext cx="5306095" cy="5306095"/>
           </a:xfrm>
           <a:prstGeom prst="ellipse">
@@ -10346,7 +9273,7 @@
         </p:blipFill>
         <p:spPr>
           <a:xfrm>
-            <a:off x="5220903" y="775952"/>
+            <a:off x="5220902" y="634284"/>
             <a:ext cx="6858000" cy="6858000"/>
           </a:xfrm>
           <a:prstGeom prst="rect">
@@ -12087,6 +11014,184 @@
             <a:endParaRPr lang="hu-HU" b="1" dirty="0">
               <a:latin typeface="Montserrat" panose="00000500000000000000" pitchFamily="2" charset="-18"/>
             </a:endParaRPr>
+          </a:p>
+        </p:txBody>
+      </p:sp>
+      <p:sp>
+        <p:nvSpPr>
+          <p:cNvPr id="3" name="Jobb oldali kapcsos zárójel 2">
+            <a:extLst>
+              <a:ext uri="{FF2B5EF4-FFF2-40B4-BE49-F238E27FC236}">
+                <a16:creationId xmlns:a16="http://schemas.microsoft.com/office/drawing/2014/main" id="{AC372FEC-86BA-927D-A122-F39935F003B5}"/>
+              </a:ext>
+            </a:extLst>
+          </p:cNvPr>
+          <p:cNvSpPr/>
+          <p:nvPr/>
+        </p:nvSpPr>
+        <p:spPr>
+          <a:xfrm rot="5400000">
+            <a:off x="2781352" y="3628546"/>
+            <a:ext cx="618864" cy="3117754"/>
+          </a:xfrm>
+          <a:prstGeom prst="rightBrace">
+            <a:avLst/>
+          </a:prstGeom>
+          <a:solidFill>
+            <a:schemeClr val="bg1"/>
+          </a:solidFill>
+          <a:ln>
+            <a:solidFill>
+              <a:schemeClr val="tx1"/>
+            </a:solidFill>
+          </a:ln>
+        </p:spPr>
+        <p:style>
+          <a:lnRef idx="1">
+            <a:schemeClr val="accent1"/>
+          </a:lnRef>
+          <a:fillRef idx="0">
+            <a:schemeClr val="accent1"/>
+          </a:fillRef>
+          <a:effectRef idx="0">
+            <a:schemeClr val="accent1"/>
+          </a:effectRef>
+          <a:fontRef idx="minor">
+            <a:schemeClr val="tx1"/>
+          </a:fontRef>
+        </p:style>
+        <p:txBody>
+          <a:bodyPr rtlCol="0" anchor="ctr"/>
+          <a:lstStyle/>
+          <a:p>
+            <a:pPr algn="ctr"/>
+            <a:endParaRPr lang="hu-HU" dirty="0"/>
+          </a:p>
+        </p:txBody>
+      </p:sp>
+      <p:sp>
+        <p:nvSpPr>
+          <p:cNvPr id="19" name="Szövegdoboz 18">
+            <a:extLst>
+              <a:ext uri="{FF2B5EF4-FFF2-40B4-BE49-F238E27FC236}">
+                <a16:creationId xmlns:a16="http://schemas.microsoft.com/office/drawing/2014/main" id="{9670664B-5467-1E6B-40E2-2966D641B22A}"/>
+              </a:ext>
+            </a:extLst>
+          </p:cNvPr>
+          <p:cNvSpPr txBox="1"/>
+          <p:nvPr/>
+        </p:nvSpPr>
+        <p:spPr>
+          <a:xfrm>
+            <a:off x="2366347" y="5827690"/>
+            <a:ext cx="1448873" cy="369332"/>
+          </a:xfrm>
+          <a:prstGeom prst="rect">
+            <a:avLst/>
+          </a:prstGeom>
+          <a:noFill/>
+        </p:spPr>
+        <p:txBody>
+          <a:bodyPr wrap="square" rtlCol="0">
+            <a:spAutoFit/>
+          </a:bodyPr>
+          <a:lstStyle/>
+          <a:p>
+            <a:r>
+              <a:rPr lang="hu-HU" b="1" dirty="0">
+                <a:latin typeface="Monsterrat"/>
+              </a:rPr>
+              <a:t>Háttérszínek</a:t>
+            </a:r>
+          </a:p>
+        </p:txBody>
+      </p:sp>
+      <p:sp>
+        <p:nvSpPr>
+          <p:cNvPr id="20" name="Jobb oldali kapcsos zárójel 19">
+            <a:extLst>
+              <a:ext uri="{FF2B5EF4-FFF2-40B4-BE49-F238E27FC236}">
+                <a16:creationId xmlns:a16="http://schemas.microsoft.com/office/drawing/2014/main" id="{9072AD06-BD28-E012-D9C5-AD628759C6AF}"/>
+              </a:ext>
+            </a:extLst>
+          </p:cNvPr>
+          <p:cNvSpPr/>
+          <p:nvPr/>
+        </p:nvSpPr>
+        <p:spPr>
+          <a:xfrm rot="5400000">
+            <a:off x="7744544" y="2365191"/>
+            <a:ext cx="618864" cy="5644463"/>
+          </a:xfrm>
+          <a:prstGeom prst="rightBrace">
+            <a:avLst/>
+          </a:prstGeom>
+          <a:solidFill>
+            <a:schemeClr val="bg1"/>
+          </a:solidFill>
+          <a:ln>
+            <a:solidFill>
+              <a:schemeClr val="tx1"/>
+            </a:solidFill>
+          </a:ln>
+        </p:spPr>
+        <p:style>
+          <a:lnRef idx="1">
+            <a:schemeClr val="accent1"/>
+          </a:lnRef>
+          <a:fillRef idx="0">
+            <a:schemeClr val="accent1"/>
+          </a:fillRef>
+          <a:effectRef idx="0">
+            <a:schemeClr val="accent1"/>
+          </a:effectRef>
+          <a:fontRef idx="minor">
+            <a:schemeClr val="tx1"/>
+          </a:fontRef>
+        </p:style>
+        <p:txBody>
+          <a:bodyPr rtlCol="0" anchor="ctr"/>
+          <a:lstStyle/>
+          <a:p>
+            <a:pPr algn="ctr"/>
+            <a:endParaRPr lang="hu-HU" dirty="0"/>
+          </a:p>
+        </p:txBody>
+      </p:sp>
+      <p:sp>
+        <p:nvSpPr>
+          <p:cNvPr id="21" name="Szövegdoboz 20">
+            <a:extLst>
+              <a:ext uri="{FF2B5EF4-FFF2-40B4-BE49-F238E27FC236}">
+                <a16:creationId xmlns:a16="http://schemas.microsoft.com/office/drawing/2014/main" id="{5DBAC063-BB45-228E-7AA7-555ADBC70352}"/>
+              </a:ext>
+            </a:extLst>
+          </p:cNvPr>
+          <p:cNvSpPr txBox="1"/>
+          <p:nvPr/>
+        </p:nvSpPr>
+        <p:spPr>
+          <a:xfrm>
+            <a:off x="7575608" y="5808372"/>
+            <a:ext cx="1047741" cy="369332"/>
+          </a:xfrm>
+          <a:prstGeom prst="rect">
+            <a:avLst/>
+          </a:prstGeom>
+          <a:noFill/>
+        </p:spPr>
+        <p:txBody>
+          <a:bodyPr wrap="square" rtlCol="0">
+            <a:spAutoFit/>
+          </a:bodyPr>
+          <a:lstStyle/>
+          <a:p>
+            <a:r>
+              <a:rPr lang="hu-HU" b="1" dirty="0">
+                <a:latin typeface="Monsterrat"/>
+              </a:rPr>
+              <a:t>Fő színek</a:t>
+            </a:r>
           </a:p>
         </p:txBody>
       </p:sp>

</xml_diff>